<commit_message>
Redesign trade-offs slide, fold tech stack into architecture slide
Options & trade-offs: widen and highlight the Build (EGPA) column with
a solid navy band and a "path we chose" pill so the winning approach
reads at a glance instead of competing equally with Extend/Buy.

Technology Stack slide is gone - every technology it named is now
folded into the Overall Platform Architecture slide's layer bands,
so architecture and tech stack read as one slide instead of two.

Co-Authored-By: Claude Sonnet 5 <noreply@anthropic.com>
</commit_message>
<xml_diff>
--- a/docs/EGPA-Overview.pptx
+++ b/docs/EGPA-Overview.pptx
@@ -22,10 +22,9 @@
     <p:sldId id="270" r:id="rId16"/>
     <p:sldId id="271" r:id="rId17"/>
     <p:sldId id="272" r:id="rId18"/>
-    <p:sldId id="273" r:id="rId19"/>
   </p:sldIdLst>
   <p:notesMasterIdLst>
-    <p:notesMasterId r:id="rId20"/>
+    <p:notesMasterId r:id="rId19"/>
   </p:notesMasterIdLst>
   <p:sldSz cx="12192000" cy="6858000"/>
   <p:notesSz cx="6858000" cy="12192000"/>
@@ -1247,94 +1246,6 @@
             <a:fld id="{F7021451-1387-4CA6-816F-3879F97B5CBC}" type="slidenum">
               <a:rPr lang="en-US"/>
               <a:t>17</a:t>
-            </a:fld>
-            <a:endParaRPr lang="en-US"/>
-          </a:p>
-        </p:txBody>
-      </p:sp>
-    </p:spTree>
-    <p:extLst>
-      <p:ext uri="{BB962C8B-B14F-4D97-AF65-F5344CB8AC3E}">
-        <p14:creationId xmlns:p14="http://schemas.microsoft.com/office/powerpoint/2010/main" val="1024086991"/>
-      </p:ext>
-    </p:extLst>
-  </p:cSld>
-  <p:clrMapOvr>
-    <a:masterClrMapping/>
-  </p:clrMapOvr>
-</p:notes>
-</file>
-
-<file path=ppt/notesSlides/notesSlide18.xml><?xml version="1.0" encoding="utf-8"?>
-<p:notes xmlns:a="http://schemas.openxmlformats.org/drawingml/2006/main" xmlns:r="http://schemas.openxmlformats.org/officeDocument/2006/relationships" xmlns:p="http://schemas.openxmlformats.org/presentationml/2006/main">
-  <p:cSld>
-    <p:spTree>
-      <p:nvGrpSpPr>
-        <p:cNvPr id="1" name=""/>
-        <p:cNvGrpSpPr/>
-        <p:nvPr/>
-      </p:nvGrpSpPr>
-      <p:grpSpPr>
-        <a:xfrm>
-          <a:off x="0" y="0"/>
-          <a:ext cx="0" cy="0"/>
-          <a:chOff x="0" y="0"/>
-          <a:chExt cx="0" cy="0"/>
-        </a:xfrm>
-      </p:grpSpPr>
-      <p:sp>
-        <p:nvSpPr>
-          <p:cNvPr id="2" name="Slide Image Placeholder 1"/>
-          <p:cNvSpPr>
-            <a:spLocks noGrp="1" noRot="1" noChangeAspect="1"/>
-          </p:cNvSpPr>
-          <p:nvPr>
-            <p:ph type="sldImg"/>
-          </p:nvPr>
-        </p:nvSpPr>
-        <p:spPr/>
-      </p:sp>
-      <p:sp>
-        <p:nvSpPr>
-          <p:cNvPr id="3" name="Notes Placeholder 2"/>
-          <p:cNvSpPr>
-            <a:spLocks noGrp="1"/>
-          </p:cNvSpPr>
-          <p:nvPr>
-            <p:ph type="body" idx="1"/>
-          </p:nvPr>
-        </p:nvSpPr>
-        <p:spPr/>
-        <p:txBody>
-          <a:bodyPr/>
-          <a:lstStyle/>
-          <a:p>
-            <a:r>
-              <a:rPr lang="en-US" dirty="0"/>
-              <a:t/>
-            </a:r>
-            <a:endParaRPr lang="en-US" dirty="0"/>
-          </a:p>
-        </p:txBody>
-      </p:sp>
-      <p:sp>
-        <p:nvSpPr>
-          <p:cNvPr id="4" name="Slide Number Placeholder 3"/>
-          <p:cNvSpPr>
-            <a:spLocks noGrp="1"/>
-          </p:cNvSpPr>
-          <p:nvPr>
-            <p:ph type="sldNum" sz="quarter" idx="10"/>
-          </p:nvPr>
-        </p:nvSpPr>
-        <p:spPr/>
-        <p:txBody>
-          <a:bodyPr/>
-          <a:lstStyle/>
-          <a:p>
-            <a:fld id="{F7021451-1387-4CA6-816F-3879F97B5CBC}" type="slidenum">
-              <a:rPr lang="en-US"/>
-              <a:t>18</a:t>
             </a:fld>
             <a:endParaRPr lang="en-US"/>
           </a:p>
@@ -4095,7 +4006,7 @@
                 <a:ea typeface="Calibri" pitchFamily="34" charset="-122"/>
                 <a:cs typeface="Calibri" pitchFamily="34" charset="-120"/>
               </a:rPr>
-              <a:t>End-to-end view · Every layer real and deployed · No layer simulated for this diagram</a:t>
+              <a:t>End-to-end view · Every layer real, deployed, and named — the full technology stack in one diagram</a:t>
             </a:r>
             <a:endParaRPr lang="en-US" sz="1250" dirty="0"/>
           </a:p>
@@ -4363,7 +4274,7 @@
                 <a:ea typeface="Calibri" pitchFamily="34" charset="-122"/>
                 <a:cs typeface="Calibri" pitchFamily="34" charset="-120"/>
               </a:rPr>
-              <a:t>→ Next.js 16 App Router</a:t>
+              <a:t>→ Next.js 16, React 19, TypeScript, Tailwind v4</a:t>
             </a:r>
             <a:endParaRPr lang="en-US" sz="1100" dirty="0"/>
           </a:p>
@@ -4551,7 +4462,7 @@
                 <a:ea typeface="Calibri" pitchFamily="34" charset="-122"/>
                 <a:cs typeface="Calibri" pitchFamily="34" charset="-120"/>
               </a:rPr>
-              <a:t>→ Self-hosted LiteLLM Proxy</a:t>
+              <a:t>→ Self-hosted LiteLLM Proxy (Cloud Run)</a:t>
             </a:r>
             <a:endParaRPr lang="en-US" sz="1100" dirty="0"/>
           </a:p>
@@ -4591,7 +4502,7 @@
                 <a:ea typeface="Calibri" pitchFamily="34" charset="-122"/>
                 <a:cs typeface="Calibri" pitchFamily="34" charset="-120"/>
               </a:rPr>
-              <a:t>→ LangGraph sub-agent execution</a:t>
+              <a:t>→ LangGraph + LangChain sub-agent execution</a:t>
             </a:r>
             <a:endParaRPr lang="en-US" sz="1100" dirty="0"/>
           </a:p>
@@ -8514,7 +8425,7 @@
                 <a:ea typeface="Calibri" pitchFamily="34" charset="-122"/>
                 <a:cs typeface="Calibri" pitchFamily="34" charset="-120"/>
               </a:rPr>
-              <a:t>TECHNOLOGY STACK</a:t>
+              <a:t>PHASED IMPLEMENTATION</a:t>
             </a:r>
             <a:endParaRPr lang="en-US" sz="1200" dirty="0"/>
           </a:p>
@@ -8529,23 +8440,23 @@
         <p:spPr>
           <a:xfrm>
             <a:off x="548640" y="822960"/>
-            <a:ext cx="10058400" cy="914400"/>
-          </a:xfrm>
-          <a:prstGeom prst="rect">
-            <a:avLst/>
-          </a:prstGeom>
-          <a:noFill/>
-          <a:ln/>
-        </p:spPr>
-        <p:txBody>
-          <a:bodyPr wrap="square" rtlCol="0" anchor="ctr"/>
-          <a:lstStyle/>
-          <a:p>
-            <a:pPr indent="0" marL="0">
-              <a:buNone/>
-            </a:pPr>
-            <a:r>
-              <a:rPr lang="en-US" sz="3000" b="1" dirty="0">
+            <a:ext cx="10972800" cy="548640"/>
+          </a:xfrm>
+          <a:prstGeom prst="rect">
+            <a:avLst/>
+          </a:prstGeom>
+          <a:noFill/>
+          <a:ln/>
+        </p:spPr>
+        <p:txBody>
+          <a:bodyPr wrap="square" rtlCol="0" anchor="ctr"/>
+          <a:lstStyle/>
+          <a:p>
+            <a:pPr indent="0" marL="0">
+              <a:buNone/>
+            </a:pPr>
+            <a:r>
+              <a:rPr lang="en-US" sz="2400" b="1" dirty="0">
                 <a:solidFill>
                   <a:srgbClr val="0A2A43"/>
                 </a:solidFill>
@@ -8553,26 +8464,65 @@
                 <a:ea typeface="Cambria" pitchFamily="34" charset="-122"/>
                 <a:cs typeface="Cambria" pitchFamily="34" charset="-120"/>
               </a:rPr>
-              <a:t>Built on real, production infrastructure</a:t>
-            </a:r>
-            <a:endParaRPr lang="en-US" sz="3000" dirty="0"/>
-          </a:p>
-        </p:txBody>
-      </p:sp>
-      <p:sp>
-        <p:nvSpPr>
-          <p:cNvPr id="4" name="Shape 2"/>
-          <p:cNvSpPr/>
-          <p:nvPr/>
-        </p:nvSpPr>
-        <p:spPr>
-          <a:xfrm>
-            <a:off x="548640" y="2103120"/>
-            <a:ext cx="3611880" cy="1554480"/>
+              <a:t>No invented dates — sequenced by what deepens governance first</a:t>
+            </a:r>
+            <a:endParaRPr lang="en-US" sz="2400" dirty="0"/>
+          </a:p>
+        </p:txBody>
+      </p:sp>
+      <p:sp>
+        <p:nvSpPr>
+          <p:cNvPr id="4" name="Text 2"/>
+          <p:cNvSpPr/>
+          <p:nvPr/>
+        </p:nvSpPr>
+        <p:spPr>
+          <a:xfrm>
+            <a:off x="548640" y="1371600"/>
+            <a:ext cx="10972800" cy="365760"/>
+          </a:xfrm>
+          <a:prstGeom prst="rect">
+            <a:avLst/>
+          </a:prstGeom>
+          <a:noFill/>
+          <a:ln/>
+        </p:spPr>
+        <p:txBody>
+          <a:bodyPr wrap="square" rtlCol="0" anchor="ctr"/>
+          <a:lstStyle/>
+          <a:p>
+            <a:pPr indent="0" marL="0">
+              <a:buNone/>
+            </a:pPr>
+            <a:r>
+              <a:rPr lang="en-US" sz="1250" i="1" dirty="0">
+                <a:solidFill>
+                  <a:srgbClr val="6B7280"/>
+                </a:solidFill>
+                <a:latin typeface="Calibri" pitchFamily="34" charset="0"/>
+                <a:ea typeface="Calibri" pitchFamily="34" charset="-122"/>
+                <a:cs typeface="Calibri" pitchFamily="34" charset="-120"/>
+              </a:rPr>
+              <a:t>A single-team roadmap can't credibly commit to a quarter, so this is grouped by sequencing, not promised timing.</a:t>
+            </a:r>
+            <a:endParaRPr lang="en-US" sz="1250" dirty="0"/>
+          </a:p>
+        </p:txBody>
+      </p:sp>
+      <p:sp>
+        <p:nvSpPr>
+          <p:cNvPr id="5" name="Shape 3"/>
+          <p:cNvSpPr/>
+          <p:nvPr/>
+        </p:nvSpPr>
+        <p:spPr>
+          <a:xfrm>
+            <a:off x="457200" y="2011680"/>
+            <a:ext cx="3611880" cy="4160520"/>
           </a:xfrm>
           <a:prstGeom prst="roundRect">
             <a:avLst>
-              <a:gd name="adj" fmla="val 5882"/>
+              <a:gd name="adj" fmla="val 2532"/>
             </a:avLst>
           </a:prstGeom>
           <a:solidFill>
@@ -8583,99 +8533,214 @@
       </p:sp>
       <p:sp>
         <p:nvSpPr>
-          <p:cNvPr id="5" name="Text 3"/>
-          <p:cNvSpPr/>
-          <p:nvPr/>
-        </p:nvSpPr>
-        <p:spPr>
-          <a:xfrm>
-            <a:off x="822960" y="2331720"/>
-            <a:ext cx="3063240" cy="457200"/>
-          </a:xfrm>
-          <a:prstGeom prst="rect">
-            <a:avLst/>
-          </a:prstGeom>
-          <a:noFill/>
-          <a:ln/>
-        </p:spPr>
-        <p:txBody>
-          <a:bodyPr wrap="square" rtlCol="0" anchor="ctr"/>
-          <a:lstStyle/>
-          <a:p>
-            <a:pPr indent="0" marL="0">
-              <a:buNone/>
-            </a:pPr>
-            <a:r>
-              <a:rPr lang="en-US" sz="1400" b="1" dirty="0">
-                <a:solidFill>
-                  <a:srgbClr val="0A2A43"/>
-                </a:solidFill>
-                <a:latin typeface="Calibri" pitchFamily="34" charset="0"/>
-                <a:ea typeface="Calibri" pitchFamily="34" charset="-122"/>
-                <a:cs typeface="Calibri" pitchFamily="34" charset="-120"/>
-              </a:rPr>
-              <a:t>Frontend</a:t>
-            </a:r>
-            <a:endParaRPr lang="en-US" sz="1400" dirty="0"/>
-          </a:p>
-        </p:txBody>
-      </p:sp>
-      <p:sp>
-        <p:nvSpPr>
-          <p:cNvPr id="6" name="Text 4"/>
-          <p:cNvSpPr/>
-          <p:nvPr/>
-        </p:nvSpPr>
-        <p:spPr>
-          <a:xfrm>
-            <a:off x="822960" y="2834640"/>
-            <a:ext cx="3063240" cy="731520"/>
-          </a:xfrm>
-          <a:prstGeom prst="rect">
-            <a:avLst/>
-          </a:prstGeom>
-          <a:noFill/>
-          <a:ln/>
-        </p:spPr>
-        <p:txBody>
-          <a:bodyPr wrap="square" rtlCol="0" anchor="ctr"/>
-          <a:lstStyle/>
-          <a:p>
-            <a:pPr indent="0" marL="0">
-              <a:lnSpc>
-                <a:spcPct val="125000"/>
-              </a:lnSpc>
-              <a:buNone/>
-            </a:pPr>
-            <a:r>
-              <a:rPr lang="en-US" sz="1150" dirty="0">
-                <a:solidFill>
-                  <a:srgbClr val="1F2937"/>
-                </a:solidFill>
-                <a:latin typeface="Calibri" pitchFamily="34" charset="0"/>
-                <a:ea typeface="Calibri" pitchFamily="34" charset="-122"/>
-                <a:cs typeface="Calibri" pitchFamily="34" charset="-120"/>
-              </a:rPr>
-              <a:t>Next.js 16, React 19, TypeScript, Tailwind v4</a:t>
-            </a:r>
-            <a:endParaRPr lang="en-US" sz="1150" dirty="0"/>
-          </a:p>
-        </p:txBody>
-      </p:sp>
-      <p:sp>
-        <p:nvSpPr>
-          <p:cNvPr id="7" name="Shape 5"/>
-          <p:cNvSpPr/>
-          <p:nvPr/>
-        </p:nvSpPr>
-        <p:spPr>
-          <a:xfrm>
-            <a:off x="4343400" y="2103120"/>
-            <a:ext cx="3611880" cy="1554480"/>
+          <p:cNvPr id="6" name="Shape 4"/>
+          <p:cNvSpPr/>
+          <p:nvPr/>
+        </p:nvSpPr>
+        <p:spPr>
+          <a:xfrm>
+            <a:off x="457200" y="2011680"/>
+            <a:ext cx="3611880" cy="502920"/>
           </a:xfrm>
           <a:prstGeom prst="roundRect">
             <a:avLst>
-              <a:gd name="adj" fmla="val 5882"/>
+              <a:gd name="adj" fmla="val 18182"/>
+            </a:avLst>
+          </a:prstGeom>
+          <a:solidFill>
+            <a:srgbClr val="1A9C94"/>
+          </a:solidFill>
+          <a:ln/>
+        </p:spPr>
+      </p:sp>
+      <p:sp>
+        <p:nvSpPr>
+          <p:cNvPr id="7" name="Shape 5"/>
+          <p:cNvSpPr/>
+          <p:nvPr/>
+        </p:nvSpPr>
+        <p:spPr>
+          <a:xfrm>
+            <a:off x="457200" y="2267712"/>
+            <a:ext cx="3611880" cy="246888"/>
+          </a:xfrm>
+          <a:prstGeom prst="rect">
+            <a:avLst/>
+          </a:prstGeom>
+          <a:solidFill>
+            <a:srgbClr val="1A9C94"/>
+          </a:solidFill>
+          <a:ln/>
+        </p:spPr>
+      </p:sp>
+      <p:sp>
+        <p:nvSpPr>
+          <p:cNvPr id="8" name="Text 6"/>
+          <p:cNvSpPr/>
+          <p:nvPr/>
+        </p:nvSpPr>
+        <p:spPr>
+          <a:xfrm>
+            <a:off x="640080" y="2011680"/>
+            <a:ext cx="3246120" cy="502920"/>
+          </a:xfrm>
+          <a:prstGeom prst="rect">
+            <a:avLst/>
+          </a:prstGeom>
+          <a:noFill/>
+          <a:ln/>
+        </p:spPr>
+        <p:txBody>
+          <a:bodyPr wrap="square" rtlCol="0" anchor="ctr"/>
+          <a:lstStyle/>
+          <a:p>
+            <a:pPr indent="0" marL="0">
+              <a:buNone/>
+            </a:pPr>
+            <a:r>
+              <a:rPr lang="en-US" sz="1150" b="1" dirty="0">
+                <a:solidFill>
+                  <a:srgbClr val="FFFFFF"/>
+                </a:solidFill>
+                <a:latin typeface="Calibri" pitchFamily="34" charset="0"/>
+                <a:ea typeface="Calibri" pitchFamily="34" charset="-122"/>
+                <a:cs typeface="Calibri" pitchFamily="34" charset="-120"/>
+              </a:rPr>
+              <a:t>DELIVERED — MVP, LIVE TODAY</a:t>
+            </a:r>
+            <a:endParaRPr lang="en-US" sz="1150" dirty="0"/>
+          </a:p>
+        </p:txBody>
+      </p:sp>
+      <p:sp>
+        <p:nvSpPr>
+          <p:cNvPr id="9" name="Text 7"/>
+          <p:cNvSpPr/>
+          <p:nvPr/>
+        </p:nvSpPr>
+        <p:spPr>
+          <a:xfrm>
+            <a:off x="658368" y="2697480"/>
+            <a:ext cx="3209544" cy="3246120"/>
+          </a:xfrm>
+          <a:prstGeom prst="rect">
+            <a:avLst/>
+          </a:prstGeom>
+          <a:noFill/>
+          <a:ln/>
+        </p:spPr>
+        <p:txBody>
+          <a:bodyPr wrap="square" rtlCol="0" anchor="ctr"/>
+          <a:lstStyle/>
+          <a:p>
+            <a:pPr marL="177800" indent="-177800">
+              <a:lnSpc>
+                <a:spcPct val="130000"/>
+              </a:lnSpc>
+              <a:spcAft>
+                <a:spcPts val="800"/>
+              </a:spcAft>
+              <a:buSzPct val="100000"/>
+              <a:buChar char="•"/>
+            </a:pPr>
+            <a:r>
+              <a:rPr lang="en-US" sz="1100" dirty="0">
+                <a:solidFill>
+                  <a:srgbClr val="1F2937"/>
+                </a:solidFill>
+                <a:latin typeface="Calibri" pitchFamily="34" charset="0"/>
+                <a:ea typeface="Calibri" pitchFamily="34" charset="-122"/>
+                <a:cs typeface="Calibri" pitchFamily="34" charset="-120"/>
+              </a:rPr>
+              <a:t>Full pipeline, Discovery through Observability</a:t>
+            </a:r>
+            <a:endParaRPr lang="en-US" sz="1100" dirty="0"/>
+          </a:p>
+          <a:p>
+            <a:pPr indent="0" marL="0">
+              <a:lnSpc>
+                <a:spcPct val="130000"/>
+              </a:lnSpc>
+              <a:spcAft>
+                <a:spcPts val="800"/>
+              </a:spcAft>
+              <a:buNone/>
+            </a:pPr>
+            <a:r>
+              <a:rPr lang="en-US" sz="1100" dirty="0">
+                <a:solidFill>
+                  <a:srgbClr val="1F2937"/>
+                </a:solidFill>
+                <a:latin typeface="Calibri" pitchFamily="34" charset="0"/>
+                <a:ea typeface="Calibri" pitchFamily="34" charset="-122"/>
+                <a:cs typeface="Calibri" pitchFamily="34" charset="-120"/>
+              </a:rPr>
+              <a:t>Real runtime governance: kill-switch, audit log, PII redaction</a:t>
+            </a:r>
+            <a:endParaRPr lang="en-US" sz="1100" dirty="0"/>
+          </a:p>
+          <a:p>
+            <a:pPr indent="0" marL="0">
+              <a:lnSpc>
+                <a:spcPct val="130000"/>
+              </a:lnSpc>
+              <a:spcAft>
+                <a:spcPts val="800"/>
+              </a:spcAft>
+              <a:buNone/>
+            </a:pPr>
+            <a:r>
+              <a:rPr lang="en-US" sz="1100" dirty="0">
+                <a:solidFill>
+                  <a:srgbClr val="1F2937"/>
+                </a:solidFill>
+                <a:latin typeface="Calibri" pitchFamily="34" charset="0"/>
+                <a:ea typeface="Calibri" pitchFamily="34" charset="-122"/>
+                <a:cs typeface="Calibri" pitchFamily="34" charset="-120"/>
+              </a:rPr>
+              <a:t>Real multi-tenancy, SSO, AI Gateway with fallback</a:t>
+            </a:r>
+            <a:endParaRPr lang="en-US" sz="1100" dirty="0"/>
+          </a:p>
+          <a:p>
+            <a:pPr indent="0" marL="0">
+              <a:lnSpc>
+                <a:spcPct val="130000"/>
+              </a:lnSpc>
+              <a:spcAft>
+                <a:spcPts val="800"/>
+              </a:spcAft>
+              <a:buNone/>
+            </a:pPr>
+            <a:r>
+              <a:rPr lang="en-US" sz="1100" dirty="0">
+                <a:solidFill>
+                  <a:srgbClr val="1F2937"/>
+                </a:solidFill>
+                <a:latin typeface="Calibri" pitchFamily="34" charset="0"/>
+                <a:ea typeface="Calibri" pitchFamily="34" charset="-122"/>
+                <a:cs typeface="Calibri" pitchFamily="34" charset="-120"/>
+              </a:rPr>
+              <a:t>Preflight-check + reconciliation APIs</a:t>
+            </a:r>
+            <a:endParaRPr lang="en-US" sz="1100" dirty="0"/>
+          </a:p>
+        </p:txBody>
+      </p:sp>
+      <p:sp>
+        <p:nvSpPr>
+          <p:cNvPr id="10" name="Shape 8"/>
+          <p:cNvSpPr/>
+          <p:nvPr/>
+        </p:nvSpPr>
+        <p:spPr>
+          <a:xfrm>
+            <a:off x="4288536" y="2011680"/>
+            <a:ext cx="3611880" cy="4160520"/>
+          </a:xfrm>
+          <a:prstGeom prst="roundRect">
+            <a:avLst>
+              <a:gd name="adj" fmla="val 2532"/>
             </a:avLst>
           </a:prstGeom>
           <a:solidFill>
@@ -8686,99 +8751,237 @@
       </p:sp>
       <p:sp>
         <p:nvSpPr>
-          <p:cNvPr id="8" name="Text 6"/>
-          <p:cNvSpPr/>
-          <p:nvPr/>
-        </p:nvSpPr>
-        <p:spPr>
-          <a:xfrm>
-            <a:off x="4617720" y="2331720"/>
-            <a:ext cx="3063240" cy="457200"/>
-          </a:xfrm>
-          <a:prstGeom prst="rect">
-            <a:avLst/>
-          </a:prstGeom>
-          <a:noFill/>
-          <a:ln/>
-        </p:spPr>
-        <p:txBody>
-          <a:bodyPr wrap="square" rtlCol="0" anchor="ctr"/>
-          <a:lstStyle/>
-          <a:p>
-            <a:pPr indent="0" marL="0">
-              <a:buNone/>
-            </a:pPr>
-            <a:r>
-              <a:rPr lang="en-US" sz="1400" b="1" dirty="0">
-                <a:solidFill>
-                  <a:srgbClr val="0A2A43"/>
-                </a:solidFill>
-                <a:latin typeface="Calibri" pitchFamily="34" charset="0"/>
-                <a:ea typeface="Calibri" pitchFamily="34" charset="-122"/>
-                <a:cs typeface="Calibri" pitchFamily="34" charset="-120"/>
-              </a:rPr>
-              <a:t>Backend / Data</a:t>
-            </a:r>
-            <a:endParaRPr lang="en-US" sz="1400" dirty="0"/>
-          </a:p>
-        </p:txBody>
-      </p:sp>
-      <p:sp>
-        <p:nvSpPr>
-          <p:cNvPr id="9" name="Text 7"/>
-          <p:cNvSpPr/>
-          <p:nvPr/>
-        </p:nvSpPr>
-        <p:spPr>
-          <a:xfrm>
-            <a:off x="4617720" y="2834640"/>
-            <a:ext cx="3063240" cy="731520"/>
-          </a:xfrm>
-          <a:prstGeom prst="rect">
-            <a:avLst/>
-          </a:prstGeom>
-          <a:noFill/>
-          <a:ln/>
-        </p:spPr>
-        <p:txBody>
-          <a:bodyPr wrap="square" rtlCol="0" anchor="ctr"/>
-          <a:lstStyle/>
-          <a:p>
-            <a:pPr indent="0" marL="0">
-              <a:lnSpc>
-                <a:spcPct val="125000"/>
-              </a:lnSpc>
-              <a:buNone/>
-            </a:pPr>
-            <a:r>
-              <a:rPr lang="en-US" sz="1150" dirty="0">
-                <a:solidFill>
-                  <a:srgbClr val="1F2937"/>
-                </a:solidFill>
-                <a:latin typeface="Calibri" pitchFamily="34" charset="0"/>
-                <a:ea typeface="Calibri" pitchFamily="34" charset="-122"/>
-                <a:cs typeface="Calibri" pitchFamily="34" charset="-120"/>
-              </a:rPr>
-              <a:t>Prisma 7 + Neon Postgres, Auth.js v5</a:t>
-            </a:r>
-            <a:endParaRPr lang="en-US" sz="1150" dirty="0"/>
-          </a:p>
-        </p:txBody>
-      </p:sp>
-      <p:sp>
-        <p:nvSpPr>
-          <p:cNvPr id="10" name="Shape 8"/>
-          <p:cNvSpPr/>
-          <p:nvPr/>
-        </p:nvSpPr>
-        <p:spPr>
-          <a:xfrm>
-            <a:off x="8138160" y="2103120"/>
-            <a:ext cx="3611880" cy="1554480"/>
+          <p:cNvPr id="11" name="Shape 9"/>
+          <p:cNvSpPr/>
+          <p:nvPr/>
+        </p:nvSpPr>
+        <p:spPr>
+          <a:xfrm>
+            <a:off x="4288536" y="2011680"/>
+            <a:ext cx="3611880" cy="502920"/>
           </a:xfrm>
           <a:prstGeom prst="roundRect">
             <a:avLst>
-              <a:gd name="adj" fmla="val 5882"/>
+              <a:gd name="adj" fmla="val 18182"/>
+            </a:avLst>
+          </a:prstGeom>
+          <a:solidFill>
+            <a:srgbClr val="0A2A43"/>
+          </a:solidFill>
+          <a:ln/>
+        </p:spPr>
+      </p:sp>
+      <p:sp>
+        <p:nvSpPr>
+          <p:cNvPr id="12" name="Shape 10"/>
+          <p:cNvSpPr/>
+          <p:nvPr/>
+        </p:nvSpPr>
+        <p:spPr>
+          <a:xfrm>
+            <a:off x="4288536" y="2267712"/>
+            <a:ext cx="3611880" cy="246888"/>
+          </a:xfrm>
+          <a:prstGeom prst="rect">
+            <a:avLst/>
+          </a:prstGeom>
+          <a:solidFill>
+            <a:srgbClr val="0A2A43"/>
+          </a:solidFill>
+          <a:ln/>
+        </p:spPr>
+      </p:sp>
+      <p:sp>
+        <p:nvSpPr>
+          <p:cNvPr id="13" name="Text 11"/>
+          <p:cNvSpPr/>
+          <p:nvPr/>
+        </p:nvSpPr>
+        <p:spPr>
+          <a:xfrm>
+            <a:off x="4471416" y="2011680"/>
+            <a:ext cx="3246120" cy="502920"/>
+          </a:xfrm>
+          <a:prstGeom prst="rect">
+            <a:avLst/>
+          </a:prstGeom>
+          <a:noFill/>
+          <a:ln/>
+        </p:spPr>
+        <p:txBody>
+          <a:bodyPr wrap="square" rtlCol="0" anchor="ctr"/>
+          <a:lstStyle/>
+          <a:p>
+            <a:pPr indent="0" marL="0">
+              <a:buNone/>
+            </a:pPr>
+            <a:r>
+              <a:rPr lang="en-US" sz="1150" b="1" dirty="0">
+                <a:solidFill>
+                  <a:srgbClr val="FFFFFF"/>
+                </a:solidFill>
+                <a:latin typeface="Calibri" pitchFamily="34" charset="0"/>
+                <a:ea typeface="Calibri" pitchFamily="34" charset="-122"/>
+                <a:cs typeface="Calibri" pitchFamily="34" charset="-120"/>
+              </a:rPr>
+              <a:t>NEXT — DEEPENS GOVERNANCE</a:t>
+            </a:r>
+            <a:endParaRPr lang="en-US" sz="1150" dirty="0"/>
+          </a:p>
+        </p:txBody>
+      </p:sp>
+      <p:sp>
+        <p:nvSpPr>
+          <p:cNvPr id="14" name="Text 12"/>
+          <p:cNvSpPr/>
+          <p:nvPr/>
+        </p:nvSpPr>
+        <p:spPr>
+          <a:xfrm>
+            <a:off x="4489704" y="2697480"/>
+            <a:ext cx="3209544" cy="3246120"/>
+          </a:xfrm>
+          <a:prstGeom prst="rect">
+            <a:avLst/>
+          </a:prstGeom>
+          <a:noFill/>
+          <a:ln/>
+        </p:spPr>
+        <p:txBody>
+          <a:bodyPr wrap="square" rtlCol="0" anchor="ctr"/>
+          <a:lstStyle/>
+          <a:p>
+            <a:pPr marL="177800" indent="-177800">
+              <a:lnSpc>
+                <a:spcPct val="130000"/>
+              </a:lnSpc>
+              <a:spcAft>
+                <a:spcPts val="800"/>
+              </a:spcAft>
+              <a:buSzPct val="100000"/>
+              <a:buChar char="•"/>
+            </a:pPr>
+            <a:r>
+              <a:rPr lang="en-US" sz="1100" dirty="0">
+                <a:solidFill>
+                  <a:srgbClr val="1F2937"/>
+                </a:solidFill>
+                <a:latin typeface="Calibri" pitchFamily="34" charset="0"/>
+                <a:ea typeface="Calibri" pitchFamily="34" charset="-122"/>
+                <a:cs typeface="Calibri" pitchFamily="34" charset="-120"/>
+              </a:rPr>
+              <a:t>Governance templates per regulatory regime</a:t>
+            </a:r>
+            <a:endParaRPr lang="en-US" sz="1100" dirty="0"/>
+          </a:p>
+          <a:p>
+            <a:pPr indent="0" marL="0">
+              <a:lnSpc>
+                <a:spcPct val="130000"/>
+              </a:lnSpc>
+              <a:spcAft>
+                <a:spcPts val="800"/>
+              </a:spcAft>
+              <a:buNone/>
+            </a:pPr>
+            <a:r>
+              <a:rPr lang="en-US" sz="1100" dirty="0">
+                <a:solidFill>
+                  <a:srgbClr val="1F2937"/>
+                </a:solidFill>
+                <a:latin typeface="Calibri" pitchFamily="34" charset="0"/>
+                <a:ea typeface="Calibri" pitchFamily="34" charset="-122"/>
+                <a:cs typeface="Calibri" pitchFamily="34" charset="-120"/>
+              </a:rPr>
+              <a:t>Configurable PII patterns per org/region</a:t>
+            </a:r>
+            <a:endParaRPr lang="en-US" sz="1100" dirty="0"/>
+          </a:p>
+          <a:p>
+            <a:pPr indent="0" marL="0">
+              <a:lnSpc>
+                <a:spcPct val="130000"/>
+              </a:lnSpc>
+              <a:spcAft>
+                <a:spcPts val="800"/>
+              </a:spcAft>
+              <a:buNone/>
+            </a:pPr>
+            <a:r>
+              <a:rPr lang="en-US" sz="1100" dirty="0">
+                <a:solidFill>
+                  <a:srgbClr val="1F2937"/>
+                </a:solidFill>
+                <a:latin typeface="Calibri" pitchFamily="34" charset="0"/>
+                <a:ea typeface="Calibri" pitchFamily="34" charset="-122"/>
+                <a:cs typeface="Calibri" pitchFamily="34" charset="-120"/>
+              </a:rPr>
+              <a:t>Regulatory citation mapping</a:t>
+            </a:r>
+            <a:endParaRPr lang="en-US" sz="1100" dirty="0"/>
+          </a:p>
+          <a:p>
+            <a:pPr indent="0" marL="0">
+              <a:lnSpc>
+                <a:spcPct val="130000"/>
+              </a:lnSpc>
+              <a:spcAft>
+                <a:spcPts val="800"/>
+              </a:spcAft>
+              <a:buNone/>
+            </a:pPr>
+            <a:r>
+              <a:rPr lang="en-US" sz="1100" dirty="0">
+                <a:solidFill>
+                  <a:srgbClr val="1F2937"/>
+                </a:solidFill>
+                <a:latin typeface="Calibri" pitchFamily="34" charset="0"/>
+                <a:ea typeface="Calibri" pitchFamily="34" charset="-122"/>
+                <a:cs typeface="Calibri" pitchFamily="34" charset="-120"/>
+              </a:rPr>
+              <a:t>Incident workflow tied to the kill-switch</a:t>
+            </a:r>
+            <a:endParaRPr lang="en-US" sz="1100" dirty="0"/>
+          </a:p>
+          <a:p>
+            <a:pPr indent="0" marL="0">
+              <a:lnSpc>
+                <a:spcPct val="130000"/>
+              </a:lnSpc>
+              <a:spcAft>
+                <a:spcPts val="800"/>
+              </a:spcAft>
+              <a:buNone/>
+            </a:pPr>
+            <a:r>
+              <a:rPr lang="en-US" sz="1100" dirty="0">
+                <a:solidFill>
+                  <a:srgbClr val="1F2937"/>
+                </a:solidFill>
+                <a:latin typeface="Calibri" pitchFamily="34" charset="0"/>
+                <a:ea typeface="Calibri" pitchFamily="34" charset="-122"/>
+                <a:cs typeface="Calibri" pitchFamily="34" charset="-120"/>
+              </a:rPr>
+              <a:t>Aggregate portfolio risk rollup</a:t>
+            </a:r>
+            <a:endParaRPr lang="en-US" sz="1100" dirty="0"/>
+          </a:p>
+        </p:txBody>
+      </p:sp>
+      <p:sp>
+        <p:nvSpPr>
+          <p:cNvPr id="15" name="Shape 13"/>
+          <p:cNvSpPr/>
+          <p:nvPr/>
+        </p:nvSpPr>
+        <p:spPr>
+          <a:xfrm>
+            <a:off x="8119872" y="2011680"/>
+            <a:ext cx="3611880" cy="4160520"/>
+          </a:xfrm>
+          <a:prstGeom prst="roundRect">
+            <a:avLst>
+              <a:gd name="adj" fmla="val 2532"/>
             </a:avLst>
           </a:prstGeom>
           <a:solidFill>
@@ -8789,175 +8992,118 @@
       </p:sp>
       <p:sp>
         <p:nvSpPr>
-          <p:cNvPr id="11" name="Text 9"/>
-          <p:cNvSpPr/>
-          <p:nvPr/>
-        </p:nvSpPr>
-        <p:spPr>
-          <a:xfrm>
-            <a:off x="8412480" y="2331720"/>
-            <a:ext cx="3063240" cy="457200"/>
-          </a:xfrm>
-          <a:prstGeom prst="rect">
-            <a:avLst/>
-          </a:prstGeom>
-          <a:noFill/>
-          <a:ln/>
-        </p:spPr>
-        <p:txBody>
-          <a:bodyPr wrap="square" rtlCol="0" anchor="ctr"/>
-          <a:lstStyle/>
-          <a:p>
-            <a:pPr indent="0" marL="0">
-              <a:buNone/>
-            </a:pPr>
-            <a:r>
-              <a:rPr lang="en-US" sz="1400" b="1" dirty="0">
-                <a:solidFill>
-                  <a:srgbClr val="0A2A43"/>
-                </a:solidFill>
-                <a:latin typeface="Calibri" pitchFamily="34" charset="0"/>
-                <a:ea typeface="Calibri" pitchFamily="34" charset="-122"/>
-                <a:cs typeface="Calibri" pitchFamily="34" charset="-120"/>
-              </a:rPr>
-              <a:t>Agent Orchestration</a:t>
-            </a:r>
-            <a:endParaRPr lang="en-US" sz="1400" dirty="0"/>
-          </a:p>
-        </p:txBody>
-      </p:sp>
-      <p:sp>
-        <p:nvSpPr>
-          <p:cNvPr id="12" name="Text 10"/>
-          <p:cNvSpPr/>
-          <p:nvPr/>
-        </p:nvSpPr>
-        <p:spPr>
-          <a:xfrm>
-            <a:off x="8412480" y="2834640"/>
-            <a:ext cx="3063240" cy="731520"/>
-          </a:xfrm>
-          <a:prstGeom prst="rect">
-            <a:avLst/>
-          </a:prstGeom>
-          <a:noFill/>
-          <a:ln/>
-        </p:spPr>
-        <p:txBody>
-          <a:bodyPr wrap="square" rtlCol="0" anchor="ctr"/>
-          <a:lstStyle/>
-          <a:p>
-            <a:pPr indent="0" marL="0">
-              <a:lnSpc>
-                <a:spcPct val="125000"/>
-              </a:lnSpc>
-              <a:buNone/>
-            </a:pPr>
-            <a:r>
-              <a:rPr lang="en-US" sz="1150" dirty="0">
-                <a:solidFill>
-                  <a:srgbClr val="1F2937"/>
-                </a:solidFill>
-                <a:latin typeface="Calibri" pitchFamily="34" charset="0"/>
-                <a:ea typeface="Calibri" pitchFamily="34" charset="-122"/>
-                <a:cs typeface="Calibri" pitchFamily="34" charset="-120"/>
-              </a:rPr>
-              <a:t>LangGraph + LangChain, SSE streaming</a:t>
-            </a:r>
-            <a:endParaRPr lang="en-US" sz="1150" dirty="0"/>
-          </a:p>
-        </p:txBody>
-      </p:sp>
-      <p:sp>
-        <p:nvSpPr>
-          <p:cNvPr id="13" name="Shape 11"/>
-          <p:cNvSpPr/>
-          <p:nvPr/>
-        </p:nvSpPr>
-        <p:spPr>
-          <a:xfrm>
-            <a:off x="548640" y="3840480"/>
-            <a:ext cx="3611880" cy="1554480"/>
+          <p:cNvPr id="16" name="Shape 14"/>
+          <p:cNvSpPr/>
+          <p:nvPr/>
+        </p:nvSpPr>
+        <p:spPr>
+          <a:xfrm>
+            <a:off x="8119872" y="2011680"/>
+            <a:ext cx="3611880" cy="502920"/>
           </a:xfrm>
           <a:prstGeom prst="roundRect">
             <a:avLst>
-              <a:gd name="adj" fmla="val 5882"/>
+              <a:gd name="adj" fmla="val 18182"/>
             </a:avLst>
           </a:prstGeom>
           <a:solidFill>
-            <a:srgbClr val="F3F6F8"/>
+            <a:srgbClr val="6B7280"/>
           </a:solidFill>
           <a:ln/>
         </p:spPr>
       </p:sp>
       <p:sp>
         <p:nvSpPr>
-          <p:cNvPr id="14" name="Text 12"/>
-          <p:cNvSpPr/>
-          <p:nvPr/>
-        </p:nvSpPr>
-        <p:spPr>
-          <a:xfrm>
-            <a:off x="822960" y="4069080"/>
-            <a:ext cx="3063240" cy="457200"/>
-          </a:xfrm>
-          <a:prstGeom prst="rect">
-            <a:avLst/>
-          </a:prstGeom>
-          <a:noFill/>
-          <a:ln/>
-        </p:spPr>
-        <p:txBody>
-          <a:bodyPr wrap="square" rtlCol="0" anchor="ctr"/>
-          <a:lstStyle/>
-          <a:p>
-            <a:pPr indent="0" marL="0">
-              <a:buNone/>
-            </a:pPr>
-            <a:r>
-              <a:rPr lang="en-US" sz="1400" b="1" dirty="0">
-                <a:solidFill>
-                  <a:srgbClr val="0A2A43"/>
-                </a:solidFill>
-                <a:latin typeface="Calibri" pitchFamily="34" charset="0"/>
-                <a:ea typeface="Calibri" pitchFamily="34" charset="-122"/>
-                <a:cs typeface="Calibri" pitchFamily="34" charset="-120"/>
-              </a:rPr>
-              <a:t>Retrieval / RAG</a:t>
-            </a:r>
-            <a:endParaRPr lang="en-US" sz="1400" dirty="0"/>
-          </a:p>
-        </p:txBody>
-      </p:sp>
-      <p:sp>
-        <p:nvSpPr>
-          <p:cNvPr id="15" name="Text 13"/>
-          <p:cNvSpPr/>
-          <p:nvPr/>
-        </p:nvSpPr>
-        <p:spPr>
-          <a:xfrm>
-            <a:off x="822960" y="4572000"/>
-            <a:ext cx="3063240" cy="731520"/>
-          </a:xfrm>
-          <a:prstGeom prst="rect">
-            <a:avLst/>
-          </a:prstGeom>
-          <a:noFill/>
-          <a:ln/>
-        </p:spPr>
-        <p:txBody>
-          <a:bodyPr wrap="square" rtlCol="0" anchor="ctr"/>
-          <a:lstStyle/>
-          <a:p>
-            <a:pPr indent="0" marL="0">
+          <p:cNvPr id="17" name="Shape 15"/>
+          <p:cNvSpPr/>
+          <p:nvPr/>
+        </p:nvSpPr>
+        <p:spPr>
+          <a:xfrm>
+            <a:off x="8119872" y="2267712"/>
+            <a:ext cx="3611880" cy="246888"/>
+          </a:xfrm>
+          <a:prstGeom prst="rect">
+            <a:avLst/>
+          </a:prstGeom>
+          <a:solidFill>
+            <a:srgbClr val="6B7280"/>
+          </a:solidFill>
+          <a:ln/>
+        </p:spPr>
+      </p:sp>
+      <p:sp>
+        <p:nvSpPr>
+          <p:cNvPr id="18" name="Text 16"/>
+          <p:cNvSpPr/>
+          <p:nvPr/>
+        </p:nvSpPr>
+        <p:spPr>
+          <a:xfrm>
+            <a:off x="8302752" y="2011680"/>
+            <a:ext cx="3246120" cy="502920"/>
+          </a:xfrm>
+          <a:prstGeom prst="rect">
+            <a:avLst/>
+          </a:prstGeom>
+          <a:noFill/>
+          <a:ln/>
+        </p:spPr>
+        <p:txBody>
+          <a:bodyPr wrap="square" rtlCol="0" anchor="ctr"/>
+          <a:lstStyle/>
+          <a:p>
+            <a:pPr indent="0" marL="0">
+              <a:buNone/>
+            </a:pPr>
+            <a:r>
+              <a:rPr lang="en-US" sz="1150" b="1" dirty="0">
+                <a:solidFill>
+                  <a:srgbClr val="FFFFFF"/>
+                </a:solidFill>
+                <a:latin typeface="Calibri" pitchFamily="34" charset="0"/>
+                <a:ea typeface="Calibri" pitchFamily="34" charset="-122"/>
+                <a:cs typeface="Calibri" pitchFamily="34" charset="-120"/>
+              </a:rPr>
+              <a:t>LATER &amp; HARDENING</a:t>
+            </a:r>
+            <a:endParaRPr lang="en-US" sz="1150" dirty="0"/>
+          </a:p>
+        </p:txBody>
+      </p:sp>
+      <p:sp>
+        <p:nvSpPr>
+          <p:cNvPr id="19" name="Text 17"/>
+          <p:cNvSpPr/>
+          <p:nvPr/>
+        </p:nvSpPr>
+        <p:spPr>
+          <a:xfrm>
+            <a:off x="8321040" y="2697480"/>
+            <a:ext cx="3209544" cy="3246120"/>
+          </a:xfrm>
+          <a:prstGeom prst="rect">
+            <a:avLst/>
+          </a:prstGeom>
+          <a:noFill/>
+          <a:ln/>
+        </p:spPr>
+        <p:txBody>
+          <a:bodyPr wrap="square" rtlCol="0" anchor="ctr"/>
+          <a:lstStyle/>
+          <a:p>
+            <a:pPr marL="177800" indent="-177800">
               <a:lnSpc>
-                <a:spcPct val="125000"/>
+                <a:spcPct val="130000"/>
               </a:lnSpc>
-              <a:buNone/>
-            </a:pPr>
-            <a:r>
-              <a:rPr lang="en-US" sz="1150" dirty="0">
+              <a:spcAft>
+                <a:spcPts val="800"/>
+              </a:spcAft>
+              <a:buSzPct val="100000"/>
+              <a:buChar char="•"/>
+            </a:pPr>
+            <a:r>
+              <a:rPr lang="en-US" sz="1100" dirty="0">
                 <a:solidFill>
                   <a:srgbClr val="1F2937"/>
                 </a:solidFill>
@@ -8965,102 +9111,22 @@
                 <a:ea typeface="Calibri" pitchFamily="34" charset="-122"/>
                 <a:cs typeface="Calibri" pitchFamily="34" charset="-120"/>
               </a:rPr>
-              <a:t>Pinecone + Cohere</a:t>
-            </a:r>
-            <a:endParaRPr lang="en-US" sz="1150" dirty="0"/>
-          </a:p>
-        </p:txBody>
-      </p:sp>
-      <p:sp>
-        <p:nvSpPr>
-          <p:cNvPr id="16" name="Shape 14"/>
-          <p:cNvSpPr/>
-          <p:nvPr/>
-        </p:nvSpPr>
-        <p:spPr>
-          <a:xfrm>
-            <a:off x="4343400" y="3840480"/>
-            <a:ext cx="3611880" cy="1554480"/>
-          </a:xfrm>
-          <a:prstGeom prst="roundRect">
-            <a:avLst>
-              <a:gd name="adj" fmla="val 5882"/>
-            </a:avLst>
-          </a:prstGeom>
-          <a:solidFill>
-            <a:srgbClr val="F3F6F8"/>
-          </a:solidFill>
-          <a:ln/>
-        </p:spPr>
-      </p:sp>
-      <p:sp>
-        <p:nvSpPr>
-          <p:cNvPr id="17" name="Text 15"/>
-          <p:cNvSpPr/>
-          <p:nvPr/>
-        </p:nvSpPr>
-        <p:spPr>
-          <a:xfrm>
-            <a:off x="4617720" y="4069080"/>
-            <a:ext cx="3063240" cy="457200"/>
-          </a:xfrm>
-          <a:prstGeom prst="rect">
-            <a:avLst/>
-          </a:prstGeom>
-          <a:noFill/>
-          <a:ln/>
-        </p:spPr>
-        <p:txBody>
-          <a:bodyPr wrap="square" rtlCol="0" anchor="ctr"/>
-          <a:lstStyle/>
-          <a:p>
-            <a:pPr indent="0" marL="0">
-              <a:buNone/>
-            </a:pPr>
-            <a:r>
-              <a:rPr lang="en-US" sz="1400" b="1" dirty="0">
-                <a:solidFill>
-                  <a:srgbClr val="0A2A43"/>
-                </a:solidFill>
-                <a:latin typeface="Calibri" pitchFamily="34" charset="0"/>
-                <a:ea typeface="Calibri" pitchFamily="34" charset="-122"/>
-                <a:cs typeface="Calibri" pitchFamily="34" charset="-120"/>
-              </a:rPr>
-              <a:t>AI Gateway</a:t>
-            </a:r>
-            <a:endParaRPr lang="en-US" sz="1400" dirty="0"/>
-          </a:p>
-        </p:txBody>
-      </p:sp>
-      <p:sp>
-        <p:nvSpPr>
-          <p:cNvPr id="18" name="Text 16"/>
-          <p:cNvSpPr/>
-          <p:nvPr/>
-        </p:nvSpPr>
-        <p:spPr>
-          <a:xfrm>
-            <a:off x="4617720" y="4572000"/>
-            <a:ext cx="3063240" cy="731520"/>
-          </a:xfrm>
-          <a:prstGeom prst="rect">
-            <a:avLst/>
-          </a:prstGeom>
-          <a:noFill/>
-          <a:ln/>
-        </p:spPr>
-        <p:txBody>
-          <a:bodyPr wrap="square" rtlCol="0" anchor="ctr"/>
-          <a:lstStyle/>
+              <a:t>Intake &amp; reference architecture templates</a:t>
+            </a:r>
+            <a:endParaRPr lang="en-US" sz="1100" dirty="0"/>
+          </a:p>
           <a:p>
             <a:pPr indent="0" marL="0">
               <a:lnSpc>
-                <a:spcPct val="125000"/>
+                <a:spcPct val="130000"/>
               </a:lnSpc>
-              <a:buNone/>
-            </a:pPr>
-            <a:r>
-              <a:rPr lang="en-US" sz="1150" dirty="0">
+              <a:spcAft>
+                <a:spcPts val="800"/>
+              </a:spcAft>
+              <a:buNone/>
+            </a:pPr>
+            <a:r>
+              <a:rPr lang="en-US" sz="1100" dirty="0">
                 <a:solidFill>
                   <a:srgbClr val="1F2937"/>
                 </a:solidFill>
@@ -9068,118 +9134,61 @@
                 <a:ea typeface="Calibri" pitchFamily="34" charset="-122"/>
                 <a:cs typeface="Calibri" pitchFamily="34" charset="-120"/>
               </a:rPr>
-              <a:t>Self-hosted LiteLLM Proxy, Google Cloud Run</a:t>
-            </a:r>
-            <a:endParaRPr lang="en-US" sz="1150" dirty="0"/>
-          </a:p>
-        </p:txBody>
-      </p:sp>
-      <p:sp>
-        <p:nvSpPr>
-          <p:cNvPr id="19" name="Shape 17"/>
-          <p:cNvSpPr/>
-          <p:nvPr/>
-        </p:nvSpPr>
-        <p:spPr>
-          <a:xfrm>
-            <a:off x="8138160" y="3840480"/>
-            <a:ext cx="3611880" cy="1554480"/>
-          </a:xfrm>
-          <a:prstGeom prst="roundRect">
-            <a:avLst>
-              <a:gd name="adj" fmla="val 5882"/>
-            </a:avLst>
-          </a:prstGeom>
-          <a:solidFill>
-            <a:srgbClr val="F3F6F8"/>
-          </a:solidFill>
-          <a:ln/>
-        </p:spPr>
+              <a:t>Vendor/model blast-radius reverse lookup</a:t>
+            </a:r>
+            <a:endParaRPr lang="en-US" sz="1100" dirty="0"/>
+          </a:p>
+          <a:p>
+            <a:pPr indent="0" marL="0">
+              <a:lnSpc>
+                <a:spcPct val="130000"/>
+              </a:lnSpc>
+              <a:spcAft>
+                <a:spcPts val="800"/>
+              </a:spcAft>
+              <a:buNone/>
+            </a:pPr>
+            <a:r>
+              <a:rPr lang="en-US" sz="1100" dirty="0">
+                <a:solidFill>
+                  <a:srgbClr val="1F2937"/>
+                </a:solidFill>
+                <a:latin typeface="Calibri" pitchFamily="34" charset="0"/>
+                <a:ea typeface="Calibri" pitchFamily="34" charset="-122"/>
+                <a:cs typeface="Calibri" pitchFamily="34" charset="-120"/>
+              </a:rPr>
+              <a:t>Configurable approval workflows per org</a:t>
+            </a:r>
+            <a:endParaRPr lang="en-US" sz="1100" dirty="0"/>
+          </a:p>
+          <a:p>
+            <a:pPr indent="0" marL="0">
+              <a:lnSpc>
+                <a:spcPct val="130000"/>
+              </a:lnSpc>
+              <a:spcAft>
+                <a:spcPts val="800"/>
+              </a:spcAft>
+              <a:buNone/>
+            </a:pPr>
+            <a:r>
+              <a:rPr lang="en-US" sz="1100" dirty="0">
+                <a:solidFill>
+                  <a:srgbClr val="1F2937"/>
+                </a:solidFill>
+                <a:latin typeface="Calibri" pitchFamily="34" charset="0"/>
+                <a:ea typeface="Calibri" pitchFamily="34" charset="-122"/>
+                <a:cs typeface="Calibri" pitchFamily="34" charset="-120"/>
+              </a:rPr>
+              <a:t>Broader test coverage, accessibility audit, SCIM, per-tenant branding</a:t>
+            </a:r>
+            <a:endParaRPr lang="en-US" sz="1100" dirty="0"/>
+          </a:p>
+        </p:txBody>
       </p:sp>
       <p:sp>
         <p:nvSpPr>
           <p:cNvPr id="20" name="Text 18"/>
-          <p:cNvSpPr/>
-          <p:nvPr/>
-        </p:nvSpPr>
-        <p:spPr>
-          <a:xfrm>
-            <a:off x="8412480" y="4069080"/>
-            <a:ext cx="3063240" cy="457200"/>
-          </a:xfrm>
-          <a:prstGeom prst="rect">
-            <a:avLst/>
-          </a:prstGeom>
-          <a:noFill/>
-          <a:ln/>
-        </p:spPr>
-        <p:txBody>
-          <a:bodyPr wrap="square" rtlCol="0" anchor="ctr"/>
-          <a:lstStyle/>
-          <a:p>
-            <a:pPr indent="0" marL="0">
-              <a:buNone/>
-            </a:pPr>
-            <a:r>
-              <a:rPr lang="en-US" sz="1400" b="1" dirty="0">
-                <a:solidFill>
-                  <a:srgbClr val="0A2A43"/>
-                </a:solidFill>
-                <a:latin typeface="Calibri" pitchFamily="34" charset="0"/>
-                <a:ea typeface="Calibri" pitchFamily="34" charset="-122"/>
-                <a:cs typeface="Calibri" pitchFamily="34" charset="-120"/>
-              </a:rPr>
-              <a:t>Real-time / Caching</a:t>
-            </a:r>
-            <a:endParaRPr lang="en-US" sz="1400" dirty="0"/>
-          </a:p>
-        </p:txBody>
-      </p:sp>
-      <p:sp>
-        <p:nvSpPr>
-          <p:cNvPr id="21" name="Text 19"/>
-          <p:cNvSpPr/>
-          <p:nvPr/>
-        </p:nvSpPr>
-        <p:spPr>
-          <a:xfrm>
-            <a:off x="8412480" y="4572000"/>
-            <a:ext cx="3063240" cy="731520"/>
-          </a:xfrm>
-          <a:prstGeom prst="rect">
-            <a:avLst/>
-          </a:prstGeom>
-          <a:noFill/>
-          <a:ln/>
-        </p:spPr>
-        <p:txBody>
-          <a:bodyPr wrap="square" rtlCol="0" anchor="ctr"/>
-          <a:lstStyle/>
-          <a:p>
-            <a:pPr indent="0" marL="0">
-              <a:lnSpc>
-                <a:spcPct val="125000"/>
-              </a:lnSpc>
-              <a:buNone/>
-            </a:pPr>
-            <a:r>
-              <a:rPr lang="en-US" sz="1150" dirty="0">
-                <a:solidFill>
-                  <a:srgbClr val="1F2937"/>
-                </a:solidFill>
-                <a:latin typeface="Calibri" pitchFamily="34" charset="0"/>
-                <a:ea typeface="Calibri" pitchFamily="34" charset="-122"/>
-                <a:cs typeface="Calibri" pitchFamily="34" charset="-120"/>
-              </a:rPr>
-              <a:t>Redis (Upstash)</a:t>
-            </a:r>
-            <a:endParaRPr lang="en-US" sz="1150" dirty="0"/>
-          </a:p>
-        </p:txBody>
-      </p:sp>
-      <p:sp>
-        <p:nvSpPr>
-          <p:cNvPr id="22" name="Text 20"/>
           <p:cNvSpPr/>
           <p:nvPr/>
         </p:nvSpPr>
@@ -9218,7 +9227,7 @@
       </p:sp>
       <p:sp>
         <p:nvSpPr>
-          <p:cNvPr id="23" name="Text 21"/>
+          <p:cNvPr id="21" name="Text 19"/>
           <p:cNvSpPr/>
           <p:nvPr/>
         </p:nvSpPr>
@@ -9266,910 +9275,6 @@
 <file path=ppt/slides/slide17.xml><?xml version="1.0" encoding="utf-8"?>
 <p:sld xmlns:a="http://schemas.openxmlformats.org/drawingml/2006/main" xmlns:r="http://schemas.openxmlformats.org/officeDocument/2006/relationships" xmlns:p="http://schemas.openxmlformats.org/presentationml/2006/main">
   <p:cSld name="Slide 17">
-    <p:bg>
-      <p:bgPr>
-        <a:solidFill>
-          <a:srgbClr val="FFFFFF"/>
-        </a:solidFill>
-      </p:bgPr>
-    </p:bg>
-    <p:spTree>
-      <p:nvGrpSpPr>
-        <p:cNvPr id="1" name=""/>
-        <p:cNvGrpSpPr/>
-        <p:nvPr/>
-      </p:nvGrpSpPr>
-      <p:grpSpPr>
-        <a:xfrm>
-          <a:off x="0" y="0"/>
-          <a:ext cx="0" cy="0"/>
-          <a:chOff x="0" y="0"/>
-          <a:chExt cx="0" cy="0"/>
-        </a:xfrm>
-      </p:grpSpPr>
-      <p:sp>
-        <p:nvSpPr>
-          <p:cNvPr id="2" name="Text 0"/>
-          <p:cNvSpPr/>
-          <p:nvPr/>
-        </p:nvSpPr>
-        <p:spPr>
-          <a:xfrm>
-            <a:off x="548640" y="457200"/>
-            <a:ext cx="7315200" cy="365760"/>
-          </a:xfrm>
-          <a:prstGeom prst="rect">
-            <a:avLst/>
-          </a:prstGeom>
-          <a:noFill/>
-          <a:ln/>
-        </p:spPr>
-        <p:txBody>
-          <a:bodyPr wrap="square" rtlCol="0" anchor="ctr"/>
-          <a:lstStyle/>
-          <a:p>
-            <a:pPr indent="0" marL="0">
-              <a:buNone/>
-            </a:pPr>
-            <a:r>
-              <a:rPr lang="en-US" sz="1200" b="1" spc="200" kern="0" dirty="0">
-                <a:solidFill>
-                  <a:srgbClr val="1A9C94"/>
-                </a:solidFill>
-                <a:latin typeface="Calibri" pitchFamily="34" charset="0"/>
-                <a:ea typeface="Calibri" pitchFamily="34" charset="-122"/>
-                <a:cs typeface="Calibri" pitchFamily="34" charset="-120"/>
-              </a:rPr>
-              <a:t>PHASED IMPLEMENTATION</a:t>
-            </a:r>
-            <a:endParaRPr lang="en-US" sz="1200" dirty="0"/>
-          </a:p>
-        </p:txBody>
-      </p:sp>
-      <p:sp>
-        <p:nvSpPr>
-          <p:cNvPr id="3" name="Text 1"/>
-          <p:cNvSpPr/>
-          <p:nvPr/>
-        </p:nvSpPr>
-        <p:spPr>
-          <a:xfrm>
-            <a:off x="548640" y="822960"/>
-            <a:ext cx="10972800" cy="548640"/>
-          </a:xfrm>
-          <a:prstGeom prst="rect">
-            <a:avLst/>
-          </a:prstGeom>
-          <a:noFill/>
-          <a:ln/>
-        </p:spPr>
-        <p:txBody>
-          <a:bodyPr wrap="square" rtlCol="0" anchor="ctr"/>
-          <a:lstStyle/>
-          <a:p>
-            <a:pPr indent="0" marL="0">
-              <a:buNone/>
-            </a:pPr>
-            <a:r>
-              <a:rPr lang="en-US" sz="2400" b="1" dirty="0">
-                <a:solidFill>
-                  <a:srgbClr val="0A2A43"/>
-                </a:solidFill>
-                <a:latin typeface="Cambria" pitchFamily="34" charset="0"/>
-                <a:ea typeface="Cambria" pitchFamily="34" charset="-122"/>
-                <a:cs typeface="Cambria" pitchFamily="34" charset="-120"/>
-              </a:rPr>
-              <a:t>No invented dates — sequenced by what deepens governance first</a:t>
-            </a:r>
-            <a:endParaRPr lang="en-US" sz="2400" dirty="0"/>
-          </a:p>
-        </p:txBody>
-      </p:sp>
-      <p:sp>
-        <p:nvSpPr>
-          <p:cNvPr id="4" name="Text 2"/>
-          <p:cNvSpPr/>
-          <p:nvPr/>
-        </p:nvSpPr>
-        <p:spPr>
-          <a:xfrm>
-            <a:off x="548640" y="1371600"/>
-            <a:ext cx="10972800" cy="365760"/>
-          </a:xfrm>
-          <a:prstGeom prst="rect">
-            <a:avLst/>
-          </a:prstGeom>
-          <a:noFill/>
-          <a:ln/>
-        </p:spPr>
-        <p:txBody>
-          <a:bodyPr wrap="square" rtlCol="0" anchor="ctr"/>
-          <a:lstStyle/>
-          <a:p>
-            <a:pPr indent="0" marL="0">
-              <a:buNone/>
-            </a:pPr>
-            <a:r>
-              <a:rPr lang="en-US" sz="1250" i="1" dirty="0">
-                <a:solidFill>
-                  <a:srgbClr val="6B7280"/>
-                </a:solidFill>
-                <a:latin typeface="Calibri" pitchFamily="34" charset="0"/>
-                <a:ea typeface="Calibri" pitchFamily="34" charset="-122"/>
-                <a:cs typeface="Calibri" pitchFamily="34" charset="-120"/>
-              </a:rPr>
-              <a:t>A single-team roadmap can't credibly commit to a quarter, so this is grouped by sequencing, not promised timing.</a:t>
-            </a:r>
-            <a:endParaRPr lang="en-US" sz="1250" dirty="0"/>
-          </a:p>
-        </p:txBody>
-      </p:sp>
-      <p:sp>
-        <p:nvSpPr>
-          <p:cNvPr id="5" name="Shape 3"/>
-          <p:cNvSpPr/>
-          <p:nvPr/>
-        </p:nvSpPr>
-        <p:spPr>
-          <a:xfrm>
-            <a:off x="457200" y="2011680"/>
-            <a:ext cx="3611880" cy="4160520"/>
-          </a:xfrm>
-          <a:prstGeom prst="roundRect">
-            <a:avLst>
-              <a:gd name="adj" fmla="val 2532"/>
-            </a:avLst>
-          </a:prstGeom>
-          <a:solidFill>
-            <a:srgbClr val="F3F6F8"/>
-          </a:solidFill>
-          <a:ln/>
-        </p:spPr>
-      </p:sp>
-      <p:sp>
-        <p:nvSpPr>
-          <p:cNvPr id="6" name="Shape 4"/>
-          <p:cNvSpPr/>
-          <p:nvPr/>
-        </p:nvSpPr>
-        <p:spPr>
-          <a:xfrm>
-            <a:off x="457200" y="2011680"/>
-            <a:ext cx="3611880" cy="502920"/>
-          </a:xfrm>
-          <a:prstGeom prst="roundRect">
-            <a:avLst>
-              <a:gd name="adj" fmla="val 18182"/>
-            </a:avLst>
-          </a:prstGeom>
-          <a:solidFill>
-            <a:srgbClr val="1A9C94"/>
-          </a:solidFill>
-          <a:ln/>
-        </p:spPr>
-      </p:sp>
-      <p:sp>
-        <p:nvSpPr>
-          <p:cNvPr id="7" name="Shape 5"/>
-          <p:cNvSpPr/>
-          <p:nvPr/>
-        </p:nvSpPr>
-        <p:spPr>
-          <a:xfrm>
-            <a:off x="457200" y="2267712"/>
-            <a:ext cx="3611880" cy="246888"/>
-          </a:xfrm>
-          <a:prstGeom prst="rect">
-            <a:avLst/>
-          </a:prstGeom>
-          <a:solidFill>
-            <a:srgbClr val="1A9C94"/>
-          </a:solidFill>
-          <a:ln/>
-        </p:spPr>
-      </p:sp>
-      <p:sp>
-        <p:nvSpPr>
-          <p:cNvPr id="8" name="Text 6"/>
-          <p:cNvSpPr/>
-          <p:nvPr/>
-        </p:nvSpPr>
-        <p:spPr>
-          <a:xfrm>
-            <a:off x="640080" y="2011680"/>
-            <a:ext cx="3246120" cy="502920"/>
-          </a:xfrm>
-          <a:prstGeom prst="rect">
-            <a:avLst/>
-          </a:prstGeom>
-          <a:noFill/>
-          <a:ln/>
-        </p:spPr>
-        <p:txBody>
-          <a:bodyPr wrap="square" rtlCol="0" anchor="ctr"/>
-          <a:lstStyle/>
-          <a:p>
-            <a:pPr indent="0" marL="0">
-              <a:buNone/>
-            </a:pPr>
-            <a:r>
-              <a:rPr lang="en-US" sz="1150" b="1" dirty="0">
-                <a:solidFill>
-                  <a:srgbClr val="FFFFFF"/>
-                </a:solidFill>
-                <a:latin typeface="Calibri" pitchFamily="34" charset="0"/>
-                <a:ea typeface="Calibri" pitchFamily="34" charset="-122"/>
-                <a:cs typeface="Calibri" pitchFamily="34" charset="-120"/>
-              </a:rPr>
-              <a:t>DELIVERED — MVP, LIVE TODAY</a:t>
-            </a:r>
-            <a:endParaRPr lang="en-US" sz="1150" dirty="0"/>
-          </a:p>
-        </p:txBody>
-      </p:sp>
-      <p:sp>
-        <p:nvSpPr>
-          <p:cNvPr id="9" name="Text 7"/>
-          <p:cNvSpPr/>
-          <p:nvPr/>
-        </p:nvSpPr>
-        <p:spPr>
-          <a:xfrm>
-            <a:off x="658368" y="2697480"/>
-            <a:ext cx="3209544" cy="3246120"/>
-          </a:xfrm>
-          <a:prstGeom prst="rect">
-            <a:avLst/>
-          </a:prstGeom>
-          <a:noFill/>
-          <a:ln/>
-        </p:spPr>
-        <p:txBody>
-          <a:bodyPr wrap="square" rtlCol="0" anchor="ctr"/>
-          <a:lstStyle/>
-          <a:p>
-            <a:pPr marL="177800" indent="-177800">
-              <a:lnSpc>
-                <a:spcPct val="130000"/>
-              </a:lnSpc>
-              <a:spcAft>
-                <a:spcPts val="800"/>
-              </a:spcAft>
-              <a:buSzPct val="100000"/>
-              <a:buChar char="•"/>
-            </a:pPr>
-            <a:r>
-              <a:rPr lang="en-US" sz="1100" dirty="0">
-                <a:solidFill>
-                  <a:srgbClr val="1F2937"/>
-                </a:solidFill>
-                <a:latin typeface="Calibri" pitchFamily="34" charset="0"/>
-                <a:ea typeface="Calibri" pitchFamily="34" charset="-122"/>
-                <a:cs typeface="Calibri" pitchFamily="34" charset="-120"/>
-              </a:rPr>
-              <a:t>Full pipeline, Discovery through Observability</a:t>
-            </a:r>
-            <a:endParaRPr lang="en-US" sz="1100" dirty="0"/>
-          </a:p>
-          <a:p>
-            <a:pPr indent="0" marL="0">
-              <a:lnSpc>
-                <a:spcPct val="130000"/>
-              </a:lnSpc>
-              <a:spcAft>
-                <a:spcPts val="800"/>
-              </a:spcAft>
-              <a:buNone/>
-            </a:pPr>
-            <a:r>
-              <a:rPr lang="en-US" sz="1100" dirty="0">
-                <a:solidFill>
-                  <a:srgbClr val="1F2937"/>
-                </a:solidFill>
-                <a:latin typeface="Calibri" pitchFamily="34" charset="0"/>
-                <a:ea typeface="Calibri" pitchFamily="34" charset="-122"/>
-                <a:cs typeface="Calibri" pitchFamily="34" charset="-120"/>
-              </a:rPr>
-              <a:t>Real runtime governance: kill-switch, audit log, PII redaction</a:t>
-            </a:r>
-            <a:endParaRPr lang="en-US" sz="1100" dirty="0"/>
-          </a:p>
-          <a:p>
-            <a:pPr indent="0" marL="0">
-              <a:lnSpc>
-                <a:spcPct val="130000"/>
-              </a:lnSpc>
-              <a:spcAft>
-                <a:spcPts val="800"/>
-              </a:spcAft>
-              <a:buNone/>
-            </a:pPr>
-            <a:r>
-              <a:rPr lang="en-US" sz="1100" dirty="0">
-                <a:solidFill>
-                  <a:srgbClr val="1F2937"/>
-                </a:solidFill>
-                <a:latin typeface="Calibri" pitchFamily="34" charset="0"/>
-                <a:ea typeface="Calibri" pitchFamily="34" charset="-122"/>
-                <a:cs typeface="Calibri" pitchFamily="34" charset="-120"/>
-              </a:rPr>
-              <a:t>Real multi-tenancy, SSO, AI Gateway with fallback</a:t>
-            </a:r>
-            <a:endParaRPr lang="en-US" sz="1100" dirty="0"/>
-          </a:p>
-          <a:p>
-            <a:pPr indent="0" marL="0">
-              <a:lnSpc>
-                <a:spcPct val="130000"/>
-              </a:lnSpc>
-              <a:spcAft>
-                <a:spcPts val="800"/>
-              </a:spcAft>
-              <a:buNone/>
-            </a:pPr>
-            <a:r>
-              <a:rPr lang="en-US" sz="1100" dirty="0">
-                <a:solidFill>
-                  <a:srgbClr val="1F2937"/>
-                </a:solidFill>
-                <a:latin typeface="Calibri" pitchFamily="34" charset="0"/>
-                <a:ea typeface="Calibri" pitchFamily="34" charset="-122"/>
-                <a:cs typeface="Calibri" pitchFamily="34" charset="-120"/>
-              </a:rPr>
-              <a:t>Preflight-check + reconciliation APIs</a:t>
-            </a:r>
-            <a:endParaRPr lang="en-US" sz="1100" dirty="0"/>
-          </a:p>
-        </p:txBody>
-      </p:sp>
-      <p:sp>
-        <p:nvSpPr>
-          <p:cNvPr id="10" name="Shape 8"/>
-          <p:cNvSpPr/>
-          <p:nvPr/>
-        </p:nvSpPr>
-        <p:spPr>
-          <a:xfrm>
-            <a:off x="4288536" y="2011680"/>
-            <a:ext cx="3611880" cy="4160520"/>
-          </a:xfrm>
-          <a:prstGeom prst="roundRect">
-            <a:avLst>
-              <a:gd name="adj" fmla="val 2532"/>
-            </a:avLst>
-          </a:prstGeom>
-          <a:solidFill>
-            <a:srgbClr val="F3F6F8"/>
-          </a:solidFill>
-          <a:ln/>
-        </p:spPr>
-      </p:sp>
-      <p:sp>
-        <p:nvSpPr>
-          <p:cNvPr id="11" name="Shape 9"/>
-          <p:cNvSpPr/>
-          <p:nvPr/>
-        </p:nvSpPr>
-        <p:spPr>
-          <a:xfrm>
-            <a:off x="4288536" y="2011680"/>
-            <a:ext cx="3611880" cy="502920"/>
-          </a:xfrm>
-          <a:prstGeom prst="roundRect">
-            <a:avLst>
-              <a:gd name="adj" fmla="val 18182"/>
-            </a:avLst>
-          </a:prstGeom>
-          <a:solidFill>
-            <a:srgbClr val="0A2A43"/>
-          </a:solidFill>
-          <a:ln/>
-        </p:spPr>
-      </p:sp>
-      <p:sp>
-        <p:nvSpPr>
-          <p:cNvPr id="12" name="Shape 10"/>
-          <p:cNvSpPr/>
-          <p:nvPr/>
-        </p:nvSpPr>
-        <p:spPr>
-          <a:xfrm>
-            <a:off x="4288536" y="2267712"/>
-            <a:ext cx="3611880" cy="246888"/>
-          </a:xfrm>
-          <a:prstGeom prst="rect">
-            <a:avLst/>
-          </a:prstGeom>
-          <a:solidFill>
-            <a:srgbClr val="0A2A43"/>
-          </a:solidFill>
-          <a:ln/>
-        </p:spPr>
-      </p:sp>
-      <p:sp>
-        <p:nvSpPr>
-          <p:cNvPr id="13" name="Text 11"/>
-          <p:cNvSpPr/>
-          <p:nvPr/>
-        </p:nvSpPr>
-        <p:spPr>
-          <a:xfrm>
-            <a:off x="4471416" y="2011680"/>
-            <a:ext cx="3246120" cy="502920"/>
-          </a:xfrm>
-          <a:prstGeom prst="rect">
-            <a:avLst/>
-          </a:prstGeom>
-          <a:noFill/>
-          <a:ln/>
-        </p:spPr>
-        <p:txBody>
-          <a:bodyPr wrap="square" rtlCol="0" anchor="ctr"/>
-          <a:lstStyle/>
-          <a:p>
-            <a:pPr indent="0" marL="0">
-              <a:buNone/>
-            </a:pPr>
-            <a:r>
-              <a:rPr lang="en-US" sz="1150" b="1" dirty="0">
-                <a:solidFill>
-                  <a:srgbClr val="FFFFFF"/>
-                </a:solidFill>
-                <a:latin typeface="Calibri" pitchFamily="34" charset="0"/>
-                <a:ea typeface="Calibri" pitchFamily="34" charset="-122"/>
-                <a:cs typeface="Calibri" pitchFamily="34" charset="-120"/>
-              </a:rPr>
-              <a:t>NEXT — DEEPENS GOVERNANCE</a:t>
-            </a:r>
-            <a:endParaRPr lang="en-US" sz="1150" dirty="0"/>
-          </a:p>
-        </p:txBody>
-      </p:sp>
-      <p:sp>
-        <p:nvSpPr>
-          <p:cNvPr id="14" name="Text 12"/>
-          <p:cNvSpPr/>
-          <p:nvPr/>
-        </p:nvSpPr>
-        <p:spPr>
-          <a:xfrm>
-            <a:off x="4489704" y="2697480"/>
-            <a:ext cx="3209544" cy="3246120"/>
-          </a:xfrm>
-          <a:prstGeom prst="rect">
-            <a:avLst/>
-          </a:prstGeom>
-          <a:noFill/>
-          <a:ln/>
-        </p:spPr>
-        <p:txBody>
-          <a:bodyPr wrap="square" rtlCol="0" anchor="ctr"/>
-          <a:lstStyle/>
-          <a:p>
-            <a:pPr marL="177800" indent="-177800">
-              <a:lnSpc>
-                <a:spcPct val="130000"/>
-              </a:lnSpc>
-              <a:spcAft>
-                <a:spcPts val="800"/>
-              </a:spcAft>
-              <a:buSzPct val="100000"/>
-              <a:buChar char="•"/>
-            </a:pPr>
-            <a:r>
-              <a:rPr lang="en-US" sz="1100" dirty="0">
-                <a:solidFill>
-                  <a:srgbClr val="1F2937"/>
-                </a:solidFill>
-                <a:latin typeface="Calibri" pitchFamily="34" charset="0"/>
-                <a:ea typeface="Calibri" pitchFamily="34" charset="-122"/>
-                <a:cs typeface="Calibri" pitchFamily="34" charset="-120"/>
-              </a:rPr>
-              <a:t>Governance templates per regulatory regime</a:t>
-            </a:r>
-            <a:endParaRPr lang="en-US" sz="1100" dirty="0"/>
-          </a:p>
-          <a:p>
-            <a:pPr indent="0" marL="0">
-              <a:lnSpc>
-                <a:spcPct val="130000"/>
-              </a:lnSpc>
-              <a:spcAft>
-                <a:spcPts val="800"/>
-              </a:spcAft>
-              <a:buNone/>
-            </a:pPr>
-            <a:r>
-              <a:rPr lang="en-US" sz="1100" dirty="0">
-                <a:solidFill>
-                  <a:srgbClr val="1F2937"/>
-                </a:solidFill>
-                <a:latin typeface="Calibri" pitchFamily="34" charset="0"/>
-                <a:ea typeface="Calibri" pitchFamily="34" charset="-122"/>
-                <a:cs typeface="Calibri" pitchFamily="34" charset="-120"/>
-              </a:rPr>
-              <a:t>Configurable PII patterns per org/region</a:t>
-            </a:r>
-            <a:endParaRPr lang="en-US" sz="1100" dirty="0"/>
-          </a:p>
-          <a:p>
-            <a:pPr indent="0" marL="0">
-              <a:lnSpc>
-                <a:spcPct val="130000"/>
-              </a:lnSpc>
-              <a:spcAft>
-                <a:spcPts val="800"/>
-              </a:spcAft>
-              <a:buNone/>
-            </a:pPr>
-            <a:r>
-              <a:rPr lang="en-US" sz="1100" dirty="0">
-                <a:solidFill>
-                  <a:srgbClr val="1F2937"/>
-                </a:solidFill>
-                <a:latin typeface="Calibri" pitchFamily="34" charset="0"/>
-                <a:ea typeface="Calibri" pitchFamily="34" charset="-122"/>
-                <a:cs typeface="Calibri" pitchFamily="34" charset="-120"/>
-              </a:rPr>
-              <a:t>Regulatory citation mapping</a:t>
-            </a:r>
-            <a:endParaRPr lang="en-US" sz="1100" dirty="0"/>
-          </a:p>
-          <a:p>
-            <a:pPr indent="0" marL="0">
-              <a:lnSpc>
-                <a:spcPct val="130000"/>
-              </a:lnSpc>
-              <a:spcAft>
-                <a:spcPts val="800"/>
-              </a:spcAft>
-              <a:buNone/>
-            </a:pPr>
-            <a:r>
-              <a:rPr lang="en-US" sz="1100" dirty="0">
-                <a:solidFill>
-                  <a:srgbClr val="1F2937"/>
-                </a:solidFill>
-                <a:latin typeface="Calibri" pitchFamily="34" charset="0"/>
-                <a:ea typeface="Calibri" pitchFamily="34" charset="-122"/>
-                <a:cs typeface="Calibri" pitchFamily="34" charset="-120"/>
-              </a:rPr>
-              <a:t>Incident workflow tied to the kill-switch</a:t>
-            </a:r>
-            <a:endParaRPr lang="en-US" sz="1100" dirty="0"/>
-          </a:p>
-          <a:p>
-            <a:pPr indent="0" marL="0">
-              <a:lnSpc>
-                <a:spcPct val="130000"/>
-              </a:lnSpc>
-              <a:spcAft>
-                <a:spcPts val="800"/>
-              </a:spcAft>
-              <a:buNone/>
-            </a:pPr>
-            <a:r>
-              <a:rPr lang="en-US" sz="1100" dirty="0">
-                <a:solidFill>
-                  <a:srgbClr val="1F2937"/>
-                </a:solidFill>
-                <a:latin typeface="Calibri" pitchFamily="34" charset="0"/>
-                <a:ea typeface="Calibri" pitchFamily="34" charset="-122"/>
-                <a:cs typeface="Calibri" pitchFamily="34" charset="-120"/>
-              </a:rPr>
-              <a:t>Aggregate portfolio risk rollup</a:t>
-            </a:r>
-            <a:endParaRPr lang="en-US" sz="1100" dirty="0"/>
-          </a:p>
-        </p:txBody>
-      </p:sp>
-      <p:sp>
-        <p:nvSpPr>
-          <p:cNvPr id="15" name="Shape 13"/>
-          <p:cNvSpPr/>
-          <p:nvPr/>
-        </p:nvSpPr>
-        <p:spPr>
-          <a:xfrm>
-            <a:off x="8119872" y="2011680"/>
-            <a:ext cx="3611880" cy="4160520"/>
-          </a:xfrm>
-          <a:prstGeom prst="roundRect">
-            <a:avLst>
-              <a:gd name="adj" fmla="val 2532"/>
-            </a:avLst>
-          </a:prstGeom>
-          <a:solidFill>
-            <a:srgbClr val="F3F6F8"/>
-          </a:solidFill>
-          <a:ln/>
-        </p:spPr>
-      </p:sp>
-      <p:sp>
-        <p:nvSpPr>
-          <p:cNvPr id="16" name="Shape 14"/>
-          <p:cNvSpPr/>
-          <p:nvPr/>
-        </p:nvSpPr>
-        <p:spPr>
-          <a:xfrm>
-            <a:off x="8119872" y="2011680"/>
-            <a:ext cx="3611880" cy="502920"/>
-          </a:xfrm>
-          <a:prstGeom prst="roundRect">
-            <a:avLst>
-              <a:gd name="adj" fmla="val 18182"/>
-            </a:avLst>
-          </a:prstGeom>
-          <a:solidFill>
-            <a:srgbClr val="6B7280"/>
-          </a:solidFill>
-          <a:ln/>
-        </p:spPr>
-      </p:sp>
-      <p:sp>
-        <p:nvSpPr>
-          <p:cNvPr id="17" name="Shape 15"/>
-          <p:cNvSpPr/>
-          <p:nvPr/>
-        </p:nvSpPr>
-        <p:spPr>
-          <a:xfrm>
-            <a:off x="8119872" y="2267712"/>
-            <a:ext cx="3611880" cy="246888"/>
-          </a:xfrm>
-          <a:prstGeom prst="rect">
-            <a:avLst/>
-          </a:prstGeom>
-          <a:solidFill>
-            <a:srgbClr val="6B7280"/>
-          </a:solidFill>
-          <a:ln/>
-        </p:spPr>
-      </p:sp>
-      <p:sp>
-        <p:nvSpPr>
-          <p:cNvPr id="18" name="Text 16"/>
-          <p:cNvSpPr/>
-          <p:nvPr/>
-        </p:nvSpPr>
-        <p:spPr>
-          <a:xfrm>
-            <a:off x="8302752" y="2011680"/>
-            <a:ext cx="3246120" cy="502920"/>
-          </a:xfrm>
-          <a:prstGeom prst="rect">
-            <a:avLst/>
-          </a:prstGeom>
-          <a:noFill/>
-          <a:ln/>
-        </p:spPr>
-        <p:txBody>
-          <a:bodyPr wrap="square" rtlCol="0" anchor="ctr"/>
-          <a:lstStyle/>
-          <a:p>
-            <a:pPr indent="0" marL="0">
-              <a:buNone/>
-            </a:pPr>
-            <a:r>
-              <a:rPr lang="en-US" sz="1150" b="1" dirty="0">
-                <a:solidFill>
-                  <a:srgbClr val="FFFFFF"/>
-                </a:solidFill>
-                <a:latin typeface="Calibri" pitchFamily="34" charset="0"/>
-                <a:ea typeface="Calibri" pitchFamily="34" charset="-122"/>
-                <a:cs typeface="Calibri" pitchFamily="34" charset="-120"/>
-              </a:rPr>
-              <a:t>LATER &amp; HARDENING</a:t>
-            </a:r>
-            <a:endParaRPr lang="en-US" sz="1150" dirty="0"/>
-          </a:p>
-        </p:txBody>
-      </p:sp>
-      <p:sp>
-        <p:nvSpPr>
-          <p:cNvPr id="19" name="Text 17"/>
-          <p:cNvSpPr/>
-          <p:nvPr/>
-        </p:nvSpPr>
-        <p:spPr>
-          <a:xfrm>
-            <a:off x="8321040" y="2697480"/>
-            <a:ext cx="3209544" cy="3246120"/>
-          </a:xfrm>
-          <a:prstGeom prst="rect">
-            <a:avLst/>
-          </a:prstGeom>
-          <a:noFill/>
-          <a:ln/>
-        </p:spPr>
-        <p:txBody>
-          <a:bodyPr wrap="square" rtlCol="0" anchor="ctr"/>
-          <a:lstStyle/>
-          <a:p>
-            <a:pPr marL="177800" indent="-177800">
-              <a:lnSpc>
-                <a:spcPct val="130000"/>
-              </a:lnSpc>
-              <a:spcAft>
-                <a:spcPts val="800"/>
-              </a:spcAft>
-              <a:buSzPct val="100000"/>
-              <a:buChar char="•"/>
-            </a:pPr>
-            <a:r>
-              <a:rPr lang="en-US" sz="1100" dirty="0">
-                <a:solidFill>
-                  <a:srgbClr val="1F2937"/>
-                </a:solidFill>
-                <a:latin typeface="Calibri" pitchFamily="34" charset="0"/>
-                <a:ea typeface="Calibri" pitchFamily="34" charset="-122"/>
-                <a:cs typeface="Calibri" pitchFamily="34" charset="-120"/>
-              </a:rPr>
-              <a:t>Intake &amp; reference architecture templates</a:t>
-            </a:r>
-            <a:endParaRPr lang="en-US" sz="1100" dirty="0"/>
-          </a:p>
-          <a:p>
-            <a:pPr indent="0" marL="0">
-              <a:lnSpc>
-                <a:spcPct val="130000"/>
-              </a:lnSpc>
-              <a:spcAft>
-                <a:spcPts val="800"/>
-              </a:spcAft>
-              <a:buNone/>
-            </a:pPr>
-            <a:r>
-              <a:rPr lang="en-US" sz="1100" dirty="0">
-                <a:solidFill>
-                  <a:srgbClr val="1F2937"/>
-                </a:solidFill>
-                <a:latin typeface="Calibri" pitchFamily="34" charset="0"/>
-                <a:ea typeface="Calibri" pitchFamily="34" charset="-122"/>
-                <a:cs typeface="Calibri" pitchFamily="34" charset="-120"/>
-              </a:rPr>
-              <a:t>Vendor/model blast-radius reverse lookup</a:t>
-            </a:r>
-            <a:endParaRPr lang="en-US" sz="1100" dirty="0"/>
-          </a:p>
-          <a:p>
-            <a:pPr indent="0" marL="0">
-              <a:lnSpc>
-                <a:spcPct val="130000"/>
-              </a:lnSpc>
-              <a:spcAft>
-                <a:spcPts val="800"/>
-              </a:spcAft>
-              <a:buNone/>
-            </a:pPr>
-            <a:r>
-              <a:rPr lang="en-US" sz="1100" dirty="0">
-                <a:solidFill>
-                  <a:srgbClr val="1F2937"/>
-                </a:solidFill>
-                <a:latin typeface="Calibri" pitchFamily="34" charset="0"/>
-                <a:ea typeface="Calibri" pitchFamily="34" charset="-122"/>
-                <a:cs typeface="Calibri" pitchFamily="34" charset="-120"/>
-              </a:rPr>
-              <a:t>Configurable approval workflows per org</a:t>
-            </a:r>
-            <a:endParaRPr lang="en-US" sz="1100" dirty="0"/>
-          </a:p>
-          <a:p>
-            <a:pPr indent="0" marL="0">
-              <a:lnSpc>
-                <a:spcPct val="130000"/>
-              </a:lnSpc>
-              <a:spcAft>
-                <a:spcPts val="800"/>
-              </a:spcAft>
-              <a:buNone/>
-            </a:pPr>
-            <a:r>
-              <a:rPr lang="en-US" sz="1100" dirty="0">
-                <a:solidFill>
-                  <a:srgbClr val="1F2937"/>
-                </a:solidFill>
-                <a:latin typeface="Calibri" pitchFamily="34" charset="0"/>
-                <a:ea typeface="Calibri" pitchFamily="34" charset="-122"/>
-                <a:cs typeface="Calibri" pitchFamily="34" charset="-120"/>
-              </a:rPr>
-              <a:t>Broader test coverage, accessibility audit, SCIM, per-tenant branding</a:t>
-            </a:r>
-            <a:endParaRPr lang="en-US" sz="1100" dirty="0"/>
-          </a:p>
-        </p:txBody>
-      </p:sp>
-      <p:sp>
-        <p:nvSpPr>
-          <p:cNvPr id="20" name="Text 18"/>
-          <p:cNvSpPr/>
-          <p:nvPr/>
-        </p:nvSpPr>
-        <p:spPr>
-          <a:xfrm>
-            <a:off x="548640" y="6492240"/>
-            <a:ext cx="5486400" cy="274320"/>
-          </a:xfrm>
-          <a:prstGeom prst="rect">
-            <a:avLst/>
-          </a:prstGeom>
-          <a:noFill/>
-          <a:ln/>
-        </p:spPr>
-        <p:txBody>
-          <a:bodyPr wrap="square" rtlCol="0" anchor="ctr"/>
-          <a:lstStyle/>
-          <a:p>
-            <a:pPr indent="0" marL="0">
-              <a:buNone/>
-            </a:pPr>
-            <a:r>
-              <a:rPr lang="en-US" sz="1000" dirty="0">
-                <a:solidFill>
-                  <a:srgbClr val="6B7280"/>
-                </a:solidFill>
-                <a:latin typeface="Calibri" pitchFamily="34" charset="0"/>
-                <a:ea typeface="Calibri" pitchFamily="34" charset="-122"/>
-                <a:cs typeface="Calibri" pitchFamily="34" charset="-120"/>
-              </a:rPr>
-              <a:t>EGPA — Enterprise Governance Platform for AI</a:t>
-            </a:r>
-            <a:endParaRPr lang="en-US" sz="1000" dirty="0"/>
-          </a:p>
-        </p:txBody>
-      </p:sp>
-      <p:sp>
-        <p:nvSpPr>
-          <p:cNvPr id="21" name="Text 19"/>
-          <p:cNvSpPr/>
-          <p:nvPr/>
-        </p:nvSpPr>
-        <p:spPr>
-          <a:xfrm>
-            <a:off x="11521440" y="6492240"/>
-            <a:ext cx="548640" cy="274320"/>
-          </a:xfrm>
-          <a:prstGeom prst="rect">
-            <a:avLst/>
-          </a:prstGeom>
-          <a:noFill/>
-          <a:ln/>
-        </p:spPr>
-        <p:txBody>
-          <a:bodyPr wrap="square" rtlCol="0" anchor="ctr"/>
-          <a:lstStyle/>
-          <a:p>
-            <a:pPr algn="r" indent="0" marL="0">
-              <a:buNone/>
-            </a:pPr>
-            <a:r>
-              <a:rPr lang="en-US" sz="1000" dirty="0">
-                <a:solidFill>
-                  <a:srgbClr val="6B7280"/>
-                </a:solidFill>
-                <a:latin typeface="Calibri" pitchFamily="34" charset="0"/>
-                <a:ea typeface="Calibri" pitchFamily="34" charset="-122"/>
-                <a:cs typeface="Calibri" pitchFamily="34" charset="-120"/>
-              </a:rPr>
-              <a:t>16</a:t>
-            </a:r>
-            <a:endParaRPr lang="en-US" sz="1000" dirty="0"/>
-          </a:p>
-        </p:txBody>
-      </p:sp>
-    </p:spTree>
-  </p:cSld>
-  <p:clrMapOvr>
-    <a:masterClrMapping/>
-  </p:clrMapOvr>
-</p:sld>
-</file>
-
-<file path=ppt/slides/slide18.xml><?xml version="1.0" encoding="utf-8"?>
-<p:sld xmlns:a="http://schemas.openxmlformats.org/drawingml/2006/main" xmlns:r="http://schemas.openxmlformats.org/officeDocument/2006/relationships" xmlns:p="http://schemas.openxmlformats.org/presentationml/2006/main">
-  <p:cSld name="Slide 18">
     <p:bg>
       <p:bgPr>
         <a:solidFill>
@@ -12397,7 +11502,7 @@
         <p:spPr>
           <a:xfrm>
             <a:off x="457200" y="548640"/>
-            <a:ext cx="10972800" cy="502920"/>
+            <a:ext cx="7315200" cy="502920"/>
           </a:xfrm>
           <a:prstGeom prst="rect">
             <a:avLst/>
@@ -12424,6 +11529,67 @@
               <a:t>Options and trade-offs</a:t>
             </a:r>
             <a:endParaRPr lang="en-US" sz="2400" dirty="0"/>
+          </a:p>
+        </p:txBody>
+      </p:sp>
+      <p:sp>
+        <p:nvSpPr>
+          <p:cNvPr id="4" name="Shape 2"/>
+          <p:cNvSpPr/>
+          <p:nvPr/>
+        </p:nvSpPr>
+        <p:spPr>
+          <a:xfrm>
+            <a:off x="8654796" y="950976"/>
+            <a:ext cx="1737360" cy="274320"/>
+          </a:xfrm>
+          <a:prstGeom prst="roundRect">
+            <a:avLst>
+              <a:gd name="adj" fmla="val 50000"/>
+            </a:avLst>
+          </a:prstGeom>
+          <a:solidFill>
+            <a:srgbClr val="1A9C94"/>
+          </a:solidFill>
+          <a:ln/>
+        </p:spPr>
+      </p:sp>
+      <p:sp>
+        <p:nvSpPr>
+          <p:cNvPr id="5" name="Text 3"/>
+          <p:cNvSpPr/>
+          <p:nvPr/>
+        </p:nvSpPr>
+        <p:spPr>
+          <a:xfrm>
+            <a:off x="8654796" y="950976"/>
+            <a:ext cx="1737360" cy="274320"/>
+          </a:xfrm>
+          <a:prstGeom prst="rect">
+            <a:avLst/>
+          </a:prstGeom>
+          <a:noFill/>
+          <a:ln/>
+        </p:spPr>
+        <p:txBody>
+          <a:bodyPr wrap="square" rtlCol="0" anchor="ctr"/>
+          <a:lstStyle/>
+          <a:p>
+            <a:pPr algn="ctr" indent="0" marL="0">
+              <a:buNone/>
+            </a:pPr>
+            <a:r>
+              <a:rPr lang="en-US" sz="950" b="1" spc="50" kern="0" dirty="0">
+                <a:solidFill>
+                  <a:srgbClr val="FFFFFF"/>
+                </a:solidFill>
+                <a:latin typeface="Calibri" pitchFamily="34" charset="0"/>
+                <a:ea typeface="Calibri" pitchFamily="34" charset="-122"/>
+                <a:cs typeface="Calibri" pitchFamily="34" charset="-120"/>
+              </a:rPr>
+              <a:t>THE PATH WE CHOSE</a:t>
+            </a:r>
+            <a:endParaRPr lang="en-US" sz="950" dirty="0"/>
           </a:p>
         </p:txBody>
       </p:sp>
@@ -12442,7 +11608,7 @@
           </p:nvPr>
         </p:nvGraphicFramePr>
         <p:xfrm>
-          <a:off x="457200" y="1234440"/>
+          <a:off x="457200" y="1298448"/>
           <a:ext cx="11274552" cy="914400"/>
         </p:xfrm>
         <a:graphic>
@@ -12450,12 +11616,12 @@
             <a:tbl>
               <a:tblPr/>
               <a:tblGrid>
-                <a:gridCol w="2103120"/>
-                <a:gridCol w="3054096"/>
-                <a:gridCol w="3054096"/>
-                <a:gridCol w="3063240"/>
+                <a:gridCol w="1828800"/>
+                <a:gridCol w="2514600"/>
+                <a:gridCol w="2514600"/>
+                <a:gridCol w="4416552"/>
               </a:tblGrid>
-              <a:tr h="822960">
+              <a:tr h="457200">
                 <a:tc>
                   <a:txBody>
                     <a:bodyPr/>
@@ -12520,7 +11686,7 @@
                       <a:tailEnd type="none" w="med" len="med"/>
                     </a:lnB>
                     <a:solidFill>
-                      <a:srgbClr val="0A2A43"/>
+                      <a:srgbClr val="071B2E"/>
                     </a:solidFill>
                   </a:tcPr>
                 </a:tc>
@@ -12535,7 +11701,7 @@
                       <a:r>
                         <a:rPr lang="en-US" sz="1050" b="1" dirty="0">
                           <a:solidFill>
-                            <a:srgbClr val="FFFFFF"/>
+                            <a:srgbClr val="9FB0C3"/>
                           </a:solidFill>
                           <a:latin typeface="Calibri" pitchFamily="34" charset="0"/>
                           <a:ea typeface="Calibri" pitchFamily="34" charset="-122"/>
@@ -12588,7 +11754,7 @@
                       <a:tailEnd type="none" w="med" len="med"/>
                     </a:lnB>
                     <a:solidFill>
-                      <a:srgbClr val="0A2A43"/>
+                      <a:srgbClr val="071B2E"/>
                     </a:solidFill>
                   </a:tcPr>
                 </a:tc>
@@ -12603,7 +11769,7 @@
                       <a:r>
                         <a:rPr lang="en-US" sz="1050" b="1" dirty="0">
                           <a:solidFill>
-                            <a:srgbClr val="FFFFFF"/>
+                            <a:srgbClr val="9FB0C3"/>
                           </a:solidFill>
                           <a:latin typeface="Calibri" pitchFamily="34" charset="0"/>
                           <a:ea typeface="Calibri" pitchFamily="34" charset="-122"/>
@@ -12656,7 +11822,7 @@
                       <a:tailEnd type="none" w="med" len="med"/>
                     </a:lnB>
                     <a:solidFill>
-                      <a:srgbClr val="0A2A43"/>
+                      <a:srgbClr val="071B2E"/>
                     </a:solidFill>
                   </a:tcPr>
                 </a:tc>
@@ -12724,12 +11890,12 @@
                       <a:tailEnd type="none" w="med" len="med"/>
                     </a:lnB>
                     <a:solidFill>
-                      <a:srgbClr val="0A2A43"/>
+                      <a:srgbClr val="1A9C94"/>
                     </a:solidFill>
                   </a:tcPr>
                 </a:tc>
               </a:tr>
-              <a:tr h="822960">
+              <a:tr h="685800">
                 <a:tc>
                   <a:txBody>
                     <a:bodyPr/>
@@ -12739,9 +11905,9 @@
                         <a:buNone/>
                       </a:pPr>
                       <a:r>
-                        <a:rPr lang="en-US" sz="1000" b="1" dirty="0">
+                        <a:rPr lang="en-US" sz="1050" b="1" dirty="0">
                           <a:solidFill>
-                            <a:srgbClr val="1F2937"/>
+                            <a:srgbClr val="0A2A43"/>
                           </a:solidFill>
                           <a:latin typeface="Calibri" pitchFamily="34" charset="0"/>
                           <a:ea typeface="Calibri" pitchFamily="34" charset="-122"/>
@@ -12749,7 +11915,7 @@
                         </a:rPr>
                         <a:t>Implementation time</a:t>
                       </a:r>
-                      <a:endParaRPr lang="en-US" sz="1000" dirty="0">
+                      <a:endParaRPr lang="en-US" sz="1050" dirty="0">
                         <a:latin typeface="Calibri" charset="0"/>
                         <a:ea typeface="Calibri" charset="0"/>
                         <a:cs typeface="Calibri" charset="0"/>
@@ -12809,7 +11975,7 @@
                       <a:r>
                         <a:rPr lang="en-US" sz="1000" dirty="0">
                           <a:solidFill>
-                            <a:srgbClr val="1F2937"/>
+                            <a:srgbClr val="6B7280"/>
                           </a:solidFill>
                           <a:latin typeface="Calibri" pitchFamily="34" charset="0"/>
                           <a:ea typeface="Calibri" pitchFamily="34" charset="-122"/>
@@ -12877,7 +12043,7 @@
                       <a:r>
                         <a:rPr lang="en-US" sz="1000" dirty="0">
                           <a:solidFill>
-                            <a:srgbClr val="1F2937"/>
+                            <a:srgbClr val="6B7280"/>
                           </a:solidFill>
                           <a:latin typeface="Calibri" pitchFamily="34" charset="0"/>
                           <a:ea typeface="Calibri" pitchFamily="34" charset="-122"/>
@@ -12886,6 +12052,418 @@
                         <a:t>Medium — vendor config + integration</a:t>
                       </a:r>
                       <a:endParaRPr lang="en-US" sz="1000" dirty="0">
+                        <a:latin typeface="Calibri" charset="0"/>
+                        <a:ea typeface="Calibri" charset="0"/>
+                        <a:cs typeface="Calibri" charset="0"/>
+                      </a:endParaRPr>
+                    </a:p>
+                  </a:txBody>
+                  <a:tcPr marL="91440" marR="91440" marT="45720" marB="45720" anchor="ctr">
+                    <a:lnL w="9525" cap="flat" cmpd="sng" algn="ctr">
+                      <a:solidFill>
+                        <a:srgbClr val="E3E8EC"/>
+                      </a:solidFill>
+                      <a:prstDash val="solid"/>
+                      <a:round/>
+                      <a:headEnd type="none" w="med" len="med"/>
+                      <a:tailEnd type="none" w="med" len="med"/>
+                    </a:lnL>
+                    <a:lnR w="9525" cap="flat" cmpd="sng" algn="ctr">
+                      <a:solidFill>
+                        <a:srgbClr val="E3E8EC"/>
+                      </a:solidFill>
+                      <a:prstDash val="solid"/>
+                      <a:round/>
+                      <a:headEnd type="none" w="med" len="med"/>
+                      <a:tailEnd type="none" w="med" len="med"/>
+                    </a:lnR>
+                    <a:lnT w="9525" cap="flat" cmpd="sng" algn="ctr">
+                      <a:solidFill>
+                        <a:srgbClr val="E3E8EC"/>
+                      </a:solidFill>
+                      <a:prstDash val="solid"/>
+                      <a:round/>
+                      <a:headEnd type="none" w="med" len="med"/>
+                      <a:tailEnd type="none" w="med" len="med"/>
+                    </a:lnT>
+                    <a:lnB w="9525" cap="flat" cmpd="sng" algn="ctr">
+                      <a:solidFill>
+                        <a:srgbClr val="E3E8EC"/>
+                      </a:solidFill>
+                      <a:prstDash val="solid"/>
+                      <a:round/>
+                      <a:headEnd type="none" w="med" len="med"/>
+                      <a:tailEnd type="none" w="med" len="med"/>
+                    </a:lnB>
+                    <a:solidFill>
+                      <a:srgbClr val="FFFFFF"/>
+                    </a:solidFill>
+                  </a:tcPr>
+                </a:tc>
+                <a:tc>
+                  <a:txBody>
+                    <a:bodyPr/>
+                    <a:lstStyle/>
+                    <a:p>
+                      <a:pPr indent="0" marL="0">
+                        <a:buNone/>
+                      </a:pPr>
+                      <a:r>
+                        <a:rPr lang="en-US" sz="1050" dirty="0">
+                          <a:solidFill>
+                            <a:srgbClr val="FFFFFF"/>
+                          </a:solidFill>
+                          <a:latin typeface="Calibri" pitchFamily="34" charset="0"/>
+                          <a:ea typeface="Calibri" pitchFamily="34" charset="-122"/>
+                          <a:cs typeface="Calibri" pitchFamily="34" charset="-120"/>
+                        </a:rPr>
+                        <a:t>Slowest to first value, sequenced on our own terms</a:t>
+                      </a:r>
+                      <a:endParaRPr lang="en-US" sz="1050" dirty="0">
+                        <a:latin typeface="Calibri" charset="0"/>
+                        <a:ea typeface="Calibri" charset="0"/>
+                        <a:cs typeface="Calibri" charset="0"/>
+                      </a:endParaRPr>
+                    </a:p>
+                  </a:txBody>
+                  <a:tcPr marL="91440" marR="91440" marT="45720" marB="45720" anchor="ctr">
+                    <a:lnL w="9525" cap="flat" cmpd="sng" algn="ctr">
+                      <a:solidFill>
+                        <a:srgbClr val="E3E8EC"/>
+                      </a:solidFill>
+                      <a:prstDash val="solid"/>
+                      <a:round/>
+                      <a:headEnd type="none" w="med" len="med"/>
+                      <a:tailEnd type="none" w="med" len="med"/>
+                    </a:lnL>
+                    <a:lnR w="9525" cap="flat" cmpd="sng" algn="ctr">
+                      <a:solidFill>
+                        <a:srgbClr val="E3E8EC"/>
+                      </a:solidFill>
+                      <a:prstDash val="solid"/>
+                      <a:round/>
+                      <a:headEnd type="none" w="med" len="med"/>
+                      <a:tailEnd type="none" w="med" len="med"/>
+                    </a:lnR>
+                    <a:lnT w="9525" cap="flat" cmpd="sng" algn="ctr">
+                      <a:solidFill>
+                        <a:srgbClr val="E3E8EC"/>
+                      </a:solidFill>
+                      <a:prstDash val="solid"/>
+                      <a:round/>
+                      <a:headEnd type="none" w="med" len="med"/>
+                      <a:tailEnd type="none" w="med" len="med"/>
+                    </a:lnT>
+                    <a:lnB w="9525" cap="flat" cmpd="sng" algn="ctr">
+                      <a:solidFill>
+                        <a:srgbClr val="E3E8EC"/>
+                      </a:solidFill>
+                      <a:prstDash val="solid"/>
+                      <a:round/>
+                      <a:headEnd type="none" w="med" len="med"/>
+                      <a:tailEnd type="none" w="med" len="med"/>
+                    </a:lnB>
+                    <a:solidFill>
+                      <a:srgbClr val="0A2A43"/>
+                    </a:solidFill>
+                  </a:tcPr>
+                </a:tc>
+              </a:tr>
+              <a:tr h="685800">
+                <a:tc>
+                  <a:txBody>
+                    <a:bodyPr/>
+                    <a:lstStyle/>
+                    <a:p>
+                      <a:pPr indent="0" marL="0">
+                        <a:buNone/>
+                      </a:pPr>
+                      <a:r>
+                        <a:rPr lang="en-US" sz="1050" b="1" dirty="0">
+                          <a:solidFill>
+                            <a:srgbClr val="0A2A43"/>
+                          </a:solidFill>
+                          <a:latin typeface="Calibri" pitchFamily="34" charset="0"/>
+                          <a:ea typeface="Calibri" pitchFamily="34" charset="-122"/>
+                          <a:cs typeface="Calibri" pitchFamily="34" charset="-120"/>
+                        </a:rPr>
+                        <a:t>Cost profile</a:t>
+                      </a:r>
+                      <a:endParaRPr lang="en-US" sz="1050" dirty="0">
+                        <a:latin typeface="Calibri" charset="0"/>
+                        <a:ea typeface="Calibri" charset="0"/>
+                        <a:cs typeface="Calibri" charset="0"/>
+                      </a:endParaRPr>
+                    </a:p>
+                  </a:txBody>
+                  <a:tcPr marL="91440" marR="91440" marT="45720" marB="45720" anchor="ctr">
+                    <a:lnL w="9525" cap="flat" cmpd="sng" algn="ctr">
+                      <a:solidFill>
+                        <a:srgbClr val="E3E8EC"/>
+                      </a:solidFill>
+                      <a:prstDash val="solid"/>
+                      <a:round/>
+                      <a:headEnd type="none" w="med" len="med"/>
+                      <a:tailEnd type="none" w="med" len="med"/>
+                    </a:lnL>
+                    <a:lnR w="9525" cap="flat" cmpd="sng" algn="ctr">
+                      <a:solidFill>
+                        <a:srgbClr val="E3E8EC"/>
+                      </a:solidFill>
+                      <a:prstDash val="solid"/>
+                      <a:round/>
+                      <a:headEnd type="none" w="med" len="med"/>
+                      <a:tailEnd type="none" w="med" len="med"/>
+                    </a:lnR>
+                    <a:lnT w="9525" cap="flat" cmpd="sng" algn="ctr">
+                      <a:solidFill>
+                        <a:srgbClr val="E3E8EC"/>
+                      </a:solidFill>
+                      <a:prstDash val="solid"/>
+                      <a:round/>
+                      <a:headEnd type="none" w="med" len="med"/>
+                      <a:tailEnd type="none" w="med" len="med"/>
+                    </a:lnT>
+                    <a:lnB w="9525" cap="flat" cmpd="sng" algn="ctr">
+                      <a:solidFill>
+                        <a:srgbClr val="E3E8EC"/>
+                      </a:solidFill>
+                      <a:prstDash val="solid"/>
+                      <a:round/>
+                      <a:headEnd type="none" w="med" len="med"/>
+                      <a:tailEnd type="none" w="med" len="med"/>
+                    </a:lnB>
+                    <a:solidFill>
+                      <a:srgbClr val="F3F6F8"/>
+                    </a:solidFill>
+                  </a:tcPr>
+                </a:tc>
+                <a:tc>
+                  <a:txBody>
+                    <a:bodyPr/>
+                    <a:lstStyle/>
+                    <a:p>
+                      <a:pPr indent="0" marL="0">
+                        <a:buNone/>
+                      </a:pPr>
+                      <a:r>
+                        <a:rPr lang="en-US" sz="1000" dirty="0">
+                          <a:solidFill>
+                            <a:srgbClr val="6B7280"/>
+                          </a:solidFill>
+                          <a:latin typeface="Calibri" pitchFamily="34" charset="0"/>
+                          <a:ea typeface="Calibri" pitchFamily="34" charset="-122"/>
+                          <a:cs typeface="Calibri" pitchFamily="34" charset="-120"/>
+                        </a:rPr>
+                        <a:t>Lowest incremental — licensing sunk</a:t>
+                      </a:r>
+                      <a:endParaRPr lang="en-US" sz="1000" dirty="0">
+                        <a:latin typeface="Calibri" charset="0"/>
+                        <a:ea typeface="Calibri" charset="0"/>
+                        <a:cs typeface="Calibri" charset="0"/>
+                      </a:endParaRPr>
+                    </a:p>
+                  </a:txBody>
+                  <a:tcPr marL="91440" marR="91440" marT="45720" marB="45720" anchor="ctr">
+                    <a:lnL w="9525" cap="flat" cmpd="sng" algn="ctr">
+                      <a:solidFill>
+                        <a:srgbClr val="E3E8EC"/>
+                      </a:solidFill>
+                      <a:prstDash val="solid"/>
+                      <a:round/>
+                      <a:headEnd type="none" w="med" len="med"/>
+                      <a:tailEnd type="none" w="med" len="med"/>
+                    </a:lnL>
+                    <a:lnR w="9525" cap="flat" cmpd="sng" algn="ctr">
+                      <a:solidFill>
+                        <a:srgbClr val="E3E8EC"/>
+                      </a:solidFill>
+                      <a:prstDash val="solid"/>
+                      <a:round/>
+                      <a:headEnd type="none" w="med" len="med"/>
+                      <a:tailEnd type="none" w="med" len="med"/>
+                    </a:lnR>
+                    <a:lnT w="9525" cap="flat" cmpd="sng" algn="ctr">
+                      <a:solidFill>
+                        <a:srgbClr val="E3E8EC"/>
+                      </a:solidFill>
+                      <a:prstDash val="solid"/>
+                      <a:round/>
+                      <a:headEnd type="none" w="med" len="med"/>
+                      <a:tailEnd type="none" w="med" len="med"/>
+                    </a:lnT>
+                    <a:lnB w="9525" cap="flat" cmpd="sng" algn="ctr">
+                      <a:solidFill>
+                        <a:srgbClr val="E3E8EC"/>
+                      </a:solidFill>
+                      <a:prstDash val="solid"/>
+                      <a:round/>
+                      <a:headEnd type="none" w="med" len="med"/>
+                      <a:tailEnd type="none" w="med" len="med"/>
+                    </a:lnB>
+                    <a:solidFill>
+                      <a:srgbClr val="F3F6F8"/>
+                    </a:solidFill>
+                  </a:tcPr>
+                </a:tc>
+                <a:tc>
+                  <a:txBody>
+                    <a:bodyPr/>
+                    <a:lstStyle/>
+                    <a:p>
+                      <a:pPr indent="0" marL="0">
+                        <a:buNone/>
+                      </a:pPr>
+                      <a:r>
+                        <a:rPr lang="en-US" sz="1000" dirty="0">
+                          <a:solidFill>
+                            <a:srgbClr val="6B7280"/>
+                          </a:solidFill>
+                          <a:latin typeface="Calibri" pitchFamily="34" charset="0"/>
+                          <a:ea typeface="Calibri" pitchFamily="34" charset="-122"/>
+                          <a:cs typeface="Calibri" pitchFamily="34" charset="-120"/>
+                        </a:rPr>
+                        <a:t>Recurring license, per-seat/model</a:t>
+                      </a:r>
+                      <a:endParaRPr lang="en-US" sz="1000" dirty="0">
+                        <a:latin typeface="Calibri" charset="0"/>
+                        <a:ea typeface="Calibri" charset="0"/>
+                        <a:cs typeface="Calibri" charset="0"/>
+                      </a:endParaRPr>
+                    </a:p>
+                  </a:txBody>
+                  <a:tcPr marL="91440" marR="91440" marT="45720" marB="45720" anchor="ctr">
+                    <a:lnL w="9525" cap="flat" cmpd="sng" algn="ctr">
+                      <a:solidFill>
+                        <a:srgbClr val="E3E8EC"/>
+                      </a:solidFill>
+                      <a:prstDash val="solid"/>
+                      <a:round/>
+                      <a:headEnd type="none" w="med" len="med"/>
+                      <a:tailEnd type="none" w="med" len="med"/>
+                    </a:lnL>
+                    <a:lnR w="9525" cap="flat" cmpd="sng" algn="ctr">
+                      <a:solidFill>
+                        <a:srgbClr val="E3E8EC"/>
+                      </a:solidFill>
+                      <a:prstDash val="solid"/>
+                      <a:round/>
+                      <a:headEnd type="none" w="med" len="med"/>
+                      <a:tailEnd type="none" w="med" len="med"/>
+                    </a:lnR>
+                    <a:lnT w="9525" cap="flat" cmpd="sng" algn="ctr">
+                      <a:solidFill>
+                        <a:srgbClr val="E3E8EC"/>
+                      </a:solidFill>
+                      <a:prstDash val="solid"/>
+                      <a:round/>
+                      <a:headEnd type="none" w="med" len="med"/>
+                      <a:tailEnd type="none" w="med" len="med"/>
+                    </a:lnT>
+                    <a:lnB w="9525" cap="flat" cmpd="sng" algn="ctr">
+                      <a:solidFill>
+                        <a:srgbClr val="E3E8EC"/>
+                      </a:solidFill>
+                      <a:prstDash val="solid"/>
+                      <a:round/>
+                      <a:headEnd type="none" w="med" len="med"/>
+                      <a:tailEnd type="none" w="med" len="med"/>
+                    </a:lnB>
+                    <a:solidFill>
+                      <a:srgbClr val="F3F6F8"/>
+                    </a:solidFill>
+                  </a:tcPr>
+                </a:tc>
+                <a:tc>
+                  <a:txBody>
+                    <a:bodyPr/>
+                    <a:lstStyle/>
+                    <a:p>
+                      <a:pPr indent="0" marL="0">
+                        <a:buNone/>
+                      </a:pPr>
+                      <a:r>
+                        <a:rPr lang="en-US" sz="1050" dirty="0">
+                          <a:solidFill>
+                            <a:srgbClr val="FFFFFF"/>
+                          </a:solidFill>
+                          <a:latin typeface="Calibri" pitchFamily="34" charset="0"/>
+                          <a:ea typeface="Calibri" pitchFamily="34" charset="-122"/>
+                          <a:cs typeface="Calibri" pitchFamily="34" charset="-120"/>
+                        </a:rPr>
+                        <a:t>Upfront investment, no license, internal ownership</a:t>
+                      </a:r>
+                      <a:endParaRPr lang="en-US" sz="1050" dirty="0">
+                        <a:latin typeface="Calibri" charset="0"/>
+                        <a:ea typeface="Calibri" charset="0"/>
+                        <a:cs typeface="Calibri" charset="0"/>
+                      </a:endParaRPr>
+                    </a:p>
+                  </a:txBody>
+                  <a:tcPr marL="91440" marR="91440" marT="45720" marB="45720" anchor="ctr">
+                    <a:lnL w="9525" cap="flat" cmpd="sng" algn="ctr">
+                      <a:solidFill>
+                        <a:srgbClr val="E3E8EC"/>
+                      </a:solidFill>
+                      <a:prstDash val="solid"/>
+                      <a:round/>
+                      <a:headEnd type="none" w="med" len="med"/>
+                      <a:tailEnd type="none" w="med" len="med"/>
+                    </a:lnL>
+                    <a:lnR w="9525" cap="flat" cmpd="sng" algn="ctr">
+                      <a:solidFill>
+                        <a:srgbClr val="E3E8EC"/>
+                      </a:solidFill>
+                      <a:prstDash val="solid"/>
+                      <a:round/>
+                      <a:headEnd type="none" w="med" len="med"/>
+                      <a:tailEnd type="none" w="med" len="med"/>
+                    </a:lnR>
+                    <a:lnT w="9525" cap="flat" cmpd="sng" algn="ctr">
+                      <a:solidFill>
+                        <a:srgbClr val="E3E8EC"/>
+                      </a:solidFill>
+                      <a:prstDash val="solid"/>
+                      <a:round/>
+                      <a:headEnd type="none" w="med" len="med"/>
+                      <a:tailEnd type="none" w="med" len="med"/>
+                    </a:lnT>
+                    <a:lnB w="9525" cap="flat" cmpd="sng" algn="ctr">
+                      <a:solidFill>
+                        <a:srgbClr val="E3E8EC"/>
+                      </a:solidFill>
+                      <a:prstDash val="solid"/>
+                      <a:round/>
+                      <a:headEnd type="none" w="med" len="med"/>
+                      <a:tailEnd type="none" w="med" len="med"/>
+                    </a:lnB>
+                    <a:solidFill>
+                      <a:srgbClr val="0A2A43"/>
+                    </a:solidFill>
+                  </a:tcPr>
+                </a:tc>
+              </a:tr>
+              <a:tr h="685800">
+                <a:tc>
+                  <a:txBody>
+                    <a:bodyPr/>
+                    <a:lstStyle/>
+                    <a:p>
+                      <a:pPr indent="0" marL="0">
+                        <a:buNone/>
+                      </a:pPr>
+                      <a:r>
+                        <a:rPr lang="en-US" sz="1050" b="1" dirty="0">
+                          <a:solidFill>
+                            <a:srgbClr val="0A2A43"/>
+                          </a:solidFill>
+                          <a:latin typeface="Calibri" pitchFamily="34" charset="0"/>
+                          <a:ea typeface="Calibri" pitchFamily="34" charset="-122"/>
+                          <a:cs typeface="Calibri" pitchFamily="34" charset="-120"/>
+                        </a:rPr>
+                        <a:t>Integration complexity</a:t>
+                      </a:r>
+                      <a:endParaRPr lang="en-US" sz="1050" dirty="0">
                         <a:latin typeface="Calibri" charset="0"/>
                         <a:ea typeface="Calibri" charset="0"/>
                         <a:cs typeface="Calibri" charset="0"/>
@@ -12945,13 +12523,13 @@
                       <a:r>
                         <a:rPr lang="en-US" sz="1000" dirty="0">
                           <a:solidFill>
-                            <a:srgbClr val="1F2937"/>
+                            <a:srgbClr val="6B7280"/>
                           </a:solidFill>
                           <a:latin typeface="Calibri" pitchFamily="34" charset="0"/>
                           <a:ea typeface="Calibri" pitchFamily="34" charset="-122"/>
                           <a:cs typeface="Calibri" pitchFamily="34" charset="-120"/>
                         </a:rPr>
-                        <a:t>Slowest to first value, sequenced on our own terms</a:t>
+                        <a:t>Low, but AI runtime concepts aren't native</a:t>
                       </a:r>
                       <a:endParaRPr lang="en-US" sz="1000" dirty="0">
                         <a:latin typeface="Calibri" charset="0"/>
@@ -13002,8 +12580,6 @@
                     </a:solidFill>
                   </a:tcPr>
                 </a:tc>
-              </a:tr>
-              <a:tr h="822960">
                 <a:tc>
                   <a:txBody>
                     <a:bodyPr/>
@@ -13013,17 +12589,155 @@
                         <a:buNone/>
                       </a:pPr>
                       <a:r>
-                        <a:rPr lang="en-US" sz="1000" b="1" dirty="0">
+                        <a:rPr lang="en-US" sz="1000" dirty="0">
                           <a:solidFill>
-                            <a:srgbClr val="1F2937"/>
+                            <a:srgbClr val="6B7280"/>
                           </a:solidFill>
                           <a:latin typeface="Calibri" pitchFamily="34" charset="0"/>
                           <a:ea typeface="Calibri" pitchFamily="34" charset="-122"/>
                           <a:cs typeface="Calibri" pitchFamily="34" charset="-120"/>
                         </a:rPr>
-                        <a:t>Cost profile</a:t>
+                        <a:t>Medium-high — vendor didn't design for our Gateway</a:t>
                       </a:r>
                       <a:endParaRPr lang="en-US" sz="1000" dirty="0">
+                        <a:latin typeface="Calibri" charset="0"/>
+                        <a:ea typeface="Calibri" charset="0"/>
+                        <a:cs typeface="Calibri" charset="0"/>
+                      </a:endParaRPr>
+                    </a:p>
+                  </a:txBody>
+                  <a:tcPr marL="91440" marR="91440" marT="45720" marB="45720" anchor="ctr">
+                    <a:lnL w="9525" cap="flat" cmpd="sng" algn="ctr">
+                      <a:solidFill>
+                        <a:srgbClr val="E3E8EC"/>
+                      </a:solidFill>
+                      <a:prstDash val="solid"/>
+                      <a:round/>
+                      <a:headEnd type="none" w="med" len="med"/>
+                      <a:tailEnd type="none" w="med" len="med"/>
+                    </a:lnL>
+                    <a:lnR w="9525" cap="flat" cmpd="sng" algn="ctr">
+                      <a:solidFill>
+                        <a:srgbClr val="E3E8EC"/>
+                      </a:solidFill>
+                      <a:prstDash val="solid"/>
+                      <a:round/>
+                      <a:headEnd type="none" w="med" len="med"/>
+                      <a:tailEnd type="none" w="med" len="med"/>
+                    </a:lnR>
+                    <a:lnT w="9525" cap="flat" cmpd="sng" algn="ctr">
+                      <a:solidFill>
+                        <a:srgbClr val="E3E8EC"/>
+                      </a:solidFill>
+                      <a:prstDash val="solid"/>
+                      <a:round/>
+                      <a:headEnd type="none" w="med" len="med"/>
+                      <a:tailEnd type="none" w="med" len="med"/>
+                    </a:lnT>
+                    <a:lnB w="9525" cap="flat" cmpd="sng" algn="ctr">
+                      <a:solidFill>
+                        <a:srgbClr val="E3E8EC"/>
+                      </a:solidFill>
+                      <a:prstDash val="solid"/>
+                      <a:round/>
+                      <a:headEnd type="none" w="med" len="med"/>
+                      <a:tailEnd type="none" w="med" len="med"/>
+                    </a:lnB>
+                    <a:solidFill>
+                      <a:srgbClr val="FFFFFF"/>
+                    </a:solidFill>
+                  </a:tcPr>
+                </a:tc>
+                <a:tc>
+                  <a:txBody>
+                    <a:bodyPr/>
+                    <a:lstStyle/>
+                    <a:p>
+                      <a:pPr indent="0" marL="0">
+                        <a:buNone/>
+                      </a:pPr>
+                      <a:r>
+                        <a:rPr lang="en-US" sz="1050" dirty="0">
+                          <a:solidFill>
+                            <a:srgbClr val="FFFFFF"/>
+                          </a:solidFill>
+                          <a:latin typeface="Calibri" pitchFamily="34" charset="0"/>
+                          <a:ea typeface="Calibri" pitchFamily="34" charset="-122"/>
+                          <a:cs typeface="Calibri" pitchFamily="34" charset="-120"/>
+                        </a:rPr>
+                        <a:t>Low, by construction — built around our own stack</a:t>
+                      </a:r>
+                      <a:endParaRPr lang="en-US" sz="1050" dirty="0">
+                        <a:latin typeface="Calibri" charset="0"/>
+                        <a:ea typeface="Calibri" charset="0"/>
+                        <a:cs typeface="Calibri" charset="0"/>
+                      </a:endParaRPr>
+                    </a:p>
+                  </a:txBody>
+                  <a:tcPr marL="91440" marR="91440" marT="45720" marB="45720" anchor="ctr">
+                    <a:lnL w="9525" cap="flat" cmpd="sng" algn="ctr">
+                      <a:solidFill>
+                        <a:srgbClr val="E3E8EC"/>
+                      </a:solidFill>
+                      <a:prstDash val="solid"/>
+                      <a:round/>
+                      <a:headEnd type="none" w="med" len="med"/>
+                      <a:tailEnd type="none" w="med" len="med"/>
+                    </a:lnL>
+                    <a:lnR w="9525" cap="flat" cmpd="sng" algn="ctr">
+                      <a:solidFill>
+                        <a:srgbClr val="E3E8EC"/>
+                      </a:solidFill>
+                      <a:prstDash val="solid"/>
+                      <a:round/>
+                      <a:headEnd type="none" w="med" len="med"/>
+                      <a:tailEnd type="none" w="med" len="med"/>
+                    </a:lnR>
+                    <a:lnT w="9525" cap="flat" cmpd="sng" algn="ctr">
+                      <a:solidFill>
+                        <a:srgbClr val="E3E8EC"/>
+                      </a:solidFill>
+                      <a:prstDash val="solid"/>
+                      <a:round/>
+                      <a:headEnd type="none" w="med" len="med"/>
+                      <a:tailEnd type="none" w="med" len="med"/>
+                    </a:lnT>
+                    <a:lnB w="9525" cap="flat" cmpd="sng" algn="ctr">
+                      <a:solidFill>
+                        <a:srgbClr val="E3E8EC"/>
+                      </a:solidFill>
+                      <a:prstDash val="solid"/>
+                      <a:round/>
+                      <a:headEnd type="none" w="med" len="med"/>
+                      <a:tailEnd type="none" w="med" len="med"/>
+                    </a:lnB>
+                    <a:solidFill>
+                      <a:srgbClr val="0A2A43"/>
+                    </a:solidFill>
+                  </a:tcPr>
+                </a:tc>
+              </a:tr>
+              <a:tr h="685800">
+                <a:tc>
+                  <a:txBody>
+                    <a:bodyPr/>
+                    <a:lstStyle/>
+                    <a:p>
+                      <a:pPr indent="0" marL="0">
+                        <a:buNone/>
+                      </a:pPr>
+                      <a:r>
+                        <a:rPr lang="en-US" sz="1050" b="1" dirty="0">
+                          <a:solidFill>
+                            <a:srgbClr val="0A2A43"/>
+                          </a:solidFill>
+                          <a:latin typeface="Calibri" pitchFamily="34" charset="0"/>
+                          <a:ea typeface="Calibri" pitchFamily="34" charset="-122"/>
+                          <a:cs typeface="Calibri" pitchFamily="34" charset="-120"/>
+                        </a:rPr>
+                        <a:t>Flexibility</a:t>
+                      </a:r>
+                      <a:endParaRPr lang="en-US" sz="1050" dirty="0">
                         <a:latin typeface="Calibri" charset="0"/>
                         <a:ea typeface="Calibri" charset="0"/>
                         <a:cs typeface="Calibri" charset="0"/>
@@ -13083,13 +12797,13 @@
                       <a:r>
                         <a:rPr lang="en-US" sz="1000" dirty="0">
                           <a:solidFill>
-                            <a:srgbClr val="1F2937"/>
+                            <a:srgbClr val="6B7280"/>
                           </a:solidFill>
                           <a:latin typeface="Calibri" pitchFamily="34" charset="0"/>
                           <a:ea typeface="Calibri" pitchFamily="34" charset="-122"/>
                           <a:cs typeface="Calibri" pitchFamily="34" charset="-120"/>
                         </a:rPr>
-                        <a:t>Lowest incremental — licensing sunk</a:t>
+                        <a:t>Constrained to the host platform</a:t>
                       </a:r>
                       <a:endParaRPr lang="en-US" sz="1000" dirty="0">
                         <a:latin typeface="Calibri" charset="0"/>
@@ -13151,15 +12865,427 @@
                       <a:r>
                         <a:rPr lang="en-US" sz="1000" dirty="0">
                           <a:solidFill>
-                            <a:srgbClr val="1F2937"/>
+                            <a:srgbClr val="6B7280"/>
                           </a:solidFill>
                           <a:latin typeface="Calibri" pitchFamily="34" charset="0"/>
                           <a:ea typeface="Calibri" pitchFamily="34" charset="-122"/>
                           <a:cs typeface="Calibri" pitchFamily="34" charset="-120"/>
                         </a:rPr>
-                        <a:t>Recurring license, per-seat/model</a:t>
+                        <a:t>Configurable, but core logic is vendor-owned</a:t>
                       </a:r>
                       <a:endParaRPr lang="en-US" sz="1000" dirty="0">
+                        <a:latin typeface="Calibri" charset="0"/>
+                        <a:ea typeface="Calibri" charset="0"/>
+                        <a:cs typeface="Calibri" charset="0"/>
+                      </a:endParaRPr>
+                    </a:p>
+                  </a:txBody>
+                  <a:tcPr marL="91440" marR="91440" marT="45720" marB="45720" anchor="ctr">
+                    <a:lnL w="9525" cap="flat" cmpd="sng" algn="ctr">
+                      <a:solidFill>
+                        <a:srgbClr val="E3E8EC"/>
+                      </a:solidFill>
+                      <a:prstDash val="solid"/>
+                      <a:round/>
+                      <a:headEnd type="none" w="med" len="med"/>
+                      <a:tailEnd type="none" w="med" len="med"/>
+                    </a:lnL>
+                    <a:lnR w="9525" cap="flat" cmpd="sng" algn="ctr">
+                      <a:solidFill>
+                        <a:srgbClr val="E3E8EC"/>
+                      </a:solidFill>
+                      <a:prstDash val="solid"/>
+                      <a:round/>
+                      <a:headEnd type="none" w="med" len="med"/>
+                      <a:tailEnd type="none" w="med" len="med"/>
+                    </a:lnR>
+                    <a:lnT w="9525" cap="flat" cmpd="sng" algn="ctr">
+                      <a:solidFill>
+                        <a:srgbClr val="E3E8EC"/>
+                      </a:solidFill>
+                      <a:prstDash val="solid"/>
+                      <a:round/>
+                      <a:headEnd type="none" w="med" len="med"/>
+                      <a:tailEnd type="none" w="med" len="med"/>
+                    </a:lnT>
+                    <a:lnB w="9525" cap="flat" cmpd="sng" algn="ctr">
+                      <a:solidFill>
+                        <a:srgbClr val="E3E8EC"/>
+                      </a:solidFill>
+                      <a:prstDash val="solid"/>
+                      <a:round/>
+                      <a:headEnd type="none" w="med" len="med"/>
+                      <a:tailEnd type="none" w="med" len="med"/>
+                    </a:lnB>
+                    <a:solidFill>
+                      <a:srgbClr val="F3F6F8"/>
+                    </a:solidFill>
+                  </a:tcPr>
+                </a:tc>
+                <a:tc>
+                  <a:txBody>
+                    <a:bodyPr/>
+                    <a:lstStyle/>
+                    <a:p>
+                      <a:pPr indent="0" marL="0">
+                        <a:buNone/>
+                      </a:pPr>
+                      <a:r>
+                        <a:rPr lang="en-US" sz="1050" dirty="0">
+                          <a:solidFill>
+                            <a:srgbClr val="FFFFFF"/>
+                          </a:solidFill>
+                          <a:latin typeface="Calibri" pitchFamily="34" charset="0"/>
+                          <a:ea typeface="Calibri" pitchFamily="34" charset="-122"/>
+                          <a:cs typeface="Calibri" pitchFamily="34" charset="-120"/>
+                        </a:rPr>
+                        <a:t>Highest — shaped exactly to the org</a:t>
+                      </a:r>
+                      <a:endParaRPr lang="en-US" sz="1050" dirty="0">
+                        <a:latin typeface="Calibri" charset="0"/>
+                        <a:ea typeface="Calibri" charset="0"/>
+                        <a:cs typeface="Calibri" charset="0"/>
+                      </a:endParaRPr>
+                    </a:p>
+                  </a:txBody>
+                  <a:tcPr marL="91440" marR="91440" marT="45720" marB="45720" anchor="ctr">
+                    <a:lnL w="9525" cap="flat" cmpd="sng" algn="ctr">
+                      <a:solidFill>
+                        <a:srgbClr val="E3E8EC"/>
+                      </a:solidFill>
+                      <a:prstDash val="solid"/>
+                      <a:round/>
+                      <a:headEnd type="none" w="med" len="med"/>
+                      <a:tailEnd type="none" w="med" len="med"/>
+                    </a:lnL>
+                    <a:lnR w="9525" cap="flat" cmpd="sng" algn="ctr">
+                      <a:solidFill>
+                        <a:srgbClr val="E3E8EC"/>
+                      </a:solidFill>
+                      <a:prstDash val="solid"/>
+                      <a:round/>
+                      <a:headEnd type="none" w="med" len="med"/>
+                      <a:tailEnd type="none" w="med" len="med"/>
+                    </a:lnR>
+                    <a:lnT w="9525" cap="flat" cmpd="sng" algn="ctr">
+                      <a:solidFill>
+                        <a:srgbClr val="E3E8EC"/>
+                      </a:solidFill>
+                      <a:prstDash val="solid"/>
+                      <a:round/>
+                      <a:headEnd type="none" w="med" len="med"/>
+                      <a:tailEnd type="none" w="med" len="med"/>
+                    </a:lnT>
+                    <a:lnB w="9525" cap="flat" cmpd="sng" algn="ctr">
+                      <a:solidFill>
+                        <a:srgbClr val="E3E8EC"/>
+                      </a:solidFill>
+                      <a:prstDash val="solid"/>
+                      <a:round/>
+                      <a:headEnd type="none" w="med" len="med"/>
+                      <a:tailEnd type="none" w="med" len="med"/>
+                    </a:lnB>
+                    <a:solidFill>
+                      <a:srgbClr val="0A2A43"/>
+                    </a:solidFill>
+                  </a:tcPr>
+                </a:tc>
+              </a:tr>
+              <a:tr h="685800">
+                <a:tc>
+                  <a:txBody>
+                    <a:bodyPr/>
+                    <a:lstStyle/>
+                    <a:p>
+                      <a:pPr indent="0" marL="0">
+                        <a:buNone/>
+                      </a:pPr>
+                      <a:r>
+                        <a:rPr lang="en-US" sz="1050" b="1" dirty="0">
+                          <a:solidFill>
+                            <a:srgbClr val="0A2A43"/>
+                          </a:solidFill>
+                          <a:latin typeface="Calibri" pitchFamily="34" charset="0"/>
+                          <a:ea typeface="Calibri" pitchFamily="34" charset="-122"/>
+                          <a:cs typeface="Calibri" pitchFamily="34" charset="-120"/>
+                        </a:rPr>
+                        <a:t>Regulatory control</a:t>
+                      </a:r>
+                      <a:endParaRPr lang="en-US" sz="1050" dirty="0">
+                        <a:latin typeface="Calibri" charset="0"/>
+                        <a:ea typeface="Calibri" charset="0"/>
+                        <a:cs typeface="Calibri" charset="0"/>
+                      </a:endParaRPr>
+                    </a:p>
+                  </a:txBody>
+                  <a:tcPr marL="91440" marR="91440" marT="45720" marB="45720" anchor="ctr">
+                    <a:lnL w="9525" cap="flat" cmpd="sng" algn="ctr">
+                      <a:solidFill>
+                        <a:srgbClr val="E3E8EC"/>
+                      </a:solidFill>
+                      <a:prstDash val="solid"/>
+                      <a:round/>
+                      <a:headEnd type="none" w="med" len="med"/>
+                      <a:tailEnd type="none" w="med" len="med"/>
+                    </a:lnL>
+                    <a:lnR w="9525" cap="flat" cmpd="sng" algn="ctr">
+                      <a:solidFill>
+                        <a:srgbClr val="E3E8EC"/>
+                      </a:solidFill>
+                      <a:prstDash val="solid"/>
+                      <a:round/>
+                      <a:headEnd type="none" w="med" len="med"/>
+                      <a:tailEnd type="none" w="med" len="med"/>
+                    </a:lnR>
+                    <a:lnT w="9525" cap="flat" cmpd="sng" algn="ctr">
+                      <a:solidFill>
+                        <a:srgbClr val="E3E8EC"/>
+                      </a:solidFill>
+                      <a:prstDash val="solid"/>
+                      <a:round/>
+                      <a:headEnd type="none" w="med" len="med"/>
+                      <a:tailEnd type="none" w="med" len="med"/>
+                    </a:lnT>
+                    <a:lnB w="9525" cap="flat" cmpd="sng" algn="ctr">
+                      <a:solidFill>
+                        <a:srgbClr val="E3E8EC"/>
+                      </a:solidFill>
+                      <a:prstDash val="solid"/>
+                      <a:round/>
+                      <a:headEnd type="none" w="med" len="med"/>
+                      <a:tailEnd type="none" w="med" len="med"/>
+                    </a:lnB>
+                    <a:solidFill>
+                      <a:srgbClr val="FFFFFF"/>
+                    </a:solidFill>
+                  </a:tcPr>
+                </a:tc>
+                <a:tc>
+                  <a:txBody>
+                    <a:bodyPr/>
+                    <a:lstStyle/>
+                    <a:p>
+                      <a:pPr indent="0" marL="0">
+                        <a:buNone/>
+                      </a:pPr>
+                      <a:r>
+                        <a:rPr lang="en-US" sz="1000" dirty="0">
+                          <a:solidFill>
+                            <a:srgbClr val="6B7280"/>
+                          </a:solidFill>
+                          <a:latin typeface="Calibri" pitchFamily="34" charset="0"/>
+                          <a:ea typeface="Calibri" pitchFamily="34" charset="-122"/>
+                          <a:cs typeface="Calibri" pitchFamily="34" charset="-120"/>
+                        </a:rPr>
+                        <a:t>General-purpose control language</a:t>
+                      </a:r>
+                      <a:endParaRPr lang="en-US" sz="1000" dirty="0">
+                        <a:latin typeface="Calibri" charset="0"/>
+                        <a:ea typeface="Calibri" charset="0"/>
+                        <a:cs typeface="Calibri" charset="0"/>
+                      </a:endParaRPr>
+                    </a:p>
+                  </a:txBody>
+                  <a:tcPr marL="91440" marR="91440" marT="45720" marB="45720" anchor="ctr">
+                    <a:lnL w="9525" cap="flat" cmpd="sng" algn="ctr">
+                      <a:solidFill>
+                        <a:srgbClr val="E3E8EC"/>
+                      </a:solidFill>
+                      <a:prstDash val="solid"/>
+                      <a:round/>
+                      <a:headEnd type="none" w="med" len="med"/>
+                      <a:tailEnd type="none" w="med" len="med"/>
+                    </a:lnL>
+                    <a:lnR w="9525" cap="flat" cmpd="sng" algn="ctr">
+                      <a:solidFill>
+                        <a:srgbClr val="E3E8EC"/>
+                      </a:solidFill>
+                      <a:prstDash val="solid"/>
+                      <a:round/>
+                      <a:headEnd type="none" w="med" len="med"/>
+                      <a:tailEnd type="none" w="med" len="med"/>
+                    </a:lnR>
+                    <a:lnT w="9525" cap="flat" cmpd="sng" algn="ctr">
+                      <a:solidFill>
+                        <a:srgbClr val="E3E8EC"/>
+                      </a:solidFill>
+                      <a:prstDash val="solid"/>
+                      <a:round/>
+                      <a:headEnd type="none" w="med" len="med"/>
+                      <a:tailEnd type="none" w="med" len="med"/>
+                    </a:lnT>
+                    <a:lnB w="9525" cap="flat" cmpd="sng" algn="ctr">
+                      <a:solidFill>
+                        <a:srgbClr val="E3E8EC"/>
+                      </a:solidFill>
+                      <a:prstDash val="solid"/>
+                      <a:round/>
+                      <a:headEnd type="none" w="med" len="med"/>
+                      <a:tailEnd type="none" w="med" len="med"/>
+                    </a:lnB>
+                    <a:solidFill>
+                      <a:srgbClr val="FFFFFF"/>
+                    </a:solidFill>
+                  </a:tcPr>
+                </a:tc>
+                <a:tc>
+                  <a:txBody>
+                    <a:bodyPr/>
+                    <a:lstStyle/>
+                    <a:p>
+                      <a:pPr indent="0" marL="0">
+                        <a:buNone/>
+                      </a:pPr>
+                      <a:r>
+                        <a:rPr lang="en-US" sz="1000" dirty="0">
+                          <a:solidFill>
+                            <a:srgbClr val="6B7280"/>
+                          </a:solidFill>
+                          <a:latin typeface="Calibri" pitchFamily="34" charset="0"/>
+                          <a:ea typeface="Calibri" pitchFamily="34" charset="-122"/>
+                          <a:cs typeface="Calibri" pitchFamily="34" charset="-120"/>
+                        </a:rPr>
+                        <a:t>Compliance-aware, but generic</a:t>
+                      </a:r>
+                      <a:endParaRPr lang="en-US" sz="1000" dirty="0">
+                        <a:latin typeface="Calibri" charset="0"/>
+                        <a:ea typeface="Calibri" charset="0"/>
+                        <a:cs typeface="Calibri" charset="0"/>
+                      </a:endParaRPr>
+                    </a:p>
+                  </a:txBody>
+                  <a:tcPr marL="91440" marR="91440" marT="45720" marB="45720" anchor="ctr">
+                    <a:lnL w="9525" cap="flat" cmpd="sng" algn="ctr">
+                      <a:solidFill>
+                        <a:srgbClr val="E3E8EC"/>
+                      </a:solidFill>
+                      <a:prstDash val="solid"/>
+                      <a:round/>
+                      <a:headEnd type="none" w="med" len="med"/>
+                      <a:tailEnd type="none" w="med" len="med"/>
+                    </a:lnL>
+                    <a:lnR w="9525" cap="flat" cmpd="sng" algn="ctr">
+                      <a:solidFill>
+                        <a:srgbClr val="E3E8EC"/>
+                      </a:solidFill>
+                      <a:prstDash val="solid"/>
+                      <a:round/>
+                      <a:headEnd type="none" w="med" len="med"/>
+                      <a:tailEnd type="none" w="med" len="med"/>
+                    </a:lnR>
+                    <a:lnT w="9525" cap="flat" cmpd="sng" algn="ctr">
+                      <a:solidFill>
+                        <a:srgbClr val="E3E8EC"/>
+                      </a:solidFill>
+                      <a:prstDash val="solid"/>
+                      <a:round/>
+                      <a:headEnd type="none" w="med" len="med"/>
+                      <a:tailEnd type="none" w="med" len="med"/>
+                    </a:lnT>
+                    <a:lnB w="9525" cap="flat" cmpd="sng" algn="ctr">
+                      <a:solidFill>
+                        <a:srgbClr val="E3E8EC"/>
+                      </a:solidFill>
+                      <a:prstDash val="solid"/>
+                      <a:round/>
+                      <a:headEnd type="none" w="med" len="med"/>
+                      <a:tailEnd type="none" w="med" len="med"/>
+                    </a:lnB>
+                    <a:solidFill>
+                      <a:srgbClr val="FFFFFF"/>
+                    </a:solidFill>
+                  </a:tcPr>
+                </a:tc>
+                <a:tc>
+                  <a:txBody>
+                    <a:bodyPr/>
+                    <a:lstStyle/>
+                    <a:p>
+                      <a:pPr indent="0" marL="0">
+                        <a:buNone/>
+                      </a:pPr>
+                      <a:r>
+                        <a:rPr lang="en-US" sz="1050" dirty="0">
+                          <a:solidFill>
+                            <a:srgbClr val="FFFFFF"/>
+                          </a:solidFill>
+                          <a:latin typeface="Calibri" pitchFamily="34" charset="0"/>
+                          <a:ea typeface="Calibri" pitchFamily="34" charset="-122"/>
+                          <a:cs typeface="Calibri" pitchFamily="34" charset="-120"/>
+                        </a:rPr>
+                        <a:t>Highest — maps to specific regulation (roadmap item)</a:t>
+                      </a:r>
+                      <a:endParaRPr lang="en-US" sz="1050" dirty="0">
+                        <a:latin typeface="Calibri" charset="0"/>
+                        <a:ea typeface="Calibri" charset="0"/>
+                        <a:cs typeface="Calibri" charset="0"/>
+                      </a:endParaRPr>
+                    </a:p>
+                  </a:txBody>
+                  <a:tcPr marL="91440" marR="91440" marT="45720" marB="45720" anchor="ctr">
+                    <a:lnL w="9525" cap="flat" cmpd="sng" algn="ctr">
+                      <a:solidFill>
+                        <a:srgbClr val="E3E8EC"/>
+                      </a:solidFill>
+                      <a:prstDash val="solid"/>
+                      <a:round/>
+                      <a:headEnd type="none" w="med" len="med"/>
+                      <a:tailEnd type="none" w="med" len="med"/>
+                    </a:lnL>
+                    <a:lnR w="9525" cap="flat" cmpd="sng" algn="ctr">
+                      <a:solidFill>
+                        <a:srgbClr val="E3E8EC"/>
+                      </a:solidFill>
+                      <a:prstDash val="solid"/>
+                      <a:round/>
+                      <a:headEnd type="none" w="med" len="med"/>
+                      <a:tailEnd type="none" w="med" len="med"/>
+                    </a:lnR>
+                    <a:lnT w="9525" cap="flat" cmpd="sng" algn="ctr">
+                      <a:solidFill>
+                        <a:srgbClr val="E3E8EC"/>
+                      </a:solidFill>
+                      <a:prstDash val="solid"/>
+                      <a:round/>
+                      <a:headEnd type="none" w="med" len="med"/>
+                      <a:tailEnd type="none" w="med" len="med"/>
+                    </a:lnT>
+                    <a:lnB w="9525" cap="flat" cmpd="sng" algn="ctr">
+                      <a:solidFill>
+                        <a:srgbClr val="E3E8EC"/>
+                      </a:solidFill>
+                      <a:prstDash val="solid"/>
+                      <a:round/>
+                      <a:headEnd type="none" w="med" len="med"/>
+                      <a:tailEnd type="none" w="med" len="med"/>
+                    </a:lnB>
+                    <a:solidFill>
+                      <a:srgbClr val="0A2A43"/>
+                    </a:solidFill>
+                  </a:tcPr>
+                </a:tc>
+              </a:tr>
+              <a:tr h="685800">
+                <a:tc>
+                  <a:txBody>
+                    <a:bodyPr/>
+                    <a:lstStyle/>
+                    <a:p>
+                      <a:pPr indent="0" marL="0">
+                        <a:buNone/>
+                      </a:pPr>
+                      <a:r>
+                        <a:rPr lang="en-US" sz="1050" b="1" dirty="0">
+                          <a:solidFill>
+                            <a:srgbClr val="0A2A43"/>
+                          </a:solidFill>
+                          <a:latin typeface="Calibri" pitchFamily="34" charset="0"/>
+                          <a:ea typeface="Calibri" pitchFamily="34" charset="-122"/>
+                          <a:cs typeface="Calibri" pitchFamily="34" charset="-120"/>
+                        </a:rPr>
+                        <a:t>Scalability</a:t>
+                      </a:r>
+                      <a:endParaRPr lang="en-US" sz="1050" dirty="0">
                         <a:latin typeface="Calibri" charset="0"/>
                         <a:ea typeface="Calibri" charset="0"/>
                         <a:cs typeface="Calibri" charset="0"/>
@@ -13219,357 +13345,13 @@
                       <a:r>
                         <a:rPr lang="en-US" sz="1000" dirty="0">
                           <a:solidFill>
-                            <a:srgbClr val="1F2937"/>
+                            <a:srgbClr val="6B7280"/>
                           </a:solidFill>
                           <a:latin typeface="Calibri" pitchFamily="34" charset="0"/>
                           <a:ea typeface="Calibri" pitchFamily="34" charset="-122"/>
                           <a:cs typeface="Calibri" pitchFamily="34" charset="-120"/>
                         </a:rPr>
-                        <a:t>Upfront investment, no license, internal ownership</a:t>
-                      </a:r>
-                      <a:endParaRPr lang="en-US" sz="1000" dirty="0">
-                        <a:latin typeface="Calibri" charset="0"/>
-                        <a:ea typeface="Calibri" charset="0"/>
-                        <a:cs typeface="Calibri" charset="0"/>
-                      </a:endParaRPr>
-                    </a:p>
-                  </a:txBody>
-                  <a:tcPr marL="91440" marR="91440" marT="45720" marB="45720" anchor="ctr">
-                    <a:lnL w="9525" cap="flat" cmpd="sng" algn="ctr">
-                      <a:solidFill>
-                        <a:srgbClr val="E3E8EC"/>
-                      </a:solidFill>
-                      <a:prstDash val="solid"/>
-                      <a:round/>
-                      <a:headEnd type="none" w="med" len="med"/>
-                      <a:tailEnd type="none" w="med" len="med"/>
-                    </a:lnL>
-                    <a:lnR w="9525" cap="flat" cmpd="sng" algn="ctr">
-                      <a:solidFill>
-                        <a:srgbClr val="E3E8EC"/>
-                      </a:solidFill>
-                      <a:prstDash val="solid"/>
-                      <a:round/>
-                      <a:headEnd type="none" w="med" len="med"/>
-                      <a:tailEnd type="none" w="med" len="med"/>
-                    </a:lnR>
-                    <a:lnT w="9525" cap="flat" cmpd="sng" algn="ctr">
-                      <a:solidFill>
-                        <a:srgbClr val="E3E8EC"/>
-                      </a:solidFill>
-                      <a:prstDash val="solid"/>
-                      <a:round/>
-                      <a:headEnd type="none" w="med" len="med"/>
-                      <a:tailEnd type="none" w="med" len="med"/>
-                    </a:lnT>
-                    <a:lnB w="9525" cap="flat" cmpd="sng" algn="ctr">
-                      <a:solidFill>
-                        <a:srgbClr val="E3E8EC"/>
-                      </a:solidFill>
-                      <a:prstDash val="solid"/>
-                      <a:round/>
-                      <a:headEnd type="none" w="med" len="med"/>
-                      <a:tailEnd type="none" w="med" len="med"/>
-                    </a:lnB>
-                    <a:solidFill>
-                      <a:srgbClr val="F3F6F8"/>
-                    </a:solidFill>
-                  </a:tcPr>
-                </a:tc>
-              </a:tr>
-              <a:tr h="822960">
-                <a:tc>
-                  <a:txBody>
-                    <a:bodyPr/>
-                    <a:lstStyle/>
-                    <a:p>
-                      <a:pPr indent="0" marL="0">
-                        <a:buNone/>
-                      </a:pPr>
-                      <a:r>
-                        <a:rPr lang="en-US" sz="1000" b="1" dirty="0">
-                          <a:solidFill>
-                            <a:srgbClr val="1F2937"/>
-                          </a:solidFill>
-                          <a:latin typeface="Calibri" pitchFamily="34" charset="0"/>
-                          <a:ea typeface="Calibri" pitchFamily="34" charset="-122"/>
-                          <a:cs typeface="Calibri" pitchFamily="34" charset="-120"/>
-                        </a:rPr>
-                        <a:t>Integration complexity</a:t>
-                      </a:r>
-                      <a:endParaRPr lang="en-US" sz="1000" dirty="0">
-                        <a:latin typeface="Calibri" charset="0"/>
-                        <a:ea typeface="Calibri" charset="0"/>
-                        <a:cs typeface="Calibri" charset="0"/>
-                      </a:endParaRPr>
-                    </a:p>
-                  </a:txBody>
-                  <a:tcPr marL="91440" marR="91440" marT="45720" marB="45720" anchor="ctr">
-                    <a:lnL w="9525" cap="flat" cmpd="sng" algn="ctr">
-                      <a:solidFill>
-                        <a:srgbClr val="E3E8EC"/>
-                      </a:solidFill>
-                      <a:prstDash val="solid"/>
-                      <a:round/>
-                      <a:headEnd type="none" w="med" len="med"/>
-                      <a:tailEnd type="none" w="med" len="med"/>
-                    </a:lnL>
-                    <a:lnR w="9525" cap="flat" cmpd="sng" algn="ctr">
-                      <a:solidFill>
-                        <a:srgbClr val="E3E8EC"/>
-                      </a:solidFill>
-                      <a:prstDash val="solid"/>
-                      <a:round/>
-                      <a:headEnd type="none" w="med" len="med"/>
-                      <a:tailEnd type="none" w="med" len="med"/>
-                    </a:lnR>
-                    <a:lnT w="9525" cap="flat" cmpd="sng" algn="ctr">
-                      <a:solidFill>
-                        <a:srgbClr val="E3E8EC"/>
-                      </a:solidFill>
-                      <a:prstDash val="solid"/>
-                      <a:round/>
-                      <a:headEnd type="none" w="med" len="med"/>
-                      <a:tailEnd type="none" w="med" len="med"/>
-                    </a:lnT>
-                    <a:lnB w="9525" cap="flat" cmpd="sng" algn="ctr">
-                      <a:solidFill>
-                        <a:srgbClr val="E3E8EC"/>
-                      </a:solidFill>
-                      <a:prstDash val="solid"/>
-                      <a:round/>
-                      <a:headEnd type="none" w="med" len="med"/>
-                      <a:tailEnd type="none" w="med" len="med"/>
-                    </a:lnB>
-                    <a:solidFill>
-                      <a:srgbClr val="FFFFFF"/>
-                    </a:solidFill>
-                  </a:tcPr>
-                </a:tc>
-                <a:tc>
-                  <a:txBody>
-                    <a:bodyPr/>
-                    <a:lstStyle/>
-                    <a:p>
-                      <a:pPr indent="0" marL="0">
-                        <a:buNone/>
-                      </a:pPr>
-                      <a:r>
-                        <a:rPr lang="en-US" sz="1000" dirty="0">
-                          <a:solidFill>
-                            <a:srgbClr val="1F2937"/>
-                          </a:solidFill>
-                          <a:latin typeface="Calibri" pitchFamily="34" charset="0"/>
-                          <a:ea typeface="Calibri" pitchFamily="34" charset="-122"/>
-                          <a:cs typeface="Calibri" pitchFamily="34" charset="-120"/>
-                        </a:rPr>
-                        <a:t>Low, but AI runtime concepts aren't native</a:t>
-                      </a:r>
-                      <a:endParaRPr lang="en-US" sz="1000" dirty="0">
-                        <a:latin typeface="Calibri" charset="0"/>
-                        <a:ea typeface="Calibri" charset="0"/>
-                        <a:cs typeface="Calibri" charset="0"/>
-                      </a:endParaRPr>
-                    </a:p>
-                  </a:txBody>
-                  <a:tcPr marL="91440" marR="91440" marT="45720" marB="45720" anchor="ctr">
-                    <a:lnL w="9525" cap="flat" cmpd="sng" algn="ctr">
-                      <a:solidFill>
-                        <a:srgbClr val="E3E8EC"/>
-                      </a:solidFill>
-                      <a:prstDash val="solid"/>
-                      <a:round/>
-                      <a:headEnd type="none" w="med" len="med"/>
-                      <a:tailEnd type="none" w="med" len="med"/>
-                    </a:lnL>
-                    <a:lnR w="9525" cap="flat" cmpd="sng" algn="ctr">
-                      <a:solidFill>
-                        <a:srgbClr val="E3E8EC"/>
-                      </a:solidFill>
-                      <a:prstDash val="solid"/>
-                      <a:round/>
-                      <a:headEnd type="none" w="med" len="med"/>
-                      <a:tailEnd type="none" w="med" len="med"/>
-                    </a:lnR>
-                    <a:lnT w="9525" cap="flat" cmpd="sng" algn="ctr">
-                      <a:solidFill>
-                        <a:srgbClr val="E3E8EC"/>
-                      </a:solidFill>
-                      <a:prstDash val="solid"/>
-                      <a:round/>
-                      <a:headEnd type="none" w="med" len="med"/>
-                      <a:tailEnd type="none" w="med" len="med"/>
-                    </a:lnT>
-                    <a:lnB w="9525" cap="flat" cmpd="sng" algn="ctr">
-                      <a:solidFill>
-                        <a:srgbClr val="E3E8EC"/>
-                      </a:solidFill>
-                      <a:prstDash val="solid"/>
-                      <a:round/>
-                      <a:headEnd type="none" w="med" len="med"/>
-                      <a:tailEnd type="none" w="med" len="med"/>
-                    </a:lnB>
-                    <a:solidFill>
-                      <a:srgbClr val="FFFFFF"/>
-                    </a:solidFill>
-                  </a:tcPr>
-                </a:tc>
-                <a:tc>
-                  <a:txBody>
-                    <a:bodyPr/>
-                    <a:lstStyle/>
-                    <a:p>
-                      <a:pPr indent="0" marL="0">
-                        <a:buNone/>
-                      </a:pPr>
-                      <a:r>
-                        <a:rPr lang="en-US" sz="1000" dirty="0">
-                          <a:solidFill>
-                            <a:srgbClr val="1F2937"/>
-                          </a:solidFill>
-                          <a:latin typeface="Calibri" pitchFamily="34" charset="0"/>
-                          <a:ea typeface="Calibri" pitchFamily="34" charset="-122"/>
-                          <a:cs typeface="Calibri" pitchFamily="34" charset="-120"/>
-                        </a:rPr>
-                        <a:t>Medium-high — vendor didn't design for our Gateway</a:t>
-                      </a:r>
-                      <a:endParaRPr lang="en-US" sz="1000" dirty="0">
-                        <a:latin typeface="Calibri" charset="0"/>
-                        <a:ea typeface="Calibri" charset="0"/>
-                        <a:cs typeface="Calibri" charset="0"/>
-                      </a:endParaRPr>
-                    </a:p>
-                  </a:txBody>
-                  <a:tcPr marL="91440" marR="91440" marT="45720" marB="45720" anchor="ctr">
-                    <a:lnL w="9525" cap="flat" cmpd="sng" algn="ctr">
-                      <a:solidFill>
-                        <a:srgbClr val="E3E8EC"/>
-                      </a:solidFill>
-                      <a:prstDash val="solid"/>
-                      <a:round/>
-                      <a:headEnd type="none" w="med" len="med"/>
-                      <a:tailEnd type="none" w="med" len="med"/>
-                    </a:lnL>
-                    <a:lnR w="9525" cap="flat" cmpd="sng" algn="ctr">
-                      <a:solidFill>
-                        <a:srgbClr val="E3E8EC"/>
-                      </a:solidFill>
-                      <a:prstDash val="solid"/>
-                      <a:round/>
-                      <a:headEnd type="none" w="med" len="med"/>
-                      <a:tailEnd type="none" w="med" len="med"/>
-                    </a:lnR>
-                    <a:lnT w="9525" cap="flat" cmpd="sng" algn="ctr">
-                      <a:solidFill>
-                        <a:srgbClr val="E3E8EC"/>
-                      </a:solidFill>
-                      <a:prstDash val="solid"/>
-                      <a:round/>
-                      <a:headEnd type="none" w="med" len="med"/>
-                      <a:tailEnd type="none" w="med" len="med"/>
-                    </a:lnT>
-                    <a:lnB w="9525" cap="flat" cmpd="sng" algn="ctr">
-                      <a:solidFill>
-                        <a:srgbClr val="E3E8EC"/>
-                      </a:solidFill>
-                      <a:prstDash val="solid"/>
-                      <a:round/>
-                      <a:headEnd type="none" w="med" len="med"/>
-                      <a:tailEnd type="none" w="med" len="med"/>
-                    </a:lnB>
-                    <a:solidFill>
-                      <a:srgbClr val="FFFFFF"/>
-                    </a:solidFill>
-                  </a:tcPr>
-                </a:tc>
-                <a:tc>
-                  <a:txBody>
-                    <a:bodyPr/>
-                    <a:lstStyle/>
-                    <a:p>
-                      <a:pPr indent="0" marL="0">
-                        <a:buNone/>
-                      </a:pPr>
-                      <a:r>
-                        <a:rPr lang="en-US" sz="1000" dirty="0">
-                          <a:solidFill>
-                            <a:srgbClr val="1F2937"/>
-                          </a:solidFill>
-                          <a:latin typeface="Calibri" pitchFamily="34" charset="0"/>
-                          <a:ea typeface="Calibri" pitchFamily="34" charset="-122"/>
-                          <a:cs typeface="Calibri" pitchFamily="34" charset="-120"/>
-                        </a:rPr>
-                        <a:t>Low, by construction — built around our own stack</a:t>
-                      </a:r>
-                      <a:endParaRPr lang="en-US" sz="1000" dirty="0">
-                        <a:latin typeface="Calibri" charset="0"/>
-                        <a:ea typeface="Calibri" charset="0"/>
-                        <a:cs typeface="Calibri" charset="0"/>
-                      </a:endParaRPr>
-                    </a:p>
-                  </a:txBody>
-                  <a:tcPr marL="91440" marR="91440" marT="45720" marB="45720" anchor="ctr">
-                    <a:lnL w="9525" cap="flat" cmpd="sng" algn="ctr">
-                      <a:solidFill>
-                        <a:srgbClr val="E3E8EC"/>
-                      </a:solidFill>
-                      <a:prstDash val="solid"/>
-                      <a:round/>
-                      <a:headEnd type="none" w="med" len="med"/>
-                      <a:tailEnd type="none" w="med" len="med"/>
-                    </a:lnL>
-                    <a:lnR w="9525" cap="flat" cmpd="sng" algn="ctr">
-                      <a:solidFill>
-                        <a:srgbClr val="E3E8EC"/>
-                      </a:solidFill>
-                      <a:prstDash val="solid"/>
-                      <a:round/>
-                      <a:headEnd type="none" w="med" len="med"/>
-                      <a:tailEnd type="none" w="med" len="med"/>
-                    </a:lnR>
-                    <a:lnT w="9525" cap="flat" cmpd="sng" algn="ctr">
-                      <a:solidFill>
-                        <a:srgbClr val="E3E8EC"/>
-                      </a:solidFill>
-                      <a:prstDash val="solid"/>
-                      <a:round/>
-                      <a:headEnd type="none" w="med" len="med"/>
-                      <a:tailEnd type="none" w="med" len="med"/>
-                    </a:lnT>
-                    <a:lnB w="9525" cap="flat" cmpd="sng" algn="ctr">
-                      <a:solidFill>
-                        <a:srgbClr val="E3E8EC"/>
-                      </a:solidFill>
-                      <a:prstDash val="solid"/>
-                      <a:round/>
-                      <a:headEnd type="none" w="med" len="med"/>
-                      <a:tailEnd type="none" w="med" len="med"/>
-                    </a:lnB>
-                    <a:solidFill>
-                      <a:srgbClr val="FFFFFF"/>
-                    </a:solidFill>
-                  </a:tcPr>
-                </a:tc>
-              </a:tr>
-              <a:tr h="822960">
-                <a:tc>
-                  <a:txBody>
-                    <a:bodyPr/>
-                    <a:lstStyle/>
-                    <a:p>
-                      <a:pPr indent="0" marL="0">
-                        <a:buNone/>
-                      </a:pPr>
-                      <a:r>
-                        <a:rPr lang="en-US" sz="1000" b="1" dirty="0">
-                          <a:solidFill>
-                            <a:srgbClr val="1F2937"/>
-                          </a:solidFill>
-                          <a:latin typeface="Calibri" pitchFamily="34" charset="0"/>
-                          <a:ea typeface="Calibri" pitchFamily="34" charset="-122"/>
-                          <a:cs typeface="Calibri" pitchFamily="34" charset="-120"/>
-                        </a:rPr>
-                        <a:t>Flexibility</a:t>
+                        <a:t>Not built for real-time runtime supervision</a:t>
                       </a:r>
                       <a:endParaRPr lang="en-US" sz="1000" dirty="0">
                         <a:latin typeface="Calibri" charset="0"/>
@@ -13631,623 +13413,7 @@
                       <a:r>
                         <a:rPr lang="en-US" sz="1000" dirty="0">
                           <a:solidFill>
-                            <a:srgbClr val="1F2937"/>
-                          </a:solidFill>
-                          <a:latin typeface="Calibri" pitchFamily="34" charset="0"/>
-                          <a:ea typeface="Calibri" pitchFamily="34" charset="-122"/>
-                          <a:cs typeface="Calibri" pitchFamily="34" charset="-120"/>
-                        </a:rPr>
-                        <a:t>Constrained to the host platform</a:t>
-                      </a:r>
-                      <a:endParaRPr lang="en-US" sz="1000" dirty="0">
-                        <a:latin typeface="Calibri" charset="0"/>
-                        <a:ea typeface="Calibri" charset="0"/>
-                        <a:cs typeface="Calibri" charset="0"/>
-                      </a:endParaRPr>
-                    </a:p>
-                  </a:txBody>
-                  <a:tcPr marL="91440" marR="91440" marT="45720" marB="45720" anchor="ctr">
-                    <a:lnL w="9525" cap="flat" cmpd="sng" algn="ctr">
-                      <a:solidFill>
-                        <a:srgbClr val="E3E8EC"/>
-                      </a:solidFill>
-                      <a:prstDash val="solid"/>
-                      <a:round/>
-                      <a:headEnd type="none" w="med" len="med"/>
-                      <a:tailEnd type="none" w="med" len="med"/>
-                    </a:lnL>
-                    <a:lnR w="9525" cap="flat" cmpd="sng" algn="ctr">
-                      <a:solidFill>
-                        <a:srgbClr val="E3E8EC"/>
-                      </a:solidFill>
-                      <a:prstDash val="solid"/>
-                      <a:round/>
-                      <a:headEnd type="none" w="med" len="med"/>
-                      <a:tailEnd type="none" w="med" len="med"/>
-                    </a:lnR>
-                    <a:lnT w="9525" cap="flat" cmpd="sng" algn="ctr">
-                      <a:solidFill>
-                        <a:srgbClr val="E3E8EC"/>
-                      </a:solidFill>
-                      <a:prstDash val="solid"/>
-                      <a:round/>
-                      <a:headEnd type="none" w="med" len="med"/>
-                      <a:tailEnd type="none" w="med" len="med"/>
-                    </a:lnT>
-                    <a:lnB w="9525" cap="flat" cmpd="sng" algn="ctr">
-                      <a:solidFill>
-                        <a:srgbClr val="E3E8EC"/>
-                      </a:solidFill>
-                      <a:prstDash val="solid"/>
-                      <a:round/>
-                      <a:headEnd type="none" w="med" len="med"/>
-                      <a:tailEnd type="none" w="med" len="med"/>
-                    </a:lnB>
-                    <a:solidFill>
-                      <a:srgbClr val="F3F6F8"/>
-                    </a:solidFill>
-                  </a:tcPr>
-                </a:tc>
-                <a:tc>
-                  <a:txBody>
-                    <a:bodyPr/>
-                    <a:lstStyle/>
-                    <a:p>
-                      <a:pPr indent="0" marL="0">
-                        <a:buNone/>
-                      </a:pPr>
-                      <a:r>
-                        <a:rPr lang="en-US" sz="1000" dirty="0">
-                          <a:solidFill>
-                            <a:srgbClr val="1F2937"/>
-                          </a:solidFill>
-                          <a:latin typeface="Calibri" pitchFamily="34" charset="0"/>
-                          <a:ea typeface="Calibri" pitchFamily="34" charset="-122"/>
-                          <a:cs typeface="Calibri" pitchFamily="34" charset="-120"/>
-                        </a:rPr>
-                        <a:t>Configurable, but core logic is vendor-owned</a:t>
-                      </a:r>
-                      <a:endParaRPr lang="en-US" sz="1000" dirty="0">
-                        <a:latin typeface="Calibri" charset="0"/>
-                        <a:ea typeface="Calibri" charset="0"/>
-                        <a:cs typeface="Calibri" charset="0"/>
-                      </a:endParaRPr>
-                    </a:p>
-                  </a:txBody>
-                  <a:tcPr marL="91440" marR="91440" marT="45720" marB="45720" anchor="ctr">
-                    <a:lnL w="9525" cap="flat" cmpd="sng" algn="ctr">
-                      <a:solidFill>
-                        <a:srgbClr val="E3E8EC"/>
-                      </a:solidFill>
-                      <a:prstDash val="solid"/>
-                      <a:round/>
-                      <a:headEnd type="none" w="med" len="med"/>
-                      <a:tailEnd type="none" w="med" len="med"/>
-                    </a:lnL>
-                    <a:lnR w="9525" cap="flat" cmpd="sng" algn="ctr">
-                      <a:solidFill>
-                        <a:srgbClr val="E3E8EC"/>
-                      </a:solidFill>
-                      <a:prstDash val="solid"/>
-                      <a:round/>
-                      <a:headEnd type="none" w="med" len="med"/>
-                      <a:tailEnd type="none" w="med" len="med"/>
-                    </a:lnR>
-                    <a:lnT w="9525" cap="flat" cmpd="sng" algn="ctr">
-                      <a:solidFill>
-                        <a:srgbClr val="E3E8EC"/>
-                      </a:solidFill>
-                      <a:prstDash val="solid"/>
-                      <a:round/>
-                      <a:headEnd type="none" w="med" len="med"/>
-                      <a:tailEnd type="none" w="med" len="med"/>
-                    </a:lnT>
-                    <a:lnB w="9525" cap="flat" cmpd="sng" algn="ctr">
-                      <a:solidFill>
-                        <a:srgbClr val="E3E8EC"/>
-                      </a:solidFill>
-                      <a:prstDash val="solid"/>
-                      <a:round/>
-                      <a:headEnd type="none" w="med" len="med"/>
-                      <a:tailEnd type="none" w="med" len="med"/>
-                    </a:lnB>
-                    <a:solidFill>
-                      <a:srgbClr val="F3F6F8"/>
-                    </a:solidFill>
-                  </a:tcPr>
-                </a:tc>
-                <a:tc>
-                  <a:txBody>
-                    <a:bodyPr/>
-                    <a:lstStyle/>
-                    <a:p>
-                      <a:pPr indent="0" marL="0">
-                        <a:buNone/>
-                      </a:pPr>
-                      <a:r>
-                        <a:rPr lang="en-US" sz="1000" dirty="0">
-                          <a:solidFill>
-                            <a:srgbClr val="1F2937"/>
-                          </a:solidFill>
-                          <a:latin typeface="Calibri" pitchFamily="34" charset="0"/>
-                          <a:ea typeface="Calibri" pitchFamily="34" charset="-122"/>
-                          <a:cs typeface="Calibri" pitchFamily="34" charset="-120"/>
-                        </a:rPr>
-                        <a:t>Highest — shaped exactly to the org</a:t>
-                      </a:r>
-                      <a:endParaRPr lang="en-US" sz="1000" dirty="0">
-                        <a:latin typeface="Calibri" charset="0"/>
-                        <a:ea typeface="Calibri" charset="0"/>
-                        <a:cs typeface="Calibri" charset="0"/>
-                      </a:endParaRPr>
-                    </a:p>
-                  </a:txBody>
-                  <a:tcPr marL="91440" marR="91440" marT="45720" marB="45720" anchor="ctr">
-                    <a:lnL w="9525" cap="flat" cmpd="sng" algn="ctr">
-                      <a:solidFill>
-                        <a:srgbClr val="E3E8EC"/>
-                      </a:solidFill>
-                      <a:prstDash val="solid"/>
-                      <a:round/>
-                      <a:headEnd type="none" w="med" len="med"/>
-                      <a:tailEnd type="none" w="med" len="med"/>
-                    </a:lnL>
-                    <a:lnR w="9525" cap="flat" cmpd="sng" algn="ctr">
-                      <a:solidFill>
-                        <a:srgbClr val="E3E8EC"/>
-                      </a:solidFill>
-                      <a:prstDash val="solid"/>
-                      <a:round/>
-                      <a:headEnd type="none" w="med" len="med"/>
-                      <a:tailEnd type="none" w="med" len="med"/>
-                    </a:lnR>
-                    <a:lnT w="9525" cap="flat" cmpd="sng" algn="ctr">
-                      <a:solidFill>
-                        <a:srgbClr val="E3E8EC"/>
-                      </a:solidFill>
-                      <a:prstDash val="solid"/>
-                      <a:round/>
-                      <a:headEnd type="none" w="med" len="med"/>
-                      <a:tailEnd type="none" w="med" len="med"/>
-                    </a:lnT>
-                    <a:lnB w="9525" cap="flat" cmpd="sng" algn="ctr">
-                      <a:solidFill>
-                        <a:srgbClr val="E3E8EC"/>
-                      </a:solidFill>
-                      <a:prstDash val="solid"/>
-                      <a:round/>
-                      <a:headEnd type="none" w="med" len="med"/>
-                      <a:tailEnd type="none" w="med" len="med"/>
-                    </a:lnB>
-                    <a:solidFill>
-                      <a:srgbClr val="F3F6F8"/>
-                    </a:solidFill>
-                  </a:tcPr>
-                </a:tc>
-              </a:tr>
-              <a:tr h="822960">
-                <a:tc>
-                  <a:txBody>
-                    <a:bodyPr/>
-                    <a:lstStyle/>
-                    <a:p>
-                      <a:pPr indent="0" marL="0">
-                        <a:buNone/>
-                      </a:pPr>
-                      <a:r>
-                        <a:rPr lang="en-US" sz="1000" b="1" dirty="0">
-                          <a:solidFill>
-                            <a:srgbClr val="1F2937"/>
-                          </a:solidFill>
-                          <a:latin typeface="Calibri" pitchFamily="34" charset="0"/>
-                          <a:ea typeface="Calibri" pitchFamily="34" charset="-122"/>
-                          <a:cs typeface="Calibri" pitchFamily="34" charset="-120"/>
-                        </a:rPr>
-                        <a:t>Regulatory control</a:t>
-                      </a:r>
-                      <a:endParaRPr lang="en-US" sz="1000" dirty="0">
-                        <a:latin typeface="Calibri" charset="0"/>
-                        <a:ea typeface="Calibri" charset="0"/>
-                        <a:cs typeface="Calibri" charset="0"/>
-                      </a:endParaRPr>
-                    </a:p>
-                  </a:txBody>
-                  <a:tcPr marL="91440" marR="91440" marT="45720" marB="45720" anchor="ctr">
-                    <a:lnL w="9525" cap="flat" cmpd="sng" algn="ctr">
-                      <a:solidFill>
-                        <a:srgbClr val="E3E8EC"/>
-                      </a:solidFill>
-                      <a:prstDash val="solid"/>
-                      <a:round/>
-                      <a:headEnd type="none" w="med" len="med"/>
-                      <a:tailEnd type="none" w="med" len="med"/>
-                    </a:lnL>
-                    <a:lnR w="9525" cap="flat" cmpd="sng" algn="ctr">
-                      <a:solidFill>
-                        <a:srgbClr val="E3E8EC"/>
-                      </a:solidFill>
-                      <a:prstDash val="solid"/>
-                      <a:round/>
-                      <a:headEnd type="none" w="med" len="med"/>
-                      <a:tailEnd type="none" w="med" len="med"/>
-                    </a:lnR>
-                    <a:lnT w="9525" cap="flat" cmpd="sng" algn="ctr">
-                      <a:solidFill>
-                        <a:srgbClr val="E3E8EC"/>
-                      </a:solidFill>
-                      <a:prstDash val="solid"/>
-                      <a:round/>
-                      <a:headEnd type="none" w="med" len="med"/>
-                      <a:tailEnd type="none" w="med" len="med"/>
-                    </a:lnT>
-                    <a:lnB w="9525" cap="flat" cmpd="sng" algn="ctr">
-                      <a:solidFill>
-                        <a:srgbClr val="E3E8EC"/>
-                      </a:solidFill>
-                      <a:prstDash val="solid"/>
-                      <a:round/>
-                      <a:headEnd type="none" w="med" len="med"/>
-                      <a:tailEnd type="none" w="med" len="med"/>
-                    </a:lnB>
-                    <a:solidFill>
-                      <a:srgbClr val="FFFFFF"/>
-                    </a:solidFill>
-                  </a:tcPr>
-                </a:tc>
-                <a:tc>
-                  <a:txBody>
-                    <a:bodyPr/>
-                    <a:lstStyle/>
-                    <a:p>
-                      <a:pPr indent="0" marL="0">
-                        <a:buNone/>
-                      </a:pPr>
-                      <a:r>
-                        <a:rPr lang="en-US" sz="1000" dirty="0">
-                          <a:solidFill>
-                            <a:srgbClr val="1F2937"/>
-                          </a:solidFill>
-                          <a:latin typeface="Calibri" pitchFamily="34" charset="0"/>
-                          <a:ea typeface="Calibri" pitchFamily="34" charset="-122"/>
-                          <a:cs typeface="Calibri" pitchFamily="34" charset="-120"/>
-                        </a:rPr>
-                        <a:t>General-purpose control language</a:t>
-                      </a:r>
-                      <a:endParaRPr lang="en-US" sz="1000" dirty="0">
-                        <a:latin typeface="Calibri" charset="0"/>
-                        <a:ea typeface="Calibri" charset="0"/>
-                        <a:cs typeface="Calibri" charset="0"/>
-                      </a:endParaRPr>
-                    </a:p>
-                  </a:txBody>
-                  <a:tcPr marL="91440" marR="91440" marT="45720" marB="45720" anchor="ctr">
-                    <a:lnL w="9525" cap="flat" cmpd="sng" algn="ctr">
-                      <a:solidFill>
-                        <a:srgbClr val="E3E8EC"/>
-                      </a:solidFill>
-                      <a:prstDash val="solid"/>
-                      <a:round/>
-                      <a:headEnd type="none" w="med" len="med"/>
-                      <a:tailEnd type="none" w="med" len="med"/>
-                    </a:lnL>
-                    <a:lnR w="9525" cap="flat" cmpd="sng" algn="ctr">
-                      <a:solidFill>
-                        <a:srgbClr val="E3E8EC"/>
-                      </a:solidFill>
-                      <a:prstDash val="solid"/>
-                      <a:round/>
-                      <a:headEnd type="none" w="med" len="med"/>
-                      <a:tailEnd type="none" w="med" len="med"/>
-                    </a:lnR>
-                    <a:lnT w="9525" cap="flat" cmpd="sng" algn="ctr">
-                      <a:solidFill>
-                        <a:srgbClr val="E3E8EC"/>
-                      </a:solidFill>
-                      <a:prstDash val="solid"/>
-                      <a:round/>
-                      <a:headEnd type="none" w="med" len="med"/>
-                      <a:tailEnd type="none" w="med" len="med"/>
-                    </a:lnT>
-                    <a:lnB w="9525" cap="flat" cmpd="sng" algn="ctr">
-                      <a:solidFill>
-                        <a:srgbClr val="E3E8EC"/>
-                      </a:solidFill>
-                      <a:prstDash val="solid"/>
-                      <a:round/>
-                      <a:headEnd type="none" w="med" len="med"/>
-                      <a:tailEnd type="none" w="med" len="med"/>
-                    </a:lnB>
-                    <a:solidFill>
-                      <a:srgbClr val="FFFFFF"/>
-                    </a:solidFill>
-                  </a:tcPr>
-                </a:tc>
-                <a:tc>
-                  <a:txBody>
-                    <a:bodyPr/>
-                    <a:lstStyle/>
-                    <a:p>
-                      <a:pPr indent="0" marL="0">
-                        <a:buNone/>
-                      </a:pPr>
-                      <a:r>
-                        <a:rPr lang="en-US" sz="1000" dirty="0">
-                          <a:solidFill>
-                            <a:srgbClr val="1F2937"/>
-                          </a:solidFill>
-                          <a:latin typeface="Calibri" pitchFamily="34" charset="0"/>
-                          <a:ea typeface="Calibri" pitchFamily="34" charset="-122"/>
-                          <a:cs typeface="Calibri" pitchFamily="34" charset="-120"/>
-                        </a:rPr>
-                        <a:t>Compliance-aware, but generic</a:t>
-                      </a:r>
-                      <a:endParaRPr lang="en-US" sz="1000" dirty="0">
-                        <a:latin typeface="Calibri" charset="0"/>
-                        <a:ea typeface="Calibri" charset="0"/>
-                        <a:cs typeface="Calibri" charset="0"/>
-                      </a:endParaRPr>
-                    </a:p>
-                  </a:txBody>
-                  <a:tcPr marL="91440" marR="91440" marT="45720" marB="45720" anchor="ctr">
-                    <a:lnL w="9525" cap="flat" cmpd="sng" algn="ctr">
-                      <a:solidFill>
-                        <a:srgbClr val="E3E8EC"/>
-                      </a:solidFill>
-                      <a:prstDash val="solid"/>
-                      <a:round/>
-                      <a:headEnd type="none" w="med" len="med"/>
-                      <a:tailEnd type="none" w="med" len="med"/>
-                    </a:lnL>
-                    <a:lnR w="9525" cap="flat" cmpd="sng" algn="ctr">
-                      <a:solidFill>
-                        <a:srgbClr val="E3E8EC"/>
-                      </a:solidFill>
-                      <a:prstDash val="solid"/>
-                      <a:round/>
-                      <a:headEnd type="none" w="med" len="med"/>
-                      <a:tailEnd type="none" w="med" len="med"/>
-                    </a:lnR>
-                    <a:lnT w="9525" cap="flat" cmpd="sng" algn="ctr">
-                      <a:solidFill>
-                        <a:srgbClr val="E3E8EC"/>
-                      </a:solidFill>
-                      <a:prstDash val="solid"/>
-                      <a:round/>
-                      <a:headEnd type="none" w="med" len="med"/>
-                      <a:tailEnd type="none" w="med" len="med"/>
-                    </a:lnT>
-                    <a:lnB w="9525" cap="flat" cmpd="sng" algn="ctr">
-                      <a:solidFill>
-                        <a:srgbClr val="E3E8EC"/>
-                      </a:solidFill>
-                      <a:prstDash val="solid"/>
-                      <a:round/>
-                      <a:headEnd type="none" w="med" len="med"/>
-                      <a:tailEnd type="none" w="med" len="med"/>
-                    </a:lnB>
-                    <a:solidFill>
-                      <a:srgbClr val="FFFFFF"/>
-                    </a:solidFill>
-                  </a:tcPr>
-                </a:tc>
-                <a:tc>
-                  <a:txBody>
-                    <a:bodyPr/>
-                    <a:lstStyle/>
-                    <a:p>
-                      <a:pPr indent="0" marL="0">
-                        <a:buNone/>
-                      </a:pPr>
-                      <a:r>
-                        <a:rPr lang="en-US" sz="1000" dirty="0">
-                          <a:solidFill>
-                            <a:srgbClr val="1F2937"/>
-                          </a:solidFill>
-                          <a:latin typeface="Calibri" pitchFamily="34" charset="0"/>
-                          <a:ea typeface="Calibri" pitchFamily="34" charset="-122"/>
-                          <a:cs typeface="Calibri" pitchFamily="34" charset="-120"/>
-                        </a:rPr>
-                        <a:t>Highest — maps to specific regulation (roadmap item)</a:t>
-                      </a:r>
-                      <a:endParaRPr lang="en-US" sz="1000" dirty="0">
-                        <a:latin typeface="Calibri" charset="0"/>
-                        <a:ea typeface="Calibri" charset="0"/>
-                        <a:cs typeface="Calibri" charset="0"/>
-                      </a:endParaRPr>
-                    </a:p>
-                  </a:txBody>
-                  <a:tcPr marL="91440" marR="91440" marT="45720" marB="45720" anchor="ctr">
-                    <a:lnL w="9525" cap="flat" cmpd="sng" algn="ctr">
-                      <a:solidFill>
-                        <a:srgbClr val="E3E8EC"/>
-                      </a:solidFill>
-                      <a:prstDash val="solid"/>
-                      <a:round/>
-                      <a:headEnd type="none" w="med" len="med"/>
-                      <a:tailEnd type="none" w="med" len="med"/>
-                    </a:lnL>
-                    <a:lnR w="9525" cap="flat" cmpd="sng" algn="ctr">
-                      <a:solidFill>
-                        <a:srgbClr val="E3E8EC"/>
-                      </a:solidFill>
-                      <a:prstDash val="solid"/>
-                      <a:round/>
-                      <a:headEnd type="none" w="med" len="med"/>
-                      <a:tailEnd type="none" w="med" len="med"/>
-                    </a:lnR>
-                    <a:lnT w="9525" cap="flat" cmpd="sng" algn="ctr">
-                      <a:solidFill>
-                        <a:srgbClr val="E3E8EC"/>
-                      </a:solidFill>
-                      <a:prstDash val="solid"/>
-                      <a:round/>
-                      <a:headEnd type="none" w="med" len="med"/>
-                      <a:tailEnd type="none" w="med" len="med"/>
-                    </a:lnT>
-                    <a:lnB w="9525" cap="flat" cmpd="sng" algn="ctr">
-                      <a:solidFill>
-                        <a:srgbClr val="E3E8EC"/>
-                      </a:solidFill>
-                      <a:prstDash val="solid"/>
-                      <a:round/>
-                      <a:headEnd type="none" w="med" len="med"/>
-                      <a:tailEnd type="none" w="med" len="med"/>
-                    </a:lnB>
-                    <a:solidFill>
-                      <a:srgbClr val="FFFFFF"/>
-                    </a:solidFill>
-                  </a:tcPr>
-                </a:tc>
-              </a:tr>
-              <a:tr h="822960">
-                <a:tc>
-                  <a:txBody>
-                    <a:bodyPr/>
-                    <a:lstStyle/>
-                    <a:p>
-                      <a:pPr indent="0" marL="0">
-                        <a:buNone/>
-                      </a:pPr>
-                      <a:r>
-                        <a:rPr lang="en-US" sz="1000" b="1" dirty="0">
-                          <a:solidFill>
-                            <a:srgbClr val="1F2937"/>
-                          </a:solidFill>
-                          <a:latin typeface="Calibri" pitchFamily="34" charset="0"/>
-                          <a:ea typeface="Calibri" pitchFamily="34" charset="-122"/>
-                          <a:cs typeface="Calibri" pitchFamily="34" charset="-120"/>
-                        </a:rPr>
-                        <a:t>Scalability</a:t>
-                      </a:r>
-                      <a:endParaRPr lang="en-US" sz="1000" dirty="0">
-                        <a:latin typeface="Calibri" charset="0"/>
-                        <a:ea typeface="Calibri" charset="0"/>
-                        <a:cs typeface="Calibri" charset="0"/>
-                      </a:endParaRPr>
-                    </a:p>
-                  </a:txBody>
-                  <a:tcPr marL="91440" marR="91440" marT="45720" marB="45720" anchor="ctr">
-                    <a:lnL w="9525" cap="flat" cmpd="sng" algn="ctr">
-                      <a:solidFill>
-                        <a:srgbClr val="E3E8EC"/>
-                      </a:solidFill>
-                      <a:prstDash val="solid"/>
-                      <a:round/>
-                      <a:headEnd type="none" w="med" len="med"/>
-                      <a:tailEnd type="none" w="med" len="med"/>
-                    </a:lnL>
-                    <a:lnR w="9525" cap="flat" cmpd="sng" algn="ctr">
-                      <a:solidFill>
-                        <a:srgbClr val="E3E8EC"/>
-                      </a:solidFill>
-                      <a:prstDash val="solid"/>
-                      <a:round/>
-                      <a:headEnd type="none" w="med" len="med"/>
-                      <a:tailEnd type="none" w="med" len="med"/>
-                    </a:lnR>
-                    <a:lnT w="9525" cap="flat" cmpd="sng" algn="ctr">
-                      <a:solidFill>
-                        <a:srgbClr val="E3E8EC"/>
-                      </a:solidFill>
-                      <a:prstDash val="solid"/>
-                      <a:round/>
-                      <a:headEnd type="none" w="med" len="med"/>
-                      <a:tailEnd type="none" w="med" len="med"/>
-                    </a:lnT>
-                    <a:lnB w="9525" cap="flat" cmpd="sng" algn="ctr">
-                      <a:solidFill>
-                        <a:srgbClr val="E3E8EC"/>
-                      </a:solidFill>
-                      <a:prstDash val="solid"/>
-                      <a:round/>
-                      <a:headEnd type="none" w="med" len="med"/>
-                      <a:tailEnd type="none" w="med" len="med"/>
-                    </a:lnB>
-                    <a:solidFill>
-                      <a:srgbClr val="F3F6F8"/>
-                    </a:solidFill>
-                  </a:tcPr>
-                </a:tc>
-                <a:tc>
-                  <a:txBody>
-                    <a:bodyPr/>
-                    <a:lstStyle/>
-                    <a:p>
-                      <a:pPr indent="0" marL="0">
-                        <a:buNone/>
-                      </a:pPr>
-                      <a:r>
-                        <a:rPr lang="en-US" sz="1000" dirty="0">
-                          <a:solidFill>
-                            <a:srgbClr val="1F2937"/>
-                          </a:solidFill>
-                          <a:latin typeface="Calibri" pitchFamily="34" charset="0"/>
-                          <a:ea typeface="Calibri" pitchFamily="34" charset="-122"/>
-                          <a:cs typeface="Calibri" pitchFamily="34" charset="-120"/>
-                        </a:rPr>
-                        <a:t>Not built for real-time runtime supervision</a:t>
-                      </a:r>
-                      <a:endParaRPr lang="en-US" sz="1000" dirty="0">
-                        <a:latin typeface="Calibri" charset="0"/>
-                        <a:ea typeface="Calibri" charset="0"/>
-                        <a:cs typeface="Calibri" charset="0"/>
-                      </a:endParaRPr>
-                    </a:p>
-                  </a:txBody>
-                  <a:tcPr marL="91440" marR="91440" marT="45720" marB="45720" anchor="ctr">
-                    <a:lnL w="9525" cap="flat" cmpd="sng" algn="ctr">
-                      <a:solidFill>
-                        <a:srgbClr val="E3E8EC"/>
-                      </a:solidFill>
-                      <a:prstDash val="solid"/>
-                      <a:round/>
-                      <a:headEnd type="none" w="med" len="med"/>
-                      <a:tailEnd type="none" w="med" len="med"/>
-                    </a:lnL>
-                    <a:lnR w="9525" cap="flat" cmpd="sng" algn="ctr">
-                      <a:solidFill>
-                        <a:srgbClr val="E3E8EC"/>
-                      </a:solidFill>
-                      <a:prstDash val="solid"/>
-                      <a:round/>
-                      <a:headEnd type="none" w="med" len="med"/>
-                      <a:tailEnd type="none" w="med" len="med"/>
-                    </a:lnR>
-                    <a:lnT w="9525" cap="flat" cmpd="sng" algn="ctr">
-                      <a:solidFill>
-                        <a:srgbClr val="E3E8EC"/>
-                      </a:solidFill>
-                      <a:prstDash val="solid"/>
-                      <a:round/>
-                      <a:headEnd type="none" w="med" len="med"/>
-                      <a:tailEnd type="none" w="med" len="med"/>
-                    </a:lnT>
-                    <a:lnB w="9525" cap="flat" cmpd="sng" algn="ctr">
-                      <a:solidFill>
-                        <a:srgbClr val="E3E8EC"/>
-                      </a:solidFill>
-                      <a:prstDash val="solid"/>
-                      <a:round/>
-                      <a:headEnd type="none" w="med" len="med"/>
-                      <a:tailEnd type="none" w="med" len="med"/>
-                    </a:lnB>
-                    <a:solidFill>
-                      <a:srgbClr val="F3F6F8"/>
-                    </a:solidFill>
-                  </a:tcPr>
-                </a:tc>
-                <a:tc>
-                  <a:txBody>
-                    <a:bodyPr/>
-                    <a:lstStyle/>
-                    <a:p>
-                      <a:pPr indent="0" marL="0">
-                        <a:buNone/>
-                      </a:pPr>
-                      <a:r>
-                        <a:rPr lang="en-US" sz="1000" dirty="0">
-                          <a:solidFill>
-                            <a:srgbClr val="1F2937"/>
+                            <a:srgbClr val="6B7280"/>
                           </a:solidFill>
                           <a:latin typeface="Calibri" pitchFamily="34" charset="0"/>
                           <a:ea typeface="Calibri" pitchFamily="34" charset="-122"/>
@@ -14313,9 +13479,9 @@
                         <a:buNone/>
                       </a:pPr>
                       <a:r>
-                        <a:rPr lang="en-US" sz="1000" dirty="0">
+                        <a:rPr lang="en-US" sz="1050" dirty="0">
                           <a:solidFill>
-                            <a:srgbClr val="1F2937"/>
+                            <a:srgbClr val="FFFFFF"/>
                           </a:solidFill>
                           <a:latin typeface="Calibri" pitchFamily="34" charset="0"/>
                           <a:ea typeface="Calibri" pitchFamily="34" charset="-122"/>
@@ -14323,7 +13489,7 @@
                         </a:rPr>
                         <a:t>Purpose-built for kill-switch/streaming/audit</a:t>
                       </a:r>
-                      <a:endParaRPr lang="en-US" sz="1000" dirty="0">
+                      <a:endParaRPr lang="en-US" sz="1050" dirty="0">
                         <a:latin typeface="Calibri" charset="0"/>
                         <a:ea typeface="Calibri" charset="0"/>
                         <a:cs typeface="Calibri" charset="0"/>
@@ -14368,7 +13534,7 @@
                       <a:tailEnd type="none" w="med" len="med"/>
                     </a:lnB>
                     <a:solidFill>
-                      <a:srgbClr val="F3F6F8"/>
+                      <a:srgbClr val="0A2A43"/>
                     </a:solidFill>
                   </a:tcPr>
                 </a:tc>
@@ -14379,7 +13545,7 @@
       </p:graphicFrame>
       <p:sp>
         <p:nvSpPr>
-          <p:cNvPr id="5" name="Text 2"/>
+          <p:cNvPr id="7" name="Text 4"/>
           <p:cNvSpPr/>
           <p:nvPr/>
         </p:nvSpPr>
@@ -14418,7 +13584,7 @@
       </p:sp>
       <p:sp>
         <p:nvSpPr>
-          <p:cNvPr id="6" name="Text 3"/>
+          <p:cNvPr id="8" name="Text 5"/>
           <p:cNvSpPr/>
           <p:nvPr/>
         </p:nvSpPr>

</xml_diff>

<commit_message>
Add missing Operational ownership row to trade-offs table
Reviewer's trade-off dimensions list included operational ownership;
the docx table had it but the ppt table was short one row. Added it
in the same position (between Flexibility and Regulatory control),
matching both the docx and the reviewer's original ordering.

Co-Authored-By: Claude Sonnet 5 <noreply@anthropic.com>
</commit_message>
<xml_diff>
--- a/docs/EGPA-Overview.pptx
+++ b/docs/EGPA-Overview.pptx
@@ -11608,7 +11608,7 @@
           </p:nvPr>
         </p:nvGraphicFramePr>
         <p:xfrm>
-          <a:off x="457200" y="1298448"/>
+          <a:off x="457200" y="1280160"/>
           <a:ext cx="11274552" cy="914400"/>
         </p:xfrm>
         <a:graphic>
@@ -11621,7 +11621,7 @@
                 <a:gridCol w="2514600"/>
                 <a:gridCol w="4416552"/>
               </a:tblGrid>
-              <a:tr h="457200">
+              <a:tr h="420624">
                 <a:tc>
                   <a:txBody>
                     <a:bodyPr/>
@@ -11895,7 +11895,7 @@
                   </a:tcPr>
                 </a:tc>
               </a:tr>
-              <a:tr h="685800">
+              <a:tr h="640080">
                 <a:tc>
                   <a:txBody>
                     <a:bodyPr/>
@@ -12169,7 +12169,7 @@
                   </a:tcPr>
                 </a:tc>
               </a:tr>
-              <a:tr h="685800">
+              <a:tr h="640080">
                 <a:tc>
                   <a:txBody>
                     <a:bodyPr/>
@@ -12443,7 +12443,7 @@
                   </a:tcPr>
                 </a:tc>
               </a:tr>
-              <a:tr h="685800">
+              <a:tr h="640080">
                 <a:tc>
                   <a:txBody>
                     <a:bodyPr/>
@@ -12717,7 +12717,7 @@
                   </a:tcPr>
                 </a:tc>
               </a:tr>
-              <a:tr h="685800">
+              <a:tr h="640080">
                 <a:tc>
                   <a:txBody>
                     <a:bodyPr/>
@@ -12991,7 +12991,281 @@
                   </a:tcPr>
                 </a:tc>
               </a:tr>
-              <a:tr h="685800">
+              <a:tr h="640080">
+                <a:tc>
+                  <a:txBody>
+                    <a:bodyPr/>
+                    <a:lstStyle/>
+                    <a:p>
+                      <a:pPr indent="0" marL="0">
+                        <a:buNone/>
+                      </a:pPr>
+                      <a:r>
+                        <a:rPr lang="en-US" sz="1050" b="1" dirty="0">
+                          <a:solidFill>
+                            <a:srgbClr val="0A2A43"/>
+                          </a:solidFill>
+                          <a:latin typeface="Calibri" pitchFamily="34" charset="0"/>
+                          <a:ea typeface="Calibri" pitchFamily="34" charset="-122"/>
+                          <a:cs typeface="Calibri" pitchFamily="34" charset="-120"/>
+                        </a:rPr>
+                        <a:t>Operational ownership</a:t>
+                      </a:r>
+                      <a:endParaRPr lang="en-US" sz="1050" dirty="0">
+                        <a:latin typeface="Calibri" charset="0"/>
+                        <a:ea typeface="Calibri" charset="0"/>
+                        <a:cs typeface="Calibri" charset="0"/>
+                      </a:endParaRPr>
+                    </a:p>
+                  </a:txBody>
+                  <a:tcPr marL="91440" marR="91440" marT="45720" marB="45720" anchor="ctr">
+                    <a:lnL w="9525" cap="flat" cmpd="sng" algn="ctr">
+                      <a:solidFill>
+                        <a:srgbClr val="E3E8EC"/>
+                      </a:solidFill>
+                      <a:prstDash val="solid"/>
+                      <a:round/>
+                      <a:headEnd type="none" w="med" len="med"/>
+                      <a:tailEnd type="none" w="med" len="med"/>
+                    </a:lnL>
+                    <a:lnR w="9525" cap="flat" cmpd="sng" algn="ctr">
+                      <a:solidFill>
+                        <a:srgbClr val="E3E8EC"/>
+                      </a:solidFill>
+                      <a:prstDash val="solid"/>
+                      <a:round/>
+                      <a:headEnd type="none" w="med" len="med"/>
+                      <a:tailEnd type="none" w="med" len="med"/>
+                    </a:lnR>
+                    <a:lnT w="9525" cap="flat" cmpd="sng" algn="ctr">
+                      <a:solidFill>
+                        <a:srgbClr val="E3E8EC"/>
+                      </a:solidFill>
+                      <a:prstDash val="solid"/>
+                      <a:round/>
+                      <a:headEnd type="none" w="med" len="med"/>
+                      <a:tailEnd type="none" w="med" len="med"/>
+                    </a:lnT>
+                    <a:lnB w="9525" cap="flat" cmpd="sng" algn="ctr">
+                      <a:solidFill>
+                        <a:srgbClr val="E3E8EC"/>
+                      </a:solidFill>
+                      <a:prstDash val="solid"/>
+                      <a:round/>
+                      <a:headEnd type="none" w="med" len="med"/>
+                      <a:tailEnd type="none" w="med" len="med"/>
+                    </a:lnB>
+                    <a:solidFill>
+                      <a:srgbClr val="FFFFFF"/>
+                    </a:solidFill>
+                  </a:tcPr>
+                </a:tc>
+                <a:tc>
+                  <a:txBody>
+                    <a:bodyPr/>
+                    <a:lstStyle/>
+                    <a:p>
+                      <a:pPr indent="0" marL="0">
+                        <a:buNone/>
+                      </a:pPr>
+                      <a:r>
+                        <a:rPr lang="en-US" sz="1000" dirty="0">
+                          <a:solidFill>
+                            <a:srgbClr val="6B7280"/>
+                          </a:solidFill>
+                          <a:latin typeface="Calibri" pitchFamily="34" charset="0"/>
+                          <a:ea typeface="Calibri" pitchFamily="34" charset="-122"/>
+                          <a:cs typeface="Calibri" pitchFamily="34" charset="-120"/>
+                        </a:rPr>
+                        <a:t>Existing GRC/ITSM team — no new team required</a:t>
+                      </a:r>
+                      <a:endParaRPr lang="en-US" sz="1000" dirty="0">
+                        <a:latin typeface="Calibri" charset="0"/>
+                        <a:ea typeface="Calibri" charset="0"/>
+                        <a:cs typeface="Calibri" charset="0"/>
+                      </a:endParaRPr>
+                    </a:p>
+                  </a:txBody>
+                  <a:tcPr marL="91440" marR="91440" marT="45720" marB="45720" anchor="ctr">
+                    <a:lnL w="9525" cap="flat" cmpd="sng" algn="ctr">
+                      <a:solidFill>
+                        <a:srgbClr val="E3E8EC"/>
+                      </a:solidFill>
+                      <a:prstDash val="solid"/>
+                      <a:round/>
+                      <a:headEnd type="none" w="med" len="med"/>
+                      <a:tailEnd type="none" w="med" len="med"/>
+                    </a:lnL>
+                    <a:lnR w="9525" cap="flat" cmpd="sng" algn="ctr">
+                      <a:solidFill>
+                        <a:srgbClr val="E3E8EC"/>
+                      </a:solidFill>
+                      <a:prstDash val="solid"/>
+                      <a:round/>
+                      <a:headEnd type="none" w="med" len="med"/>
+                      <a:tailEnd type="none" w="med" len="med"/>
+                    </a:lnR>
+                    <a:lnT w="9525" cap="flat" cmpd="sng" algn="ctr">
+                      <a:solidFill>
+                        <a:srgbClr val="E3E8EC"/>
+                      </a:solidFill>
+                      <a:prstDash val="solid"/>
+                      <a:round/>
+                      <a:headEnd type="none" w="med" len="med"/>
+                      <a:tailEnd type="none" w="med" len="med"/>
+                    </a:lnT>
+                    <a:lnB w="9525" cap="flat" cmpd="sng" algn="ctr">
+                      <a:solidFill>
+                        <a:srgbClr val="E3E8EC"/>
+                      </a:solidFill>
+                      <a:prstDash val="solid"/>
+                      <a:round/>
+                      <a:headEnd type="none" w="med" len="med"/>
+                      <a:tailEnd type="none" w="med" len="med"/>
+                    </a:lnB>
+                    <a:solidFill>
+                      <a:srgbClr val="FFFFFF"/>
+                    </a:solidFill>
+                  </a:tcPr>
+                </a:tc>
+                <a:tc>
+                  <a:txBody>
+                    <a:bodyPr/>
+                    <a:lstStyle/>
+                    <a:p>
+                      <a:pPr indent="0" marL="0">
+                        <a:buNone/>
+                      </a:pPr>
+                      <a:r>
+                        <a:rPr lang="en-US" sz="1000" dirty="0">
+                          <a:solidFill>
+                            <a:srgbClr val="6B7280"/>
+                          </a:solidFill>
+                          <a:latin typeface="Calibri" pitchFamily="34" charset="0"/>
+                          <a:ea typeface="Calibri" pitchFamily="34" charset="-122"/>
+                          <a:cs typeface="Calibri" pitchFamily="34" charset="-120"/>
+                        </a:rPr>
+                        <a:t>Vendor owns the product; we own configuration + risk mapping</a:t>
+                      </a:r>
+                      <a:endParaRPr lang="en-US" sz="1000" dirty="0">
+                        <a:latin typeface="Calibri" charset="0"/>
+                        <a:ea typeface="Calibri" charset="0"/>
+                        <a:cs typeface="Calibri" charset="0"/>
+                      </a:endParaRPr>
+                    </a:p>
+                  </a:txBody>
+                  <a:tcPr marL="91440" marR="91440" marT="45720" marB="45720" anchor="ctr">
+                    <a:lnL w="9525" cap="flat" cmpd="sng" algn="ctr">
+                      <a:solidFill>
+                        <a:srgbClr val="E3E8EC"/>
+                      </a:solidFill>
+                      <a:prstDash val="solid"/>
+                      <a:round/>
+                      <a:headEnd type="none" w="med" len="med"/>
+                      <a:tailEnd type="none" w="med" len="med"/>
+                    </a:lnL>
+                    <a:lnR w="9525" cap="flat" cmpd="sng" algn="ctr">
+                      <a:solidFill>
+                        <a:srgbClr val="E3E8EC"/>
+                      </a:solidFill>
+                      <a:prstDash val="solid"/>
+                      <a:round/>
+                      <a:headEnd type="none" w="med" len="med"/>
+                      <a:tailEnd type="none" w="med" len="med"/>
+                    </a:lnR>
+                    <a:lnT w="9525" cap="flat" cmpd="sng" algn="ctr">
+                      <a:solidFill>
+                        <a:srgbClr val="E3E8EC"/>
+                      </a:solidFill>
+                      <a:prstDash val="solid"/>
+                      <a:round/>
+                      <a:headEnd type="none" w="med" len="med"/>
+                      <a:tailEnd type="none" w="med" len="med"/>
+                    </a:lnT>
+                    <a:lnB w="9525" cap="flat" cmpd="sng" algn="ctr">
+                      <a:solidFill>
+                        <a:srgbClr val="E3E8EC"/>
+                      </a:solidFill>
+                      <a:prstDash val="solid"/>
+                      <a:round/>
+                      <a:headEnd type="none" w="med" len="med"/>
+                      <a:tailEnd type="none" w="med" len="med"/>
+                    </a:lnB>
+                    <a:solidFill>
+                      <a:srgbClr val="FFFFFF"/>
+                    </a:solidFill>
+                  </a:tcPr>
+                </a:tc>
+                <a:tc>
+                  <a:txBody>
+                    <a:bodyPr/>
+                    <a:lstStyle/>
+                    <a:p>
+                      <a:pPr indent="0" marL="0">
+                        <a:buNone/>
+                      </a:pPr>
+                      <a:r>
+                        <a:rPr lang="en-US" sz="1050" dirty="0">
+                          <a:solidFill>
+                            <a:srgbClr val="FFFFFF"/>
+                          </a:solidFill>
+                          <a:latin typeface="Calibri" pitchFamily="34" charset="0"/>
+                          <a:ea typeface="Calibri" pitchFamily="34" charset="-122"/>
+                          <a:cs typeface="Calibri" pitchFamily="34" charset="-120"/>
+                        </a:rPr>
+                        <a:t>New internal platform team — built and run by us, long-term</a:t>
+                      </a:r>
+                      <a:endParaRPr lang="en-US" sz="1050" dirty="0">
+                        <a:latin typeface="Calibri" charset="0"/>
+                        <a:ea typeface="Calibri" charset="0"/>
+                        <a:cs typeface="Calibri" charset="0"/>
+                      </a:endParaRPr>
+                    </a:p>
+                  </a:txBody>
+                  <a:tcPr marL="91440" marR="91440" marT="45720" marB="45720" anchor="ctr">
+                    <a:lnL w="9525" cap="flat" cmpd="sng" algn="ctr">
+                      <a:solidFill>
+                        <a:srgbClr val="E3E8EC"/>
+                      </a:solidFill>
+                      <a:prstDash val="solid"/>
+                      <a:round/>
+                      <a:headEnd type="none" w="med" len="med"/>
+                      <a:tailEnd type="none" w="med" len="med"/>
+                    </a:lnL>
+                    <a:lnR w="9525" cap="flat" cmpd="sng" algn="ctr">
+                      <a:solidFill>
+                        <a:srgbClr val="E3E8EC"/>
+                      </a:solidFill>
+                      <a:prstDash val="solid"/>
+                      <a:round/>
+                      <a:headEnd type="none" w="med" len="med"/>
+                      <a:tailEnd type="none" w="med" len="med"/>
+                    </a:lnR>
+                    <a:lnT w="9525" cap="flat" cmpd="sng" algn="ctr">
+                      <a:solidFill>
+                        <a:srgbClr val="E3E8EC"/>
+                      </a:solidFill>
+                      <a:prstDash val="solid"/>
+                      <a:round/>
+                      <a:headEnd type="none" w="med" len="med"/>
+                      <a:tailEnd type="none" w="med" len="med"/>
+                    </a:lnT>
+                    <a:lnB w="9525" cap="flat" cmpd="sng" algn="ctr">
+                      <a:solidFill>
+                        <a:srgbClr val="E3E8EC"/>
+                      </a:solidFill>
+                      <a:prstDash val="solid"/>
+                      <a:round/>
+                      <a:headEnd type="none" w="med" len="med"/>
+                      <a:tailEnd type="none" w="med" len="med"/>
+                    </a:lnB>
+                    <a:solidFill>
+                      <a:srgbClr val="0A2A43"/>
+                    </a:solidFill>
+                  </a:tcPr>
+                </a:tc>
+              </a:tr>
+              <a:tr h="640080">
                 <a:tc>
                   <a:txBody>
                     <a:bodyPr/>
@@ -13056,7 +13330,7 @@
                       <a:tailEnd type="none" w="med" len="med"/>
                     </a:lnB>
                     <a:solidFill>
-                      <a:srgbClr val="FFFFFF"/>
+                      <a:srgbClr val="F3F6F8"/>
                     </a:solidFill>
                   </a:tcPr>
                 </a:tc>
@@ -13124,7 +13398,7 @@
                       <a:tailEnd type="none" w="med" len="med"/>
                     </a:lnB>
                     <a:solidFill>
-                      <a:srgbClr val="FFFFFF"/>
+                      <a:srgbClr val="F3F6F8"/>
                     </a:solidFill>
                   </a:tcPr>
                 </a:tc>
@@ -13192,7 +13466,7 @@
                       <a:tailEnd type="none" w="med" len="med"/>
                     </a:lnB>
                     <a:solidFill>
-                      <a:srgbClr val="FFFFFF"/>
+                      <a:srgbClr val="F3F6F8"/>
                     </a:solidFill>
                   </a:tcPr>
                 </a:tc>
@@ -13265,7 +13539,7 @@
                   </a:tcPr>
                 </a:tc>
               </a:tr>
-              <a:tr h="685800">
+              <a:tr h="640080">
                 <a:tc>
                   <a:txBody>
                     <a:bodyPr/>
@@ -13330,7 +13604,7 @@
                       <a:tailEnd type="none" w="med" len="med"/>
                     </a:lnB>
                     <a:solidFill>
-                      <a:srgbClr val="F3F6F8"/>
+                      <a:srgbClr val="FFFFFF"/>
                     </a:solidFill>
                   </a:tcPr>
                 </a:tc>
@@ -13398,7 +13672,7 @@
                       <a:tailEnd type="none" w="med" len="med"/>
                     </a:lnB>
                     <a:solidFill>
-                      <a:srgbClr val="F3F6F8"/>
+                      <a:srgbClr val="FFFFFF"/>
                     </a:solidFill>
                   </a:tcPr>
                 </a:tc>
@@ -13466,7 +13740,7 @@
                       <a:tailEnd type="none" w="med" len="med"/>
                     </a:lnB>
                     <a:solidFill>
-                      <a:srgbClr val="F3F6F8"/>
+                      <a:srgbClr val="FFFFFF"/>
                     </a:solidFill>
                   </a:tcPr>
                 </a:tc>

</xml_diff>